<commit_message>
chore: fix the glm-hmm fitting, update figures
</commit_message>
<xml_diff>
--- a/dissemination/Prior encoding of Superior Colliculus in perceptual decision-making.pptx
+++ b/dissemination/Prior encoding of Superior Colliculus in perceptual decision-making.pptx
@@ -5,16 +5,18 @@
     <p:sldMasterId id="2147483648" r:id="rId1"/>
   </p:sldMasterIdLst>
   <p:notesMasterIdLst>
-    <p:notesMasterId r:id="rId9"/>
+    <p:notesMasterId r:id="rId11"/>
   </p:notesMasterIdLst>
   <p:sldIdLst>
     <p:sldId id="256" r:id="rId2"/>
-    <p:sldId id="260" r:id="rId3"/>
+    <p:sldId id="269" r:id="rId3"/>
     <p:sldId id="259" r:id="rId4"/>
     <p:sldId id="257" r:id="rId5"/>
     <p:sldId id="261" r:id="rId6"/>
     <p:sldId id="262" r:id="rId7"/>
-    <p:sldId id="264" r:id="rId8"/>
+    <p:sldId id="266" r:id="rId8"/>
+    <p:sldId id="270" r:id="rId9"/>
+    <p:sldId id="264" r:id="rId10"/>
   </p:sldIdLst>
   <p:sldSz cx="12192000" cy="6858000"/>
   <p:notesSz cx="6858000" cy="9144000"/>
@@ -113,6 +115,11 @@
       </a:defRPr>
     </a:lvl9pPr>
   </p:defaultTextStyle>
+  <p:extLst>
+    <p:ext uri="{EFAFB233-063F-42B5-8137-9DF3F51BA10A}">
+      <p15:sldGuideLst xmlns:p15="http://schemas.microsoft.com/office/powerpoint/2012/main"/>
+    </p:ext>
+  </p:extLst>
 </p:presentation>
 </file>
 
@@ -198,7 +205,7 @@
           <a:p>
             <a:fld id="{BA3E252F-87BF-4487-AB21-8F0FF193234C}" type="datetimeFigureOut">
               <a:rPr lang="en-US" smtClean="0"/>
-              <a:t>7/16/2025</a:t>
+              <a:t>7/24/2025</a:t>
             </a:fld>
             <a:endParaRPr lang="en-US"/>
           </a:p>
@@ -510,55 +517,31 @@
           <a:lstStyle/>
           <a:p>
             <a:r>
-              <a:rPr lang="en-US" sz="1200" dirty="0"/>
-              <a:t>Psychometric functions of equal and unequal block in left prior(left panel, n=24) and right prior(right panel, n=21) sessions.</a:t>
-            </a:r>
-          </a:p>
-          <a:p>
-            <a:r>
-              <a:rPr lang="en-US" sz="1200" dirty="0"/>
-              <a:t>Dots are datapoints and lines are logistic fits. Transparent traces are session wise data, thicker traces are mean across sessions.</a:t>
+              <a:rPr lang="en-US" sz="1200" dirty="0">
+                <a:latin typeface="Arial" panose="020B0604020202020204" pitchFamily="34" charset="0"/>
+                <a:cs typeface="Arial" panose="020B0604020202020204" pitchFamily="34" charset="0"/>
+              </a:rPr>
+              <a:t>Top: Trial structure of the Glass Pattern task shown in a temporal sequence. The subject can choose as soon as the glass pattern stimuli appears.</a:t>
+            </a:r>
+          </a:p>
+          <a:p>
+            <a:endParaRPr lang="en-US" sz="1200" dirty="0">
+              <a:latin typeface="Arial" panose="020B0604020202020204" pitchFamily="34" charset="0"/>
+              <a:cs typeface="Arial" panose="020B0604020202020204" pitchFamily="34" charset="0"/>
+            </a:endParaRPr>
+          </a:p>
+          <a:p>
+            <a:r>
+              <a:rPr lang="en-US" sz="1200" dirty="0">
+                <a:latin typeface="Arial" panose="020B0604020202020204" pitchFamily="34" charset="0"/>
+                <a:cs typeface="Arial" panose="020B0604020202020204" pitchFamily="34" charset="0"/>
+              </a:rPr>
+              <a:t>Bottom: Every session is divided in two blocks. First is the equal block with 50/50 probability of left and right choices, The second block has unequal probability, with one target shown 70% probability and the other 30%. Each block consists of 400-900 trials.</a:t>
             </a:r>
           </a:p>
           <a:p>
             <a:endParaRPr lang="en-US" dirty="0"/>
           </a:p>
-          <a:p>
-            <a:r>
-              <a:rPr lang="en-US" sz="1200" dirty="0"/>
-              <a:t>Top: Scatterplot of logistic fits alpha(threshold) parameters of each session in equal block vs unequal block.</a:t>
-            </a:r>
-          </a:p>
-          <a:p>
-            <a:r>
-              <a:rPr lang="en-US" sz="1200" dirty="0"/>
-              <a:t>Bottom: Same as top for logistic fit beta parameter.</a:t>
-            </a:r>
-          </a:p>
-          <a:p>
-            <a:r>
-              <a:rPr lang="en-US" sz="1200" dirty="0"/>
-              <a:t>Blue: left prior sessions, Brown: right prior sessions</a:t>
-            </a:r>
-          </a:p>
-          <a:p>
-            <a:r>
-              <a:rPr lang="en-US" sz="1200" b="0" i="0" kern="1200" dirty="0">
-                <a:solidFill>
-                  <a:schemeClr val="tx1"/>
-                </a:solidFill>
-                <a:effectLst/>
-                <a:latin typeface="+mn-lt"/>
-                <a:ea typeface="+mn-ea"/>
-                <a:cs typeface="+mn-cs"/>
-              </a:rPr>
-              <a:t>241002_GP_TZ equal beta is 0.172</a:t>
-            </a:r>
-            <a:endParaRPr lang="en-US" sz="1200" dirty="0"/>
-          </a:p>
-          <a:p>
-            <a:endParaRPr lang="en-US" dirty="0"/>
-          </a:p>
         </p:txBody>
       </p:sp>
       <p:sp>
@@ -576,9 +559,9 @@
           <a:bodyPr/>
           <a:lstStyle/>
           <a:p>
-            <a:fld id="{F4472248-5027-4A3C-9488-9C593E53F37B}" type="slidenum">
+            <a:fld id="{B767B371-ADA0-464E-A5F2-5276C7C18EA9}" type="slidenum">
               <a:rPr lang="en-US" smtClean="0"/>
-              <a:t>3</a:t>
+              <a:t>2</a:t>
             </a:fld>
             <a:endParaRPr lang="en-US"/>
           </a:p>
@@ -587,7 +570,7 @@
     </p:spTree>
     <p:extLst>
       <p:ext uri="{BB962C8B-B14F-4D97-AF65-F5344CB8AC3E}">
-        <p14:creationId xmlns:p14="http://schemas.microsoft.com/office/powerpoint/2010/main" val="2597802434"/>
+        <p14:creationId xmlns:p14="http://schemas.microsoft.com/office/powerpoint/2010/main" val="2466263949"/>
       </p:ext>
     </p:extLst>
   </p:cSld>
@@ -641,27 +624,52 @@
           <a:bodyPr/>
           <a:lstStyle/>
           <a:p>
-            <a:pPr marL="0" marR="0" lvl="0" indent="0" algn="l" defTabSz="914400" rtl="0" eaLnBrk="1" fontAlgn="auto" latinLnBrk="0" hangingPunct="1">
-              <a:lnSpc>
-                <a:spcPct val="100000"/>
-              </a:lnSpc>
-              <a:spcBef>
-                <a:spcPts val="0"/>
-              </a:spcBef>
-              <a:spcAft>
-                <a:spcPts val="0"/>
-              </a:spcAft>
-              <a:buClrTx/>
-              <a:buSzTx/>
-              <a:buFontTx/>
-              <a:buNone/>
-              <a:tabLst/>
-              <a:defRPr/>
-            </a:pPr>
             <a:r>
               <a:rPr lang="en-US" sz="1200" dirty="0"/>
-              <a:t>Chronometric functions of equal and unequal prior blocks for left-prior sessions (top panel, n=24 sessions) and right-prior sessions (bottom panel, n=21 sessions).In each panel, the left subplot shows mean reaction time for correct trials, and the right subplot shows mean reaction time for incorrect trials.</a:t>
-            </a:r>
+              <a:t>Psychometric functions of equal and unequal block in left prior(left panel, n=24) and right prior(right panel, n=21) sessions.</a:t>
+            </a:r>
+          </a:p>
+          <a:p>
+            <a:r>
+              <a:rPr lang="en-US" sz="1200" dirty="0"/>
+              <a:t>Dots are datapoints and lines are logistic fits. Transparent traces are session wise data, thicker traces are mean across sessions.</a:t>
+            </a:r>
+          </a:p>
+          <a:p>
+            <a:endParaRPr lang="en-US" dirty="0"/>
+          </a:p>
+          <a:p>
+            <a:r>
+              <a:rPr lang="en-US" sz="1200" dirty="0"/>
+              <a:t>Top: Scatterplot of logistic fits alpha(threshold) parameters of each session in equal block vs unequal block.</a:t>
+            </a:r>
+          </a:p>
+          <a:p>
+            <a:r>
+              <a:rPr lang="en-US" sz="1200" dirty="0"/>
+              <a:t>Bottom: Same as top for logistic fit beta parameter.</a:t>
+            </a:r>
+          </a:p>
+          <a:p>
+            <a:r>
+              <a:rPr lang="en-US" sz="1200" dirty="0"/>
+              <a:t>Blue: left prior sessions, Brown: right prior sessions</a:t>
+            </a:r>
+          </a:p>
+          <a:p>
+            <a:r>
+              <a:rPr lang="en-US" sz="1200" b="0" i="0" kern="1200" dirty="0">
+                <a:solidFill>
+                  <a:schemeClr val="tx1"/>
+                </a:solidFill>
+                <a:effectLst/>
+                <a:latin typeface="+mn-lt"/>
+                <a:ea typeface="+mn-ea"/>
+                <a:cs typeface="+mn-cs"/>
+              </a:rPr>
+              <a:t>241002_GP_TZ equal beta is 0.172</a:t>
+            </a:r>
+            <a:endParaRPr lang="en-US" sz="1200" dirty="0"/>
           </a:p>
           <a:p>
             <a:endParaRPr lang="en-US" dirty="0"/>
@@ -685,7 +693,7 @@
           <a:p>
             <a:fld id="{F4472248-5027-4A3C-9488-9C593E53F37B}" type="slidenum">
               <a:rPr lang="en-US" smtClean="0"/>
-              <a:t>4</a:t>
+              <a:t>3</a:t>
             </a:fld>
             <a:endParaRPr lang="en-US"/>
           </a:p>
@@ -694,7 +702,7 @@
     </p:spTree>
     <p:extLst>
       <p:ext uri="{BB962C8B-B14F-4D97-AF65-F5344CB8AC3E}">
-        <p14:creationId xmlns:p14="http://schemas.microsoft.com/office/powerpoint/2010/main" val="258914497"/>
+        <p14:creationId xmlns:p14="http://schemas.microsoft.com/office/powerpoint/2010/main" val="2597802434"/>
       </p:ext>
     </p:extLst>
   </p:cSld>
@@ -748,36 +756,30 @@
           <a:bodyPr/>
           <a:lstStyle/>
           <a:p>
-            <a:r>
-              <a:rPr lang="en-US" b="1" dirty="0"/>
-              <a:t>Traditional psychophysics (SDT)</a:t>
-            </a:r>
-            <a:r>
-              <a:rPr lang="en-US" dirty="0"/>
-              <a:t> assumes a static criterion and lacks temporal structure.</a:t>
-            </a:r>
-            <a:br>
-              <a:rPr lang="en-US" dirty="0"/>
-            </a:br>
-            <a:r>
-              <a:rPr lang="en-US" b="1" dirty="0"/>
-              <a:t>Drift-diffusion models (DDM)</a:t>
-            </a:r>
-            <a:r>
-              <a:rPr lang="en-US" dirty="0"/>
-              <a:t> introduce within-trial dynamics but ignore across-trial dependencies.</a:t>
-            </a:r>
-            <a:br>
-              <a:rPr lang="en-US" dirty="0"/>
-            </a:br>
-            <a:r>
-              <a:rPr lang="en-US" b="1" dirty="0"/>
-              <a:t>GLM-HMM</a:t>
-            </a:r>
-            <a:r>
-              <a:rPr lang="en-US" dirty="0"/>
-              <a:t> bridges the gap by modeling hidden cognitive states that evolve over trials and shape decisions.</a:t>
-            </a:r>
+            <a:pPr marL="0" marR="0" lvl="0" indent="0" algn="l" defTabSz="914400" rtl="0" eaLnBrk="1" fontAlgn="auto" latinLnBrk="0" hangingPunct="1">
+              <a:lnSpc>
+                <a:spcPct val="100000"/>
+              </a:lnSpc>
+              <a:spcBef>
+                <a:spcPts val="0"/>
+              </a:spcBef>
+              <a:spcAft>
+                <a:spcPts val="0"/>
+              </a:spcAft>
+              <a:buClrTx/>
+              <a:buSzTx/>
+              <a:buFontTx/>
+              <a:buNone/>
+              <a:tabLst/>
+              <a:defRPr/>
+            </a:pPr>
+            <a:r>
+              <a:rPr lang="en-US" sz="1200" dirty="0"/>
+              <a:t>Chronometric functions of equal and unequal prior blocks for left-prior sessions (top panel, n=24 sessions) and right-prior sessions (bottom panel, n=21 sessions).In each panel, the left subplot shows mean reaction time for correct trials, and the right subplot shows mean reaction time for incorrect trials.</a:t>
+            </a:r>
+          </a:p>
+          <a:p>
+            <a:endParaRPr lang="en-US" dirty="0"/>
           </a:p>
         </p:txBody>
       </p:sp>
@@ -798,7 +800,7 @@
           <a:p>
             <a:fld id="{F4472248-5027-4A3C-9488-9C593E53F37B}" type="slidenum">
               <a:rPr lang="en-US" smtClean="0"/>
-              <a:t>5</a:t>
+              <a:t>4</a:t>
             </a:fld>
             <a:endParaRPr lang="en-US"/>
           </a:p>
@@ -807,7 +809,7 @@
     </p:spTree>
     <p:extLst>
       <p:ext uri="{BB962C8B-B14F-4D97-AF65-F5344CB8AC3E}">
-        <p14:creationId xmlns:p14="http://schemas.microsoft.com/office/powerpoint/2010/main" val="2477942779"/>
+        <p14:creationId xmlns:p14="http://schemas.microsoft.com/office/powerpoint/2010/main" val="258914497"/>
       </p:ext>
     </p:extLst>
   </p:cSld>
@@ -861,6 +863,119 @@
           <a:bodyPr/>
           <a:lstStyle/>
           <a:p>
+            <a:r>
+              <a:rPr lang="en-US" b="1" dirty="0"/>
+              <a:t>Traditional psychophysics (SDT)</a:t>
+            </a:r>
+            <a:r>
+              <a:rPr lang="en-US" dirty="0"/>
+              <a:t> assumes a static criterion and lacks temporal structure.</a:t>
+            </a:r>
+            <a:br>
+              <a:rPr lang="en-US" dirty="0"/>
+            </a:br>
+            <a:r>
+              <a:rPr lang="en-US" b="1" dirty="0"/>
+              <a:t>Drift-diffusion models (DDM)</a:t>
+            </a:r>
+            <a:r>
+              <a:rPr lang="en-US" dirty="0"/>
+              <a:t> introduce within-trial dynamics but ignore across-trial dependencies.</a:t>
+            </a:r>
+            <a:br>
+              <a:rPr lang="en-US" dirty="0"/>
+            </a:br>
+            <a:r>
+              <a:rPr lang="en-US" b="1" dirty="0"/>
+              <a:t>GLM-HMM</a:t>
+            </a:r>
+            <a:r>
+              <a:rPr lang="en-US" dirty="0"/>
+              <a:t> bridges the gap by modeling hidden cognitive states that evolve over trials and shape decisions.</a:t>
+            </a:r>
+          </a:p>
+        </p:txBody>
+      </p:sp>
+      <p:sp>
+        <p:nvSpPr>
+          <p:cNvPr id="4" name="Slide Number Placeholder 3"/>
+          <p:cNvSpPr>
+            <a:spLocks noGrp="1"/>
+          </p:cNvSpPr>
+          <p:nvPr>
+            <p:ph type="sldNum" sz="quarter" idx="5"/>
+          </p:nvPr>
+        </p:nvSpPr>
+        <p:spPr/>
+        <p:txBody>
+          <a:bodyPr/>
+          <a:lstStyle/>
+          <a:p>
+            <a:fld id="{F4472248-5027-4A3C-9488-9C593E53F37B}" type="slidenum">
+              <a:rPr lang="en-US" smtClean="0"/>
+              <a:t>5</a:t>
+            </a:fld>
+            <a:endParaRPr lang="en-US"/>
+          </a:p>
+        </p:txBody>
+      </p:sp>
+    </p:spTree>
+    <p:extLst>
+      <p:ext uri="{BB962C8B-B14F-4D97-AF65-F5344CB8AC3E}">
+        <p14:creationId xmlns:p14="http://schemas.microsoft.com/office/powerpoint/2010/main" val="2477942779"/>
+      </p:ext>
+    </p:extLst>
+  </p:cSld>
+  <p:clrMapOvr>
+    <a:masterClrMapping/>
+  </p:clrMapOvr>
+</p:notes>
+</file>
+
+<file path=ppt/notesSlides/notesSlide5.xml><?xml version="1.0" encoding="utf-8"?>
+<p:notes xmlns:a="http://schemas.openxmlformats.org/drawingml/2006/main" xmlns:r="http://schemas.openxmlformats.org/officeDocument/2006/relationships" xmlns:p="http://schemas.openxmlformats.org/presentationml/2006/main">
+  <p:cSld>
+    <p:spTree>
+      <p:nvGrpSpPr>
+        <p:cNvPr id="1" name=""/>
+        <p:cNvGrpSpPr/>
+        <p:nvPr/>
+      </p:nvGrpSpPr>
+      <p:grpSpPr>
+        <a:xfrm>
+          <a:off x="0" y="0"/>
+          <a:ext cx="0" cy="0"/>
+          <a:chOff x="0" y="0"/>
+          <a:chExt cx="0" cy="0"/>
+        </a:xfrm>
+      </p:grpSpPr>
+      <p:sp>
+        <p:nvSpPr>
+          <p:cNvPr id="2" name="Slide Image Placeholder 1"/>
+          <p:cNvSpPr>
+            <a:spLocks noGrp="1" noRot="1" noChangeAspect="1"/>
+          </p:cNvSpPr>
+          <p:nvPr>
+            <p:ph type="sldImg"/>
+          </p:nvPr>
+        </p:nvSpPr>
+        <p:spPr/>
+      </p:sp>
+      <p:sp>
+        <p:nvSpPr>
+          <p:cNvPr id="3" name="Notes Placeholder 2"/>
+          <p:cNvSpPr>
+            <a:spLocks noGrp="1"/>
+          </p:cNvSpPr>
+          <p:nvPr>
+            <p:ph type="body" idx="1"/>
+          </p:nvPr>
+        </p:nvSpPr>
+        <p:spPr/>
+        <p:txBody>
+          <a:bodyPr/>
+          <a:lstStyle/>
+          <a:p>
             <a:endParaRPr lang="en-US" dirty="0"/>
           </a:p>
         </p:txBody>
@@ -901,7 +1016,7 @@
 </p:notes>
 </file>
 
-<file path=ppt/notesSlides/notesSlide5.xml><?xml version="1.0" encoding="utf-8"?>
+<file path=ppt/notesSlides/notesSlide6.xml><?xml version="1.0" encoding="utf-8"?>
 <p:notes xmlns:a="http://schemas.openxmlformats.org/drawingml/2006/main" xmlns:r="http://schemas.openxmlformats.org/officeDocument/2006/relationships" xmlns:p="http://schemas.openxmlformats.org/presentationml/2006/main">
   <p:cSld>
     <p:spTree>
@@ -990,7 +1105,7 @@
           <a:p>
             <a:fld id="{F4472248-5027-4A3C-9488-9C593E53F37B}" type="slidenum">
               <a:rPr lang="en-US" smtClean="0"/>
-              <a:t>7</a:t>
+              <a:t>9</a:t>
             </a:fld>
             <a:endParaRPr lang="en-US"/>
           </a:p>
@@ -1156,7 +1271,7 @@
           <a:p>
             <a:fld id="{EBF6AAF7-2BB1-4A84-8C15-D326179851E7}" type="datetimeFigureOut">
               <a:rPr lang="en-US" smtClean="0"/>
-              <a:t>7/16/2025</a:t>
+              <a:t>7/24/2025</a:t>
             </a:fld>
             <a:endParaRPr lang="en-US"/>
           </a:p>
@@ -1354,7 +1469,7 @@
           <a:p>
             <a:fld id="{EBF6AAF7-2BB1-4A84-8C15-D326179851E7}" type="datetimeFigureOut">
               <a:rPr lang="en-US" smtClean="0"/>
-              <a:t>7/16/2025</a:t>
+              <a:t>7/24/2025</a:t>
             </a:fld>
             <a:endParaRPr lang="en-US"/>
           </a:p>
@@ -1562,7 +1677,7 @@
           <a:p>
             <a:fld id="{EBF6AAF7-2BB1-4A84-8C15-D326179851E7}" type="datetimeFigureOut">
               <a:rPr lang="en-US" smtClean="0"/>
-              <a:t>7/16/2025</a:t>
+              <a:t>7/24/2025</a:t>
             </a:fld>
             <a:endParaRPr lang="en-US"/>
           </a:p>
@@ -1760,7 +1875,7 @@
           <a:p>
             <a:fld id="{EBF6AAF7-2BB1-4A84-8C15-D326179851E7}" type="datetimeFigureOut">
               <a:rPr lang="en-US" smtClean="0"/>
-              <a:t>7/16/2025</a:t>
+              <a:t>7/24/2025</a:t>
             </a:fld>
             <a:endParaRPr lang="en-US"/>
           </a:p>
@@ -2035,7 +2150,7 @@
           <a:p>
             <a:fld id="{EBF6AAF7-2BB1-4A84-8C15-D326179851E7}" type="datetimeFigureOut">
               <a:rPr lang="en-US" smtClean="0"/>
-              <a:t>7/16/2025</a:t>
+              <a:t>7/24/2025</a:t>
             </a:fld>
             <a:endParaRPr lang="en-US"/>
           </a:p>
@@ -2300,7 +2415,7 @@
           <a:p>
             <a:fld id="{EBF6AAF7-2BB1-4A84-8C15-D326179851E7}" type="datetimeFigureOut">
               <a:rPr lang="en-US" smtClean="0"/>
-              <a:t>7/16/2025</a:t>
+              <a:t>7/24/2025</a:t>
             </a:fld>
             <a:endParaRPr lang="en-US"/>
           </a:p>
@@ -2712,7 +2827,7 @@
           <a:p>
             <a:fld id="{EBF6AAF7-2BB1-4A84-8C15-D326179851E7}" type="datetimeFigureOut">
               <a:rPr lang="en-US" smtClean="0"/>
-              <a:t>7/16/2025</a:t>
+              <a:t>7/24/2025</a:t>
             </a:fld>
             <a:endParaRPr lang="en-US"/>
           </a:p>
@@ -2853,7 +2968,7 @@
           <a:p>
             <a:fld id="{EBF6AAF7-2BB1-4A84-8C15-D326179851E7}" type="datetimeFigureOut">
               <a:rPr lang="en-US" smtClean="0"/>
-              <a:t>7/16/2025</a:t>
+              <a:t>7/24/2025</a:t>
             </a:fld>
             <a:endParaRPr lang="en-US"/>
           </a:p>
@@ -2966,7 +3081,7 @@
           <a:p>
             <a:fld id="{EBF6AAF7-2BB1-4A84-8C15-D326179851E7}" type="datetimeFigureOut">
               <a:rPr lang="en-US" smtClean="0"/>
-              <a:t>7/16/2025</a:t>
+              <a:t>7/24/2025</a:t>
             </a:fld>
             <a:endParaRPr lang="en-US"/>
           </a:p>
@@ -3277,7 +3392,7 @@
           <a:p>
             <a:fld id="{EBF6AAF7-2BB1-4A84-8C15-D326179851E7}" type="datetimeFigureOut">
               <a:rPr lang="en-US" smtClean="0"/>
-              <a:t>7/16/2025</a:t>
+              <a:t>7/24/2025</a:t>
             </a:fld>
             <a:endParaRPr lang="en-US"/>
           </a:p>
@@ -3565,7 +3680,7 @@
           <a:p>
             <a:fld id="{EBF6AAF7-2BB1-4A84-8C15-D326179851E7}" type="datetimeFigureOut">
               <a:rPr lang="en-US" smtClean="0"/>
-              <a:t>7/16/2025</a:t>
+              <a:t>7/24/2025</a:t>
             </a:fld>
             <a:endParaRPr lang="en-US"/>
           </a:p>
@@ -3806,7 +3921,7 @@
           <a:p>
             <a:fld id="{EBF6AAF7-2BB1-4A84-8C15-D326179851E7}" type="datetimeFigureOut">
               <a:rPr lang="en-US" smtClean="0"/>
-              <a:t>7/16/2025</a:t>
+              <a:t>7/24/2025</a:t>
             </a:fld>
             <a:endParaRPr lang="en-US"/>
           </a:p>
@@ -4288,12 +4403,405 @@
           <a:chExt cx="0" cy="0"/>
         </a:xfrm>
       </p:grpSpPr>
+      <p:pic>
+        <p:nvPicPr>
+          <p:cNvPr id="4" name="Content Placeholder 3">
+            <a:extLst>
+              <a:ext uri="{FF2B5EF4-FFF2-40B4-BE49-F238E27FC236}">
+                <a16:creationId xmlns:a16="http://schemas.microsoft.com/office/drawing/2014/main" id="{CA880B41-F9A2-642C-9555-289FE121F268}"/>
+              </a:ext>
+            </a:extLst>
+          </p:cNvPr>
+          <p:cNvPicPr>
+            <a:picLocks noChangeAspect="1"/>
+          </p:cNvPicPr>
+          <p:nvPr/>
+        </p:nvPicPr>
+        <p:blipFill>
+          <a:blip r:embed="rId3"/>
+          <a:srcRect l="10098" b="47872"/>
+          <a:stretch/>
+        </p:blipFill>
+        <p:spPr>
+          <a:xfrm>
+            <a:off x="1895038" y="1413300"/>
+            <a:ext cx="5664518" cy="2701500"/>
+          </a:xfrm>
+          <a:prstGeom prst="rect">
+            <a:avLst/>
+          </a:prstGeom>
+        </p:spPr>
+      </p:pic>
+      <p:grpSp>
+        <p:nvGrpSpPr>
+          <p:cNvPr id="9" name="Group 8">
+            <a:extLst>
+              <a:ext uri="{FF2B5EF4-FFF2-40B4-BE49-F238E27FC236}">
+                <a16:creationId xmlns:a16="http://schemas.microsoft.com/office/drawing/2014/main" id="{8C616500-39DA-E70C-1280-116756D1988D}"/>
+              </a:ext>
+            </a:extLst>
+          </p:cNvPr>
+          <p:cNvGrpSpPr/>
+          <p:nvPr/>
+        </p:nvGrpSpPr>
+        <p:grpSpPr>
+          <a:xfrm>
+            <a:off x="2537360" y="4410635"/>
+            <a:ext cx="3370730" cy="612400"/>
+            <a:chOff x="1303020" y="4491318"/>
+            <a:chExt cx="4422290" cy="792519"/>
+          </a:xfrm>
+        </p:grpSpPr>
+        <p:sp>
+          <p:nvSpPr>
+            <p:cNvPr id="5" name="Rectangle 4">
+              <a:extLst>
+                <a:ext uri="{FF2B5EF4-FFF2-40B4-BE49-F238E27FC236}">
+                  <a16:creationId xmlns:a16="http://schemas.microsoft.com/office/drawing/2014/main" id="{8151D99C-FF91-3DE5-5D42-1B3C83E7BD6C}"/>
+                </a:ext>
+              </a:extLst>
+            </p:cNvPr>
+            <p:cNvSpPr/>
+            <p:nvPr/>
+          </p:nvSpPr>
+          <p:spPr>
+            <a:xfrm>
+              <a:off x="1303020" y="4491318"/>
+              <a:ext cx="2211145" cy="788894"/>
+            </a:xfrm>
+            <a:prstGeom prst="rect">
+              <a:avLst/>
+            </a:prstGeom>
+            <a:solidFill>
+              <a:schemeClr val="bg1">
+                <a:lumMod val="75000"/>
+              </a:schemeClr>
+            </a:solidFill>
+            <a:ln w="28575">
+              <a:solidFill>
+                <a:schemeClr val="tx1"/>
+              </a:solidFill>
+            </a:ln>
+          </p:spPr>
+          <p:style>
+            <a:lnRef idx="2">
+              <a:schemeClr val="accent1">
+                <a:shade val="15000"/>
+              </a:schemeClr>
+            </a:lnRef>
+            <a:fillRef idx="1">
+              <a:schemeClr val="accent1"/>
+            </a:fillRef>
+            <a:effectRef idx="0">
+              <a:schemeClr val="accent1"/>
+            </a:effectRef>
+            <a:fontRef idx="minor">
+              <a:schemeClr val="lt1"/>
+            </a:fontRef>
+          </p:style>
+          <p:txBody>
+            <a:bodyPr rtlCol="0" anchor="ctr"/>
+            <a:lstStyle/>
+            <a:p>
+              <a:pPr algn="ctr"/>
+              <a:endParaRPr lang="en-US"/>
+            </a:p>
+          </p:txBody>
+        </p:sp>
+        <p:sp>
+          <p:nvSpPr>
+            <p:cNvPr id="6" name="Rectangle 5">
+              <a:extLst>
+                <a:ext uri="{FF2B5EF4-FFF2-40B4-BE49-F238E27FC236}">
+                  <a16:creationId xmlns:a16="http://schemas.microsoft.com/office/drawing/2014/main" id="{F2038B71-2DD1-FDEA-B72E-81FD22ED99A8}"/>
+                </a:ext>
+              </a:extLst>
+            </p:cNvPr>
+            <p:cNvSpPr/>
+            <p:nvPr/>
+          </p:nvSpPr>
+          <p:spPr>
+            <a:xfrm>
+              <a:off x="3514165" y="4491318"/>
+              <a:ext cx="2211145" cy="788894"/>
+            </a:xfrm>
+            <a:prstGeom prst="rect">
+              <a:avLst/>
+            </a:prstGeom>
+            <a:noFill/>
+            <a:ln w="28575">
+              <a:solidFill>
+                <a:schemeClr val="tx1"/>
+              </a:solidFill>
+            </a:ln>
+          </p:spPr>
+          <p:style>
+            <a:lnRef idx="2">
+              <a:schemeClr val="accent1">
+                <a:shade val="15000"/>
+              </a:schemeClr>
+            </a:lnRef>
+            <a:fillRef idx="1">
+              <a:schemeClr val="accent1"/>
+            </a:fillRef>
+            <a:effectRef idx="0">
+              <a:schemeClr val="accent1"/>
+            </a:effectRef>
+            <a:fontRef idx="minor">
+              <a:schemeClr val="lt1"/>
+            </a:fontRef>
+          </p:style>
+          <p:txBody>
+            <a:bodyPr rtlCol="0" anchor="ctr"/>
+            <a:lstStyle/>
+            <a:p>
+              <a:pPr algn="ctr"/>
+              <a:endParaRPr lang="en-US"/>
+            </a:p>
+          </p:txBody>
+        </p:sp>
+        <p:sp>
+          <p:nvSpPr>
+            <p:cNvPr id="7" name="TextBox 6">
+              <a:extLst>
+                <a:ext uri="{FF2B5EF4-FFF2-40B4-BE49-F238E27FC236}">
+                  <a16:creationId xmlns:a16="http://schemas.microsoft.com/office/drawing/2014/main" id="{FA62632E-E3E9-3ED3-CA25-7F0EF9DD1BFD}"/>
+                </a:ext>
+              </a:extLst>
+            </p:cNvPr>
+            <p:cNvSpPr txBox="1"/>
+            <p:nvPr/>
+          </p:nvSpPr>
+          <p:spPr>
+            <a:xfrm>
+              <a:off x="1303020" y="4516192"/>
+              <a:ext cx="2211146" cy="756769"/>
+            </a:xfrm>
+            <a:prstGeom prst="rect">
+              <a:avLst/>
+            </a:prstGeom>
+            <a:noFill/>
+          </p:spPr>
+          <p:txBody>
+            <a:bodyPr wrap="square" rtlCol="0">
+              <a:spAutoFit/>
+            </a:bodyPr>
+            <a:lstStyle/>
+            <a:p>
+              <a:pPr algn="ctr"/>
+              <a:r>
+                <a:rPr lang="en-US" sz="1600" b="1" dirty="0">
+                  <a:latin typeface="Arial" panose="020B0604020202020204" pitchFamily="34" charset="0"/>
+                  <a:ea typeface="Arial Unicode MS" panose="020B0604020202020204" pitchFamily="34" charset="-128"/>
+                  <a:cs typeface="Arial" panose="020B0604020202020204" pitchFamily="34" charset="0"/>
+                </a:rPr>
+                <a:t>Equal block</a:t>
+              </a:r>
+            </a:p>
+            <a:p>
+              <a:pPr algn="ctr"/>
+              <a:r>
+                <a:rPr lang="en-US" sz="1600" b="1" dirty="0">
+                  <a:latin typeface="Arial" panose="020B0604020202020204" pitchFamily="34" charset="0"/>
+                  <a:ea typeface="Arial Unicode MS" panose="020B0604020202020204" pitchFamily="34" charset="-128"/>
+                  <a:cs typeface="Arial" panose="020B0604020202020204" pitchFamily="34" charset="0"/>
+                </a:rPr>
+                <a:t>50:50</a:t>
+              </a:r>
+            </a:p>
+          </p:txBody>
+        </p:sp>
+        <p:sp>
+          <p:nvSpPr>
+            <p:cNvPr id="8" name="TextBox 7">
+              <a:extLst>
+                <a:ext uri="{FF2B5EF4-FFF2-40B4-BE49-F238E27FC236}">
+                  <a16:creationId xmlns:a16="http://schemas.microsoft.com/office/drawing/2014/main" id="{8F532924-E0BA-A55A-C98C-B0910C1B8402}"/>
+                </a:ext>
+              </a:extLst>
+            </p:cNvPr>
+            <p:cNvSpPr txBox="1"/>
+            <p:nvPr/>
+          </p:nvSpPr>
+          <p:spPr>
+            <a:xfrm>
+              <a:off x="3514163" y="4527068"/>
+              <a:ext cx="2211143" cy="756769"/>
+            </a:xfrm>
+            <a:prstGeom prst="rect">
+              <a:avLst/>
+            </a:prstGeom>
+            <a:noFill/>
+          </p:spPr>
+          <p:txBody>
+            <a:bodyPr wrap="square" rtlCol="0">
+              <a:spAutoFit/>
+            </a:bodyPr>
+            <a:lstStyle/>
+            <a:p>
+              <a:pPr algn="ctr"/>
+              <a:r>
+                <a:rPr lang="en-US" sz="1600" b="1" dirty="0">
+                  <a:latin typeface="Arial" panose="020B0604020202020204" pitchFamily="34" charset="0"/>
+                  <a:ea typeface="Arial Unicode MS" panose="020B0604020202020204" pitchFamily="34" charset="-128"/>
+                  <a:cs typeface="Arial" panose="020B0604020202020204" pitchFamily="34" charset="0"/>
+                </a:rPr>
+                <a:t>Unequal block</a:t>
+              </a:r>
+            </a:p>
+            <a:p>
+              <a:pPr algn="ctr"/>
+              <a:r>
+                <a:rPr lang="en-US" sz="1600" b="1" dirty="0">
+                  <a:latin typeface="Arial" panose="020B0604020202020204" pitchFamily="34" charset="0"/>
+                  <a:ea typeface="Arial Unicode MS" panose="020B0604020202020204" pitchFamily="34" charset="-128"/>
+                  <a:cs typeface="Arial" panose="020B0604020202020204" pitchFamily="34" charset="0"/>
+                </a:rPr>
+                <a:t>70:30 </a:t>
+              </a:r>
+            </a:p>
+          </p:txBody>
+        </p:sp>
+      </p:grpSp>
+      <p:sp>
+        <p:nvSpPr>
+          <p:cNvPr id="12" name="TextBox 11">
+            <a:extLst>
+              <a:ext uri="{FF2B5EF4-FFF2-40B4-BE49-F238E27FC236}">
+                <a16:creationId xmlns:a16="http://schemas.microsoft.com/office/drawing/2014/main" id="{B877C7BD-D466-C7E7-D408-BB8712CE104E}"/>
+              </a:ext>
+            </a:extLst>
+          </p:cNvPr>
+          <p:cNvSpPr txBox="1"/>
+          <p:nvPr/>
+        </p:nvSpPr>
+        <p:spPr>
+          <a:xfrm flipV="1">
+            <a:off x="1343431" y="1452283"/>
+            <a:ext cx="492443" cy="1846729"/>
+          </a:xfrm>
+          <a:prstGeom prst="rect">
+            <a:avLst/>
+          </a:prstGeom>
+          <a:noFill/>
+        </p:spPr>
+        <p:txBody>
+          <a:bodyPr vert="eaVert" wrap="square" rtlCol="0">
+            <a:spAutoFit/>
+          </a:bodyPr>
+          <a:lstStyle/>
+          <a:p>
+            <a:r>
+              <a:rPr lang="en-US" sz="2000" b="1" dirty="0">
+                <a:latin typeface="Arial Unicode MS" panose="020B0604020202020204" pitchFamily="34" charset="-128"/>
+                <a:ea typeface="Arial Unicode MS" panose="020B0604020202020204" pitchFamily="34" charset="-128"/>
+                <a:cs typeface="Arial Unicode MS" panose="020B0604020202020204" pitchFamily="34" charset="-128"/>
+              </a:rPr>
+              <a:t>Trial Structure</a:t>
+            </a:r>
+          </a:p>
+        </p:txBody>
+      </p:sp>
+      <p:sp>
+        <p:nvSpPr>
+          <p:cNvPr id="13" name="TextBox 12">
+            <a:extLst>
+              <a:ext uri="{FF2B5EF4-FFF2-40B4-BE49-F238E27FC236}">
+                <a16:creationId xmlns:a16="http://schemas.microsoft.com/office/drawing/2014/main" id="{81618246-38DA-F81A-986F-9FADB4B4B9C8}"/>
+              </a:ext>
+            </a:extLst>
+          </p:cNvPr>
+          <p:cNvSpPr txBox="1"/>
+          <p:nvPr/>
+        </p:nvSpPr>
+        <p:spPr>
+          <a:xfrm flipV="1">
+            <a:off x="1343431" y="3558988"/>
+            <a:ext cx="492443" cy="1846729"/>
+          </a:xfrm>
+          <a:prstGeom prst="rect">
+            <a:avLst/>
+          </a:prstGeom>
+          <a:noFill/>
+        </p:spPr>
+        <p:txBody>
+          <a:bodyPr vert="eaVert" wrap="square" rtlCol="0">
+            <a:spAutoFit/>
+          </a:bodyPr>
+          <a:lstStyle/>
+          <a:p>
+            <a:r>
+              <a:rPr lang="en-US" sz="2000" b="1" dirty="0">
+                <a:latin typeface="Arial Unicode MS" panose="020B0604020202020204" pitchFamily="34" charset="-128"/>
+                <a:ea typeface="Arial Unicode MS" panose="020B0604020202020204" pitchFamily="34" charset="-128"/>
+                <a:cs typeface="Arial Unicode MS" panose="020B0604020202020204" pitchFamily="34" charset="-128"/>
+              </a:rPr>
+              <a:t>Block design</a:t>
+            </a:r>
+          </a:p>
+        </p:txBody>
+      </p:sp>
       <p:sp>
         <p:nvSpPr>
           <p:cNvPr id="2" name="Title 1">
             <a:extLst>
               <a:ext uri="{FF2B5EF4-FFF2-40B4-BE49-F238E27FC236}">
-                <a16:creationId xmlns:a16="http://schemas.microsoft.com/office/drawing/2014/main" id="{1ED96086-7F4C-84F4-077F-2092C952D87E}"/>
+                <a16:creationId xmlns:a16="http://schemas.microsoft.com/office/drawing/2014/main" id="{04A4DA63-A312-5F14-1934-6E043C485911}"/>
+              </a:ext>
+            </a:extLst>
+          </p:cNvPr>
+          <p:cNvSpPr txBox="1">
+            <a:spLocks/>
+          </p:cNvSpPr>
+          <p:nvPr/>
+        </p:nvSpPr>
+        <p:spPr>
+          <a:xfrm>
+            <a:off x="838200" y="365125"/>
+            <a:ext cx="10515600" cy="1325563"/>
+          </a:xfrm>
+          <a:prstGeom prst="rect">
+            <a:avLst/>
+          </a:prstGeom>
+        </p:spPr>
+        <p:txBody>
+          <a:bodyPr vert="horz" lIns="91440" tIns="45720" rIns="91440" bIns="45720" rtlCol="0" anchor="ctr">
+            <a:normAutofit/>
+          </a:bodyPr>
+          <a:lstStyle>
+            <a:lvl1pPr algn="l" defTabSz="914400" rtl="0" eaLnBrk="1" latinLnBrk="0" hangingPunct="1">
+              <a:lnSpc>
+                <a:spcPct val="90000"/>
+              </a:lnSpc>
+              <a:spcBef>
+                <a:spcPct val="0"/>
+              </a:spcBef>
+              <a:buNone/>
+              <a:defRPr sz="4400" kern="1200">
+                <a:solidFill>
+                  <a:schemeClr val="tx1"/>
+                </a:solidFill>
+                <a:latin typeface="+mj-lt"/>
+                <a:ea typeface="+mj-ea"/>
+                <a:cs typeface="+mj-cs"/>
+              </a:defRPr>
+            </a:lvl1pPr>
+          </a:lstStyle>
+          <a:p>
+            <a:r>
+              <a:rPr lang="en-US"/>
+              <a:t>Fig1. Task</a:t>
+            </a:r>
+            <a:endParaRPr lang="en-US" dirty="0"/>
+          </a:p>
+        </p:txBody>
+      </p:sp>
+      <p:sp>
+        <p:nvSpPr>
+          <p:cNvPr id="10" name="Title 9">
+            <a:extLst>
+              <a:ext uri="{FF2B5EF4-FFF2-40B4-BE49-F238E27FC236}">
+                <a16:creationId xmlns:a16="http://schemas.microsoft.com/office/drawing/2014/main" id="{E5FA80C4-C9E3-B6D6-E326-035058A4E8D0}"/>
               </a:ext>
             </a:extLst>
           </p:cNvPr>
@@ -4302,34 +4810,6 @@
           </p:cNvSpPr>
           <p:nvPr>
             <p:ph type="title"/>
-          </p:nvPr>
-        </p:nvSpPr>
-        <p:spPr/>
-        <p:txBody>
-          <a:bodyPr/>
-          <a:lstStyle/>
-          <a:p>
-            <a:r>
-              <a:rPr lang="en-US" dirty="0"/>
-              <a:t>Fig1. Task</a:t>
-            </a:r>
-          </a:p>
-        </p:txBody>
-      </p:sp>
-      <p:sp>
-        <p:nvSpPr>
-          <p:cNvPr id="3" name="Content Placeholder 2">
-            <a:extLst>
-              <a:ext uri="{FF2B5EF4-FFF2-40B4-BE49-F238E27FC236}">
-                <a16:creationId xmlns:a16="http://schemas.microsoft.com/office/drawing/2014/main" id="{2C02785F-9460-BC13-7BFC-D54602C50E7E}"/>
-              </a:ext>
-            </a:extLst>
-          </p:cNvPr>
-          <p:cNvSpPr>
-            <a:spLocks noGrp="1"/>
-          </p:cNvSpPr>
-          <p:nvPr>
-            <p:ph idx="1"/>
           </p:nvPr>
         </p:nvSpPr>
         <p:spPr/>
@@ -4344,7 +4824,7 @@
     </p:spTree>
     <p:extLst>
       <p:ext uri="{BB962C8B-B14F-4D97-AF65-F5344CB8AC3E}">
-        <p14:creationId xmlns:p14="http://schemas.microsoft.com/office/powerpoint/2010/main" val="1294242674"/>
+        <p14:creationId xmlns:p14="http://schemas.microsoft.com/office/powerpoint/2010/main" val="1402081630"/>
       </p:ext>
     </p:extLst>
   </p:cSld>
@@ -5555,10 +6035,10 @@
       </p:pic>
       <p:grpSp>
         <p:nvGrpSpPr>
-          <p:cNvPr id="15" name="Group 14">
-            <a:extLst>
-              <a:ext uri="{FF2B5EF4-FFF2-40B4-BE49-F238E27FC236}">
-                <a16:creationId xmlns:a16="http://schemas.microsoft.com/office/drawing/2014/main" id="{6A625FF7-17F5-3C87-A737-E2636BC4FC81}"/>
+          <p:cNvPr id="3" name="Group 2">
+            <a:extLst>
+              <a:ext uri="{FF2B5EF4-FFF2-40B4-BE49-F238E27FC236}">
+                <a16:creationId xmlns:a16="http://schemas.microsoft.com/office/drawing/2014/main" id="{EDC456D4-29BD-B94E-9175-4361FD929B8B}"/>
               </a:ext>
             </a:extLst>
           </p:cNvPr>
@@ -5567,10 +6047,10 @@
         </p:nvGrpSpPr>
         <p:grpSpPr>
           <a:xfrm>
-            <a:off x="664782" y="2466518"/>
-            <a:ext cx="3745704" cy="2743200"/>
-            <a:chOff x="957682" y="2595110"/>
-            <a:chExt cx="3745704" cy="2884237"/>
+            <a:off x="708837" y="2466518"/>
+            <a:ext cx="3610067" cy="2743200"/>
+            <a:chOff x="708837" y="2466518"/>
+            <a:chExt cx="3610067" cy="2743200"/>
           </a:xfrm>
         </p:grpSpPr>
         <p:pic>
@@ -5600,8 +6080,8 @@
           </p:blipFill>
           <p:spPr>
             <a:xfrm>
-              <a:off x="957682" y="2666979"/>
-              <a:ext cx="3745704" cy="2812368"/>
+              <a:off x="708837" y="2534873"/>
+              <a:ext cx="3610067" cy="2674845"/>
             </a:xfrm>
             <a:prstGeom prst="rect">
               <a:avLst/>
@@ -5622,8 +6102,8 @@
           </p:nvSpPr>
           <p:spPr>
             <a:xfrm>
-              <a:off x="2164556" y="2595110"/>
-              <a:ext cx="500063" cy="483917"/>
+              <a:off x="1871656" y="2466518"/>
+              <a:ext cx="500063" cy="460254"/>
             </a:xfrm>
             <a:prstGeom prst="roundRect">
               <a:avLst/>
@@ -5712,6 +6192,308 @@
 </file>
 
 <file path=ppt/slides/slide7.xml><?xml version="1.0" encoding="utf-8"?>
+<p:sld xmlns:a="http://schemas.openxmlformats.org/drawingml/2006/main" xmlns:r="http://schemas.openxmlformats.org/officeDocument/2006/relationships" xmlns:p="http://schemas.openxmlformats.org/presentationml/2006/main">
+  <p:cSld>
+    <p:spTree>
+      <p:nvGrpSpPr>
+        <p:cNvPr id="1" name="">
+          <a:extLst>
+            <a:ext uri="{FF2B5EF4-FFF2-40B4-BE49-F238E27FC236}">
+              <a16:creationId xmlns:a16="http://schemas.microsoft.com/office/drawing/2014/main" id="{3112AA24-BDA2-79B6-4683-6DF63DC1DBAA}"/>
+            </a:ext>
+          </a:extLst>
+        </p:cNvPr>
+        <p:cNvGrpSpPr/>
+        <p:nvPr/>
+      </p:nvGrpSpPr>
+      <p:grpSpPr>
+        <a:xfrm>
+          <a:off x="0" y="0"/>
+          <a:ext cx="0" cy="0"/>
+          <a:chOff x="0" y="0"/>
+          <a:chExt cx="0" cy="0"/>
+        </a:xfrm>
+      </p:grpSpPr>
+      <p:pic>
+        <p:nvPicPr>
+          <p:cNvPr id="11" name="Picture 10">
+            <a:extLst>
+              <a:ext uri="{FF2B5EF4-FFF2-40B4-BE49-F238E27FC236}">
+                <a16:creationId xmlns:a16="http://schemas.microsoft.com/office/drawing/2014/main" id="{3B60A0AB-3D04-1AE0-49FC-48FD416A0371}"/>
+              </a:ext>
+            </a:extLst>
+          </p:cNvPr>
+          <p:cNvPicPr>
+            <a:picLocks noChangeAspect="1"/>
+          </p:cNvPicPr>
+          <p:nvPr/>
+        </p:nvPicPr>
+        <p:blipFill>
+          <a:blip r:embed="rId2">
+            <a:extLst>
+              <a:ext uri="{28A0092B-C50C-407E-A947-70E740481C1C}">
+                <a14:useLocalDpi xmlns:a14="http://schemas.microsoft.com/office/drawing/2010/main" val="0"/>
+              </a:ext>
+            </a:extLst>
+          </a:blip>
+          <a:srcRect/>
+          <a:stretch/>
+        </p:blipFill>
+        <p:spPr>
+          <a:xfrm>
+            <a:off x="1057498" y="73937"/>
+            <a:ext cx="4414726" cy="3297073"/>
+          </a:xfrm>
+          <a:prstGeom prst="rect">
+            <a:avLst/>
+          </a:prstGeom>
+        </p:spPr>
+      </p:pic>
+      <p:pic>
+        <p:nvPicPr>
+          <p:cNvPr id="4" name="Picture 3">
+            <a:extLst>
+              <a:ext uri="{FF2B5EF4-FFF2-40B4-BE49-F238E27FC236}">
+                <a16:creationId xmlns:a16="http://schemas.microsoft.com/office/drawing/2014/main" id="{03E24DCD-D397-183C-C7A5-3AC58BFDAAEE}"/>
+              </a:ext>
+            </a:extLst>
+          </p:cNvPr>
+          <p:cNvPicPr>
+            <a:picLocks noChangeAspect="1"/>
+          </p:cNvPicPr>
+          <p:nvPr/>
+        </p:nvPicPr>
+        <p:blipFill>
+          <a:blip r:embed="rId3"/>
+          <a:stretch>
+            <a:fillRect/>
+          </a:stretch>
+        </p:blipFill>
+        <p:spPr>
+          <a:xfrm>
+            <a:off x="5977935" y="73937"/>
+            <a:ext cx="4967052" cy="3721396"/>
+          </a:xfrm>
+          <a:prstGeom prst="rect">
+            <a:avLst/>
+          </a:prstGeom>
+        </p:spPr>
+      </p:pic>
+      <p:pic>
+        <p:nvPicPr>
+          <p:cNvPr id="6" name="Picture 5">
+            <a:extLst>
+              <a:ext uri="{FF2B5EF4-FFF2-40B4-BE49-F238E27FC236}">
+                <a16:creationId xmlns:a16="http://schemas.microsoft.com/office/drawing/2014/main" id="{55668DA3-F20A-DC0F-3F34-EEFA322FF58F}"/>
+              </a:ext>
+            </a:extLst>
+          </p:cNvPr>
+          <p:cNvPicPr>
+            <a:picLocks noChangeAspect="1"/>
+          </p:cNvPicPr>
+          <p:nvPr/>
+        </p:nvPicPr>
+        <p:blipFill>
+          <a:blip r:embed="rId4"/>
+          <a:stretch>
+            <a:fillRect/>
+          </a:stretch>
+        </p:blipFill>
+        <p:spPr>
+          <a:xfrm>
+            <a:off x="1837429" y="3486991"/>
+            <a:ext cx="4258571" cy="3053315"/>
+          </a:xfrm>
+          <a:prstGeom prst="rect">
+            <a:avLst/>
+          </a:prstGeom>
+        </p:spPr>
+      </p:pic>
+      <p:sp>
+        <p:nvSpPr>
+          <p:cNvPr id="7" name="TextBox 6">
+            <a:extLst>
+              <a:ext uri="{FF2B5EF4-FFF2-40B4-BE49-F238E27FC236}">
+                <a16:creationId xmlns:a16="http://schemas.microsoft.com/office/drawing/2014/main" id="{D829B96F-2139-C8EE-D71D-8EEF4933D86A}"/>
+              </a:ext>
+            </a:extLst>
+          </p:cNvPr>
+          <p:cNvSpPr txBox="1"/>
+          <p:nvPr/>
+        </p:nvSpPr>
+        <p:spPr>
+          <a:xfrm>
+            <a:off x="6677247" y="4281377"/>
+            <a:ext cx="4423144" cy="1477328"/>
+          </a:xfrm>
+          <a:prstGeom prst="rect">
+            <a:avLst/>
+          </a:prstGeom>
+          <a:noFill/>
+        </p:spPr>
+        <p:txBody>
+          <a:bodyPr wrap="square" rtlCol="0">
+            <a:spAutoFit/>
+          </a:bodyPr>
+          <a:lstStyle/>
+          <a:p>
+            <a:r>
+              <a:rPr lang="en-US" dirty="0"/>
+              <a:t>Log-likelihood: 2 states is the best</a:t>
+            </a:r>
+          </a:p>
+          <a:p>
+            <a:r>
+              <a:rPr lang="en-US" dirty="0"/>
+              <a:t>Predictive accuracy: 5 states is the highest</a:t>
+            </a:r>
+          </a:p>
+          <a:p>
+            <a:endParaRPr lang="en-US" dirty="0"/>
+          </a:p>
+          <a:p>
+            <a:r>
+              <a:rPr lang="en-US" dirty="0"/>
+              <a:t>5 states models are overall over-confident, i.e. higher penalty on incorrect predictions</a:t>
+            </a:r>
+          </a:p>
+        </p:txBody>
+      </p:sp>
+    </p:spTree>
+    <p:extLst>
+      <p:ext uri="{BB962C8B-B14F-4D97-AF65-F5344CB8AC3E}">
+        <p14:creationId xmlns:p14="http://schemas.microsoft.com/office/powerpoint/2010/main" val="2768749306"/>
+      </p:ext>
+    </p:extLst>
+  </p:cSld>
+  <p:clrMapOvr>
+    <a:masterClrMapping/>
+  </p:clrMapOvr>
+</p:sld>
+</file>
+
+<file path=ppt/slides/slide8.xml><?xml version="1.0" encoding="utf-8"?>
+<p:sld xmlns:a="http://schemas.openxmlformats.org/drawingml/2006/main" xmlns:r="http://schemas.openxmlformats.org/officeDocument/2006/relationships" xmlns:p="http://schemas.openxmlformats.org/presentationml/2006/main">
+  <p:cSld>
+    <p:spTree>
+      <p:nvGrpSpPr>
+        <p:cNvPr id="1" name=""/>
+        <p:cNvGrpSpPr/>
+        <p:nvPr/>
+      </p:nvGrpSpPr>
+      <p:grpSpPr>
+        <a:xfrm>
+          <a:off x="0" y="0"/>
+          <a:ext cx="0" cy="0"/>
+          <a:chOff x="0" y="0"/>
+          <a:chExt cx="0" cy="0"/>
+        </a:xfrm>
+      </p:grpSpPr>
+      <p:sp>
+        <p:nvSpPr>
+          <p:cNvPr id="2" name="Title 1">
+            <a:extLst>
+              <a:ext uri="{FF2B5EF4-FFF2-40B4-BE49-F238E27FC236}">
+                <a16:creationId xmlns:a16="http://schemas.microsoft.com/office/drawing/2014/main" id="{10B478D0-24D6-AA0A-8EB7-CAA5D77BB3B7}"/>
+              </a:ext>
+            </a:extLst>
+          </p:cNvPr>
+          <p:cNvSpPr>
+            <a:spLocks noGrp="1"/>
+          </p:cNvSpPr>
+          <p:nvPr>
+            <p:ph type="title"/>
+          </p:nvPr>
+        </p:nvSpPr>
+        <p:spPr/>
+        <p:txBody>
+          <a:bodyPr/>
+          <a:lstStyle/>
+          <a:p>
+            <a:r>
+              <a:rPr lang="en-US" dirty="0"/>
+              <a:t>Unequal block only GLM-HMM</a:t>
+            </a:r>
+          </a:p>
+        </p:txBody>
+      </p:sp>
+      <p:sp>
+        <p:nvSpPr>
+          <p:cNvPr id="3" name="Content Placeholder 2">
+            <a:extLst>
+              <a:ext uri="{FF2B5EF4-FFF2-40B4-BE49-F238E27FC236}">
+                <a16:creationId xmlns:a16="http://schemas.microsoft.com/office/drawing/2014/main" id="{ED1DDD19-839D-6192-96FC-210DCC2AC81A}"/>
+              </a:ext>
+            </a:extLst>
+          </p:cNvPr>
+          <p:cNvSpPr>
+            <a:spLocks noGrp="1"/>
+          </p:cNvSpPr>
+          <p:nvPr>
+            <p:ph idx="1"/>
+          </p:nvPr>
+        </p:nvSpPr>
+        <p:spPr>
+          <a:xfrm>
+            <a:off x="6741885" y="2066292"/>
+            <a:ext cx="3422756" cy="4351338"/>
+          </a:xfrm>
+        </p:spPr>
+        <p:txBody>
+          <a:bodyPr/>
+          <a:lstStyle/>
+          <a:p>
+            <a:r>
+              <a:rPr lang="en-US" dirty="0"/>
+              <a:t>2 states is still the best</a:t>
+            </a:r>
+          </a:p>
+        </p:txBody>
+      </p:sp>
+      <p:pic>
+        <p:nvPicPr>
+          <p:cNvPr id="5" name="Picture 4">
+            <a:extLst>
+              <a:ext uri="{FF2B5EF4-FFF2-40B4-BE49-F238E27FC236}">
+                <a16:creationId xmlns:a16="http://schemas.microsoft.com/office/drawing/2014/main" id="{A0A6D343-A6F4-4538-B91E-01FF17B780F3}"/>
+              </a:ext>
+            </a:extLst>
+          </p:cNvPr>
+          <p:cNvPicPr>
+            <a:picLocks noChangeAspect="1"/>
+          </p:cNvPicPr>
+          <p:nvPr/>
+        </p:nvPicPr>
+        <p:blipFill>
+          <a:blip r:embed="rId2"/>
+          <a:stretch>
+            <a:fillRect/>
+          </a:stretch>
+        </p:blipFill>
+        <p:spPr>
+          <a:xfrm>
+            <a:off x="-407028" y="1499855"/>
+            <a:ext cx="6257925" cy="4552950"/>
+          </a:xfrm>
+          <a:prstGeom prst="rect">
+            <a:avLst/>
+          </a:prstGeom>
+        </p:spPr>
+      </p:pic>
+    </p:spTree>
+    <p:extLst>
+      <p:ext uri="{BB962C8B-B14F-4D97-AF65-F5344CB8AC3E}">
+        <p14:creationId xmlns:p14="http://schemas.microsoft.com/office/powerpoint/2010/main" val="3385422129"/>
+      </p:ext>
+    </p:extLst>
+  </p:cSld>
+  <p:clrMapOvr>
+    <a:masterClrMapping/>
+  </p:clrMapOvr>
+</p:sld>
+</file>
+
+<file path=ppt/slides/slide9.xml><?xml version="1.0" encoding="utf-8"?>
 <p:sld xmlns:a="http://schemas.openxmlformats.org/drawingml/2006/main" xmlns:r="http://schemas.openxmlformats.org/officeDocument/2006/relationships" xmlns:p="http://schemas.openxmlformats.org/presentationml/2006/main">
   <p:cSld>
     <p:spTree>

</xml_diff>

<commit_message>
chore: refactoring glm-hmm section
</commit_message>
<xml_diff>
--- a/dissemination/Prior encoding of Superior Colliculus in perceptual decision-making.pptx
+++ b/dissemination/Prior encoding of Superior Colliculus in perceptual decision-making.pptx
@@ -5,18 +5,22 @@
     <p:sldMasterId id="2147483648" r:id="rId1"/>
   </p:sldMasterIdLst>
   <p:notesMasterIdLst>
-    <p:notesMasterId r:id="rId11"/>
+    <p:notesMasterId r:id="rId15"/>
   </p:notesMasterIdLst>
   <p:sldIdLst>
     <p:sldId id="256" r:id="rId2"/>
     <p:sldId id="269" r:id="rId3"/>
     <p:sldId id="259" r:id="rId4"/>
-    <p:sldId id="257" r:id="rId5"/>
-    <p:sldId id="261" r:id="rId6"/>
-    <p:sldId id="262" r:id="rId7"/>
-    <p:sldId id="266" r:id="rId8"/>
-    <p:sldId id="270" r:id="rId9"/>
-    <p:sldId id="264" r:id="rId10"/>
+    <p:sldId id="271" r:id="rId5"/>
+    <p:sldId id="273" r:id="rId6"/>
+    <p:sldId id="272" r:id="rId7"/>
+    <p:sldId id="274" r:id="rId8"/>
+    <p:sldId id="257" r:id="rId9"/>
+    <p:sldId id="261" r:id="rId10"/>
+    <p:sldId id="262" r:id="rId11"/>
+    <p:sldId id="266" r:id="rId12"/>
+    <p:sldId id="275" r:id="rId13"/>
+    <p:sldId id="264" r:id="rId14"/>
   </p:sldIdLst>
   <p:sldSz cx="12192000" cy="6858000"/>
   <p:notesSz cx="6858000" cy="9144000"/>
@@ -205,7 +209,7 @@
           <a:p>
             <a:fld id="{BA3E252F-87BF-4487-AB21-8F0FF193234C}" type="datetimeFigureOut">
               <a:rPr lang="en-US" smtClean="0"/>
-              <a:t>7/24/2025</a:t>
+              <a:t>7/28/2025</a:t>
             </a:fld>
             <a:endParaRPr lang="en-US"/>
           </a:p>
@@ -756,30 +760,10 @@
           <a:bodyPr/>
           <a:lstStyle/>
           <a:p>
-            <a:pPr marL="0" marR="0" lvl="0" indent="0" algn="l" defTabSz="914400" rtl="0" eaLnBrk="1" fontAlgn="auto" latinLnBrk="0" hangingPunct="1">
-              <a:lnSpc>
-                <a:spcPct val="100000"/>
-              </a:lnSpc>
-              <a:spcBef>
-                <a:spcPts val="0"/>
-              </a:spcBef>
-              <a:spcAft>
-                <a:spcPts val="0"/>
-              </a:spcAft>
-              <a:buClrTx/>
-              <a:buSzTx/>
-              <a:buFontTx/>
-              <a:buNone/>
-              <a:tabLst/>
-              <a:defRPr/>
-            </a:pPr>
-            <a:r>
-              <a:rPr lang="en-US" sz="1200" dirty="0"/>
-              <a:t>Chronometric functions of equal and unequal prior blocks for left-prior sessions (top panel, n=24 sessions) and right-prior sessions (bottom panel, n=21 sessions).In each panel, the left subplot shows mean reaction time for correct trials, and the right subplot shows mean reaction time for incorrect trials.</a:t>
-            </a:r>
-          </a:p>
-          <a:p>
-            <a:endParaRPr lang="en-US" dirty="0"/>
+            <a:r>
+              <a:rPr lang="en-US" dirty="0"/>
+              <a:t>Half Psychometric functions fit to left and right choices separately</a:t>
+            </a:r>
           </a:p>
         </p:txBody>
       </p:sp>
@@ -809,7 +793,7 @@
     </p:spTree>
     <p:extLst>
       <p:ext uri="{BB962C8B-B14F-4D97-AF65-F5344CB8AC3E}">
-        <p14:creationId xmlns:p14="http://schemas.microsoft.com/office/powerpoint/2010/main" val="258914497"/>
+        <p14:creationId xmlns:p14="http://schemas.microsoft.com/office/powerpoint/2010/main" val="362348999"/>
       </p:ext>
     </p:extLst>
   </p:cSld>
@@ -863,36 +847,30 @@
           <a:bodyPr/>
           <a:lstStyle/>
           <a:p>
-            <a:r>
-              <a:rPr lang="en-US" b="1" dirty="0"/>
-              <a:t>Traditional psychophysics (SDT)</a:t>
-            </a:r>
-            <a:r>
-              <a:rPr lang="en-US" dirty="0"/>
-              <a:t> assumes a static criterion and lacks temporal structure.</a:t>
-            </a:r>
-            <a:br>
-              <a:rPr lang="en-US" dirty="0"/>
-            </a:br>
-            <a:r>
-              <a:rPr lang="en-US" b="1" dirty="0"/>
-              <a:t>Drift-diffusion models (DDM)</a:t>
-            </a:r>
-            <a:r>
-              <a:rPr lang="en-US" dirty="0"/>
-              <a:t> introduce within-trial dynamics but ignore across-trial dependencies.</a:t>
-            </a:r>
-            <a:br>
-              <a:rPr lang="en-US" dirty="0"/>
-            </a:br>
-            <a:r>
-              <a:rPr lang="en-US" b="1" dirty="0"/>
-              <a:t>GLM-HMM</a:t>
-            </a:r>
-            <a:r>
-              <a:rPr lang="en-US" dirty="0"/>
-              <a:t> bridges the gap by modeling hidden cognitive states that evolve over trials and shape decisions.</a:t>
-            </a:r>
+            <a:pPr marL="0" marR="0" lvl="0" indent="0" algn="l" defTabSz="914400" rtl="0" eaLnBrk="1" fontAlgn="auto" latinLnBrk="0" hangingPunct="1">
+              <a:lnSpc>
+                <a:spcPct val="100000"/>
+              </a:lnSpc>
+              <a:spcBef>
+                <a:spcPts val="0"/>
+              </a:spcBef>
+              <a:spcAft>
+                <a:spcPts val="0"/>
+              </a:spcAft>
+              <a:buClrTx/>
+              <a:buSzTx/>
+              <a:buFontTx/>
+              <a:buNone/>
+              <a:tabLst/>
+              <a:defRPr/>
+            </a:pPr>
+            <a:r>
+              <a:rPr lang="en-US" sz="1200" dirty="0"/>
+              <a:t>Chronometric functions of equal and unequal prior blocks for left-prior sessions (top panel, n=24 sessions) and right-prior sessions (bottom panel, n=21 sessions).In each panel, the left subplot shows mean reaction time for correct trials, and the right subplot shows mean reaction time for incorrect trials.</a:t>
+            </a:r>
+          </a:p>
+          <a:p>
+            <a:endParaRPr lang="en-US" dirty="0"/>
           </a:p>
         </p:txBody>
       </p:sp>
@@ -913,7 +891,7 @@
           <a:p>
             <a:fld id="{F4472248-5027-4A3C-9488-9C593E53F37B}" type="slidenum">
               <a:rPr lang="en-US" smtClean="0"/>
-              <a:t>5</a:t>
+              <a:t>8</a:t>
             </a:fld>
             <a:endParaRPr lang="en-US"/>
           </a:p>
@@ -922,7 +900,7 @@
     </p:spTree>
     <p:extLst>
       <p:ext uri="{BB962C8B-B14F-4D97-AF65-F5344CB8AC3E}">
-        <p14:creationId xmlns:p14="http://schemas.microsoft.com/office/powerpoint/2010/main" val="2477942779"/>
+        <p14:creationId xmlns:p14="http://schemas.microsoft.com/office/powerpoint/2010/main" val="258914497"/>
       </p:ext>
     </p:extLst>
   </p:cSld>
@@ -976,7 +954,36 @@
           <a:bodyPr/>
           <a:lstStyle/>
           <a:p>
-            <a:endParaRPr lang="en-US" dirty="0"/>
+            <a:r>
+              <a:rPr lang="en-US" b="1" dirty="0"/>
+              <a:t>Traditional psychophysics (SDT)</a:t>
+            </a:r>
+            <a:r>
+              <a:rPr lang="en-US" dirty="0"/>
+              <a:t> assumes a static criterion and lacks temporal structure.</a:t>
+            </a:r>
+            <a:br>
+              <a:rPr lang="en-US" dirty="0"/>
+            </a:br>
+            <a:r>
+              <a:rPr lang="en-US" b="1" dirty="0"/>
+              <a:t>Drift-diffusion models (DDM)</a:t>
+            </a:r>
+            <a:r>
+              <a:rPr lang="en-US" dirty="0"/>
+              <a:t> introduce within-trial dynamics but ignore across-trial dependencies.</a:t>
+            </a:r>
+            <a:br>
+              <a:rPr lang="en-US" dirty="0"/>
+            </a:br>
+            <a:r>
+              <a:rPr lang="en-US" b="1" dirty="0"/>
+              <a:t>GLM-HMM</a:t>
+            </a:r>
+            <a:r>
+              <a:rPr lang="en-US" dirty="0"/>
+              <a:t> bridges the gap by modeling hidden cognitive states that evolve over trials and shape decisions.</a:t>
+            </a:r>
           </a:p>
         </p:txBody>
       </p:sp>
@@ -997,7 +1004,91 @@
           <a:p>
             <a:fld id="{F4472248-5027-4A3C-9488-9C593E53F37B}" type="slidenum">
               <a:rPr lang="en-US" smtClean="0"/>
-              <a:t>6</a:t>
+              <a:t>9</a:t>
+            </a:fld>
+            <a:endParaRPr lang="en-US"/>
+          </a:p>
+        </p:txBody>
+      </p:sp>
+    </p:spTree>
+    <p:extLst>
+      <p:ext uri="{BB962C8B-B14F-4D97-AF65-F5344CB8AC3E}">
+        <p14:creationId xmlns:p14="http://schemas.microsoft.com/office/powerpoint/2010/main" val="2477942779"/>
+      </p:ext>
+    </p:extLst>
+  </p:cSld>
+  <p:clrMapOvr>
+    <a:masterClrMapping/>
+  </p:clrMapOvr>
+</p:notes>
+</file>
+
+<file path=ppt/notesSlides/notesSlide6.xml><?xml version="1.0" encoding="utf-8"?>
+<p:notes xmlns:a="http://schemas.openxmlformats.org/drawingml/2006/main" xmlns:r="http://schemas.openxmlformats.org/officeDocument/2006/relationships" xmlns:p="http://schemas.openxmlformats.org/presentationml/2006/main">
+  <p:cSld>
+    <p:spTree>
+      <p:nvGrpSpPr>
+        <p:cNvPr id="1" name=""/>
+        <p:cNvGrpSpPr/>
+        <p:nvPr/>
+      </p:nvGrpSpPr>
+      <p:grpSpPr>
+        <a:xfrm>
+          <a:off x="0" y="0"/>
+          <a:ext cx="0" cy="0"/>
+          <a:chOff x="0" y="0"/>
+          <a:chExt cx="0" cy="0"/>
+        </a:xfrm>
+      </p:grpSpPr>
+      <p:sp>
+        <p:nvSpPr>
+          <p:cNvPr id="2" name="Slide Image Placeholder 1"/>
+          <p:cNvSpPr>
+            <a:spLocks noGrp="1" noRot="1" noChangeAspect="1"/>
+          </p:cNvSpPr>
+          <p:nvPr>
+            <p:ph type="sldImg"/>
+          </p:nvPr>
+        </p:nvSpPr>
+        <p:spPr/>
+      </p:sp>
+      <p:sp>
+        <p:nvSpPr>
+          <p:cNvPr id="3" name="Notes Placeholder 2"/>
+          <p:cNvSpPr>
+            <a:spLocks noGrp="1"/>
+          </p:cNvSpPr>
+          <p:nvPr>
+            <p:ph type="body" idx="1"/>
+          </p:nvPr>
+        </p:nvSpPr>
+        <p:spPr/>
+        <p:txBody>
+          <a:bodyPr/>
+          <a:lstStyle/>
+          <a:p>
+            <a:endParaRPr lang="en-US" dirty="0"/>
+          </a:p>
+        </p:txBody>
+      </p:sp>
+      <p:sp>
+        <p:nvSpPr>
+          <p:cNvPr id="4" name="Slide Number Placeholder 3"/>
+          <p:cNvSpPr>
+            <a:spLocks noGrp="1"/>
+          </p:cNvSpPr>
+          <p:nvPr>
+            <p:ph type="sldNum" sz="quarter" idx="5"/>
+          </p:nvPr>
+        </p:nvSpPr>
+        <p:spPr/>
+        <p:txBody>
+          <a:bodyPr/>
+          <a:lstStyle/>
+          <a:p>
+            <a:fld id="{F4472248-5027-4A3C-9488-9C593E53F37B}" type="slidenum">
+              <a:rPr lang="en-US" smtClean="0"/>
+              <a:t>10</a:t>
             </a:fld>
             <a:endParaRPr lang="en-US"/>
           </a:p>
@@ -1016,7 +1107,232 @@
 </p:notes>
 </file>
 
-<file path=ppt/notesSlides/notesSlide6.xml><?xml version="1.0" encoding="utf-8"?>
+<file path=ppt/notesSlides/notesSlide7.xml><?xml version="1.0" encoding="utf-8"?>
+<p:notes xmlns:a="http://schemas.openxmlformats.org/drawingml/2006/main" xmlns:r="http://schemas.openxmlformats.org/officeDocument/2006/relationships" xmlns:p="http://schemas.openxmlformats.org/presentationml/2006/main">
+  <p:cSld>
+    <p:spTree>
+      <p:nvGrpSpPr>
+        <p:cNvPr id="1" name=""/>
+        <p:cNvGrpSpPr/>
+        <p:nvPr/>
+      </p:nvGrpSpPr>
+      <p:grpSpPr>
+        <a:xfrm>
+          <a:off x="0" y="0"/>
+          <a:ext cx="0" cy="0"/>
+          <a:chOff x="0" y="0"/>
+          <a:chExt cx="0" cy="0"/>
+        </a:xfrm>
+      </p:grpSpPr>
+      <p:sp>
+        <p:nvSpPr>
+          <p:cNvPr id="2" name="Slide Image Placeholder 1"/>
+          <p:cNvSpPr>
+            <a:spLocks noGrp="1" noRot="1" noChangeAspect="1"/>
+          </p:cNvSpPr>
+          <p:nvPr>
+            <p:ph type="sldImg"/>
+          </p:nvPr>
+        </p:nvSpPr>
+        <p:spPr/>
+      </p:sp>
+      <p:sp>
+        <p:nvSpPr>
+          <p:cNvPr id="3" name="Notes Placeholder 2"/>
+          <p:cNvSpPr>
+            <a:spLocks noGrp="1"/>
+          </p:cNvSpPr>
+          <p:nvPr>
+            <p:ph type="body" idx="1"/>
+          </p:nvPr>
+        </p:nvSpPr>
+        <p:spPr/>
+        <p:txBody>
+          <a:bodyPr/>
+          <a:lstStyle/>
+          <a:p>
+            <a:r>
+              <a:rPr lang="en-US" dirty="0"/>
+              <a:t>Log-likelihood: 2 states is the best</a:t>
+            </a:r>
+          </a:p>
+          <a:p>
+            <a:r>
+              <a:rPr lang="en-US" dirty="0"/>
+              <a:t>Predictive accuracy: 5 states is the highest</a:t>
+            </a:r>
+          </a:p>
+          <a:p>
+            <a:endParaRPr lang="en-US" dirty="0"/>
+          </a:p>
+          <a:p>
+            <a:r>
+              <a:rPr lang="en-US" dirty="0"/>
+              <a:t>5 states models are overall over-confident, i.e. higher penalty on incorrect predictions</a:t>
+            </a:r>
+          </a:p>
+          <a:p>
+            <a:endParaRPr lang="en-US" dirty="0"/>
+          </a:p>
+        </p:txBody>
+      </p:sp>
+      <p:sp>
+        <p:nvSpPr>
+          <p:cNvPr id="4" name="Slide Number Placeholder 3"/>
+          <p:cNvSpPr>
+            <a:spLocks noGrp="1"/>
+          </p:cNvSpPr>
+          <p:nvPr>
+            <p:ph type="sldNum" sz="quarter" idx="5"/>
+          </p:nvPr>
+        </p:nvSpPr>
+        <p:spPr/>
+        <p:txBody>
+          <a:bodyPr/>
+          <a:lstStyle/>
+          <a:p>
+            <a:fld id="{F4472248-5027-4A3C-9488-9C593E53F37B}" type="slidenum">
+              <a:rPr lang="en-US" smtClean="0"/>
+              <a:t>11</a:t>
+            </a:fld>
+            <a:endParaRPr lang="en-US"/>
+          </a:p>
+        </p:txBody>
+      </p:sp>
+    </p:spTree>
+    <p:extLst>
+      <p:ext uri="{BB962C8B-B14F-4D97-AF65-F5344CB8AC3E}">
+        <p14:creationId xmlns:p14="http://schemas.microsoft.com/office/powerpoint/2010/main" val="1687827125"/>
+      </p:ext>
+    </p:extLst>
+  </p:cSld>
+  <p:clrMapOvr>
+    <a:masterClrMapping/>
+  </p:clrMapOvr>
+</p:notes>
+</file>
+
+<file path=ppt/notesSlides/notesSlide8.xml><?xml version="1.0" encoding="utf-8"?>
+<p:notes xmlns:a="http://schemas.openxmlformats.org/drawingml/2006/main" xmlns:r="http://schemas.openxmlformats.org/officeDocument/2006/relationships" xmlns:p="http://schemas.openxmlformats.org/presentationml/2006/main">
+  <p:cSld>
+    <p:spTree>
+      <p:nvGrpSpPr>
+        <p:cNvPr id="1" name="">
+          <a:extLst>
+            <a:ext uri="{FF2B5EF4-FFF2-40B4-BE49-F238E27FC236}">
+              <a16:creationId xmlns:a16="http://schemas.microsoft.com/office/drawing/2014/main" id="{1BB676C2-6E7E-86D0-55FA-0FFBAF67A187}"/>
+            </a:ext>
+          </a:extLst>
+        </p:cNvPr>
+        <p:cNvGrpSpPr/>
+        <p:nvPr/>
+      </p:nvGrpSpPr>
+      <p:grpSpPr>
+        <a:xfrm>
+          <a:off x="0" y="0"/>
+          <a:ext cx="0" cy="0"/>
+          <a:chOff x="0" y="0"/>
+          <a:chExt cx="0" cy="0"/>
+        </a:xfrm>
+      </p:grpSpPr>
+      <p:sp>
+        <p:nvSpPr>
+          <p:cNvPr id="2" name="Slide Image Placeholder 1">
+            <a:extLst>
+              <a:ext uri="{FF2B5EF4-FFF2-40B4-BE49-F238E27FC236}">
+                <a16:creationId xmlns:a16="http://schemas.microsoft.com/office/drawing/2014/main" id="{BE510152-3A39-5656-FEE7-6106915C8EC2}"/>
+              </a:ext>
+            </a:extLst>
+          </p:cNvPr>
+          <p:cNvSpPr>
+            <a:spLocks noGrp="1" noRot="1" noChangeAspect="1"/>
+          </p:cNvSpPr>
+          <p:nvPr>
+            <p:ph type="sldImg"/>
+          </p:nvPr>
+        </p:nvSpPr>
+        <p:spPr/>
+      </p:sp>
+      <p:sp>
+        <p:nvSpPr>
+          <p:cNvPr id="3" name="Notes Placeholder 2">
+            <a:extLst>
+              <a:ext uri="{FF2B5EF4-FFF2-40B4-BE49-F238E27FC236}">
+                <a16:creationId xmlns:a16="http://schemas.microsoft.com/office/drawing/2014/main" id="{01D1AC3C-EDA9-B509-CE9F-3304E280EDD4}"/>
+              </a:ext>
+            </a:extLst>
+          </p:cNvPr>
+          <p:cNvSpPr>
+            <a:spLocks noGrp="1"/>
+          </p:cNvSpPr>
+          <p:nvPr>
+            <p:ph type="body" idx="1"/>
+          </p:nvPr>
+        </p:nvSpPr>
+        <p:spPr/>
+        <p:txBody>
+          <a:bodyPr/>
+          <a:lstStyle/>
+          <a:p>
+            <a:r>
+              <a:rPr lang="en-US" dirty="0"/>
+              <a:t>Equal prior only: 1 state</a:t>
+            </a:r>
+          </a:p>
+          <a:p>
+            <a:r>
+              <a:rPr lang="en-US" dirty="0"/>
+              <a:t>Unequal prior only: 2 states</a:t>
+            </a:r>
+          </a:p>
+          <a:p>
+            <a:endParaRPr lang="en-US" dirty="0"/>
+          </a:p>
+        </p:txBody>
+      </p:sp>
+      <p:sp>
+        <p:nvSpPr>
+          <p:cNvPr id="4" name="Slide Number Placeholder 3">
+            <a:extLst>
+              <a:ext uri="{FF2B5EF4-FFF2-40B4-BE49-F238E27FC236}">
+                <a16:creationId xmlns:a16="http://schemas.microsoft.com/office/drawing/2014/main" id="{BE04C810-D811-8AC2-3F11-DE1CEC83C7FC}"/>
+              </a:ext>
+            </a:extLst>
+          </p:cNvPr>
+          <p:cNvSpPr>
+            <a:spLocks noGrp="1"/>
+          </p:cNvSpPr>
+          <p:nvPr>
+            <p:ph type="sldNum" sz="quarter" idx="5"/>
+          </p:nvPr>
+        </p:nvSpPr>
+        <p:spPr/>
+        <p:txBody>
+          <a:bodyPr/>
+          <a:lstStyle/>
+          <a:p>
+            <a:fld id="{F4472248-5027-4A3C-9488-9C593E53F37B}" type="slidenum">
+              <a:rPr lang="en-US" smtClean="0"/>
+              <a:t>12</a:t>
+            </a:fld>
+            <a:endParaRPr lang="en-US"/>
+          </a:p>
+        </p:txBody>
+      </p:sp>
+    </p:spTree>
+    <p:extLst>
+      <p:ext uri="{BB962C8B-B14F-4D97-AF65-F5344CB8AC3E}">
+        <p14:creationId xmlns:p14="http://schemas.microsoft.com/office/powerpoint/2010/main" val="1822858931"/>
+      </p:ext>
+    </p:extLst>
+  </p:cSld>
+  <p:clrMapOvr>
+    <a:masterClrMapping/>
+  </p:clrMapOvr>
+</p:notes>
+</file>
+
+<file path=ppt/notesSlides/notesSlide9.xml><?xml version="1.0" encoding="utf-8"?>
 <p:notes xmlns:a="http://schemas.openxmlformats.org/drawingml/2006/main" xmlns:r="http://schemas.openxmlformats.org/officeDocument/2006/relationships" xmlns:p="http://schemas.openxmlformats.org/presentationml/2006/main">
   <p:cSld>
     <p:spTree>
@@ -1105,7 +1421,7 @@
           <a:p>
             <a:fld id="{F4472248-5027-4A3C-9488-9C593E53F37B}" type="slidenum">
               <a:rPr lang="en-US" smtClean="0"/>
-              <a:t>9</a:t>
+              <a:t>13</a:t>
             </a:fld>
             <a:endParaRPr lang="en-US"/>
           </a:p>
@@ -1271,7 +1587,7 @@
           <a:p>
             <a:fld id="{EBF6AAF7-2BB1-4A84-8C15-D326179851E7}" type="datetimeFigureOut">
               <a:rPr lang="en-US" smtClean="0"/>
-              <a:t>7/24/2025</a:t>
+              <a:t>7/28/2025</a:t>
             </a:fld>
             <a:endParaRPr lang="en-US"/>
           </a:p>
@@ -1469,7 +1785,7 @@
           <a:p>
             <a:fld id="{EBF6AAF7-2BB1-4A84-8C15-D326179851E7}" type="datetimeFigureOut">
               <a:rPr lang="en-US" smtClean="0"/>
-              <a:t>7/24/2025</a:t>
+              <a:t>7/28/2025</a:t>
             </a:fld>
             <a:endParaRPr lang="en-US"/>
           </a:p>
@@ -1677,7 +1993,7 @@
           <a:p>
             <a:fld id="{EBF6AAF7-2BB1-4A84-8C15-D326179851E7}" type="datetimeFigureOut">
               <a:rPr lang="en-US" smtClean="0"/>
-              <a:t>7/24/2025</a:t>
+              <a:t>7/28/2025</a:t>
             </a:fld>
             <a:endParaRPr lang="en-US"/>
           </a:p>
@@ -1875,7 +2191,7 @@
           <a:p>
             <a:fld id="{EBF6AAF7-2BB1-4A84-8C15-D326179851E7}" type="datetimeFigureOut">
               <a:rPr lang="en-US" smtClean="0"/>
-              <a:t>7/24/2025</a:t>
+              <a:t>7/28/2025</a:t>
             </a:fld>
             <a:endParaRPr lang="en-US"/>
           </a:p>
@@ -2150,7 +2466,7 @@
           <a:p>
             <a:fld id="{EBF6AAF7-2BB1-4A84-8C15-D326179851E7}" type="datetimeFigureOut">
               <a:rPr lang="en-US" smtClean="0"/>
-              <a:t>7/24/2025</a:t>
+              <a:t>7/28/2025</a:t>
             </a:fld>
             <a:endParaRPr lang="en-US"/>
           </a:p>
@@ -2415,7 +2731,7 @@
           <a:p>
             <a:fld id="{EBF6AAF7-2BB1-4A84-8C15-D326179851E7}" type="datetimeFigureOut">
               <a:rPr lang="en-US" smtClean="0"/>
-              <a:t>7/24/2025</a:t>
+              <a:t>7/28/2025</a:t>
             </a:fld>
             <a:endParaRPr lang="en-US"/>
           </a:p>
@@ -2827,7 +3143,7 @@
           <a:p>
             <a:fld id="{EBF6AAF7-2BB1-4A84-8C15-D326179851E7}" type="datetimeFigureOut">
               <a:rPr lang="en-US" smtClean="0"/>
-              <a:t>7/24/2025</a:t>
+              <a:t>7/28/2025</a:t>
             </a:fld>
             <a:endParaRPr lang="en-US"/>
           </a:p>
@@ -2968,7 +3284,7 @@
           <a:p>
             <a:fld id="{EBF6AAF7-2BB1-4A84-8C15-D326179851E7}" type="datetimeFigureOut">
               <a:rPr lang="en-US" smtClean="0"/>
-              <a:t>7/24/2025</a:t>
+              <a:t>7/28/2025</a:t>
             </a:fld>
             <a:endParaRPr lang="en-US"/>
           </a:p>
@@ -3081,7 +3397,7 @@
           <a:p>
             <a:fld id="{EBF6AAF7-2BB1-4A84-8C15-D326179851E7}" type="datetimeFigureOut">
               <a:rPr lang="en-US" smtClean="0"/>
-              <a:t>7/24/2025</a:t>
+              <a:t>7/28/2025</a:t>
             </a:fld>
             <a:endParaRPr lang="en-US"/>
           </a:p>
@@ -3392,7 +3708,7 @@
           <a:p>
             <a:fld id="{EBF6AAF7-2BB1-4A84-8C15-D326179851E7}" type="datetimeFigureOut">
               <a:rPr lang="en-US" smtClean="0"/>
-              <a:t>7/24/2025</a:t>
+              <a:t>7/28/2025</a:t>
             </a:fld>
             <a:endParaRPr lang="en-US"/>
           </a:p>
@@ -3680,7 +3996,7 @@
           <a:p>
             <a:fld id="{EBF6AAF7-2BB1-4A84-8C15-D326179851E7}" type="datetimeFigureOut">
               <a:rPr lang="en-US" smtClean="0"/>
-              <a:t>7/24/2025</a:t>
+              <a:t>7/28/2025</a:t>
             </a:fld>
             <a:endParaRPr lang="en-US"/>
           </a:p>
@@ -3921,7 +4237,7 @@
           <a:p>
             <a:fld id="{EBF6AAF7-2BB1-4A84-8C15-D326179851E7}" type="datetimeFigureOut">
               <a:rPr lang="en-US" smtClean="0"/>
-              <a:t>7/24/2025</a:t>
+              <a:t>7/28/2025</a:t>
             </a:fld>
             <a:endParaRPr lang="en-US"/>
           </a:p>
@@ -4386,6 +4702,964 @@
 </p:sld>
 </file>
 
+<file path=ppt/slides/slide10.xml><?xml version="1.0" encoding="utf-8"?>
+<p:sld xmlns:a="http://schemas.openxmlformats.org/drawingml/2006/main" xmlns:r="http://schemas.openxmlformats.org/officeDocument/2006/relationships" xmlns:p="http://schemas.openxmlformats.org/presentationml/2006/main">
+  <p:cSld>
+    <p:spTree>
+      <p:nvGrpSpPr>
+        <p:cNvPr id="1" name=""/>
+        <p:cNvGrpSpPr/>
+        <p:nvPr/>
+      </p:nvGrpSpPr>
+      <p:grpSpPr>
+        <a:xfrm>
+          <a:off x="0" y="0"/>
+          <a:ext cx="0" cy="0"/>
+          <a:chOff x="0" y="0"/>
+          <a:chExt cx="0" cy="0"/>
+        </a:xfrm>
+      </p:grpSpPr>
+      <p:sp>
+        <p:nvSpPr>
+          <p:cNvPr id="2" name="Title 1">
+            <a:extLst>
+              <a:ext uri="{FF2B5EF4-FFF2-40B4-BE49-F238E27FC236}">
+                <a16:creationId xmlns:a16="http://schemas.microsoft.com/office/drawing/2014/main" id="{6499F9B1-CD61-B64C-0D8C-9C2872835C0C}"/>
+              </a:ext>
+            </a:extLst>
+          </p:cNvPr>
+          <p:cNvSpPr>
+            <a:spLocks noGrp="1"/>
+          </p:cNvSpPr>
+          <p:nvPr>
+            <p:ph type="title"/>
+          </p:nvPr>
+        </p:nvSpPr>
+        <p:spPr/>
+        <p:txBody>
+          <a:bodyPr/>
+          <a:lstStyle/>
+          <a:p>
+            <a:r>
+              <a:rPr lang="en-US" dirty="0"/>
+              <a:t>Fig. 2 GLM-HMM</a:t>
+            </a:r>
+          </a:p>
+        </p:txBody>
+      </p:sp>
+      <p:pic>
+        <p:nvPicPr>
+          <p:cNvPr id="8" name="Picture 7">
+            <a:extLst>
+              <a:ext uri="{FF2B5EF4-FFF2-40B4-BE49-F238E27FC236}">
+                <a16:creationId xmlns:a16="http://schemas.microsoft.com/office/drawing/2014/main" id="{5CAADE6A-566F-7AD4-BA81-D5F747017178}"/>
+              </a:ext>
+            </a:extLst>
+          </p:cNvPr>
+          <p:cNvPicPr>
+            <a:picLocks noChangeAspect="1"/>
+          </p:cNvPicPr>
+          <p:nvPr/>
+        </p:nvPicPr>
+        <p:blipFill>
+          <a:blip r:embed="rId3">
+            <a:extLst>
+              <a:ext uri="{28A0092B-C50C-407E-A947-70E740481C1C}">
+                <a14:useLocalDpi xmlns:a14="http://schemas.microsoft.com/office/drawing/2010/main" val="0"/>
+              </a:ext>
+            </a:extLst>
+          </a:blip>
+          <a:srcRect/>
+          <a:stretch/>
+        </p:blipFill>
+        <p:spPr>
+          <a:xfrm>
+            <a:off x="8432128" y="2466518"/>
+            <a:ext cx="3628723" cy="2812758"/>
+          </a:xfrm>
+          <a:prstGeom prst="rect">
+            <a:avLst/>
+          </a:prstGeom>
+        </p:spPr>
+      </p:pic>
+      <p:grpSp>
+        <p:nvGrpSpPr>
+          <p:cNvPr id="3" name="Group 2">
+            <a:extLst>
+              <a:ext uri="{FF2B5EF4-FFF2-40B4-BE49-F238E27FC236}">
+                <a16:creationId xmlns:a16="http://schemas.microsoft.com/office/drawing/2014/main" id="{EDC456D4-29BD-B94E-9175-4361FD929B8B}"/>
+              </a:ext>
+            </a:extLst>
+          </p:cNvPr>
+          <p:cNvGrpSpPr/>
+          <p:nvPr/>
+        </p:nvGrpSpPr>
+        <p:grpSpPr>
+          <a:xfrm>
+            <a:off x="708361" y="2348183"/>
+            <a:ext cx="3702125" cy="2833547"/>
+            <a:chOff x="719119" y="2466518"/>
+            <a:chExt cx="3589503" cy="2743200"/>
+          </a:xfrm>
+        </p:grpSpPr>
+        <p:pic>
+          <p:nvPicPr>
+            <p:cNvPr id="10" name="Picture 9">
+              <a:extLst>
+                <a:ext uri="{FF2B5EF4-FFF2-40B4-BE49-F238E27FC236}">
+                  <a16:creationId xmlns:a16="http://schemas.microsoft.com/office/drawing/2014/main" id="{AE51462A-E301-AFE2-67CF-F12D27F77BF2}"/>
+                </a:ext>
+              </a:extLst>
+            </p:cNvPr>
+            <p:cNvPicPr>
+              <a:picLocks noChangeAspect="1"/>
+            </p:cNvPicPr>
+            <p:nvPr/>
+          </p:nvPicPr>
+          <p:blipFill>
+            <a:blip r:embed="rId4">
+              <a:extLst>
+                <a:ext uri="{28A0092B-C50C-407E-A947-70E740481C1C}">
+                  <a14:useLocalDpi xmlns:a14="http://schemas.microsoft.com/office/drawing/2010/main" val="0"/>
+                </a:ext>
+              </a:extLst>
+            </a:blip>
+            <a:srcRect/>
+            <a:stretch/>
+          </p:blipFill>
+          <p:spPr>
+            <a:xfrm>
+              <a:off x="719119" y="2534873"/>
+              <a:ext cx="3589503" cy="2674845"/>
+            </a:xfrm>
+            <a:prstGeom prst="rect">
+              <a:avLst/>
+            </a:prstGeom>
+          </p:spPr>
+        </p:pic>
+        <p:sp>
+          <p:nvSpPr>
+            <p:cNvPr id="11" name="Rectangle: Rounded Corners 10">
+              <a:extLst>
+                <a:ext uri="{FF2B5EF4-FFF2-40B4-BE49-F238E27FC236}">
+                  <a16:creationId xmlns:a16="http://schemas.microsoft.com/office/drawing/2014/main" id="{E4117C3B-20F6-17B8-21C5-1E5DA8189EBE}"/>
+                </a:ext>
+              </a:extLst>
+            </p:cNvPr>
+            <p:cNvSpPr/>
+            <p:nvPr/>
+          </p:nvSpPr>
+          <p:spPr>
+            <a:xfrm>
+              <a:off x="1742565" y="2466518"/>
+              <a:ext cx="500063" cy="460254"/>
+            </a:xfrm>
+            <a:prstGeom prst="roundRect">
+              <a:avLst/>
+            </a:prstGeom>
+            <a:noFill/>
+            <a:ln w="38100">
+              <a:solidFill>
+                <a:schemeClr val="bg2">
+                  <a:lumMod val="25000"/>
+                </a:schemeClr>
+              </a:solidFill>
+            </a:ln>
+          </p:spPr>
+          <p:style>
+            <a:lnRef idx="2">
+              <a:schemeClr val="accent1">
+                <a:shade val="15000"/>
+              </a:schemeClr>
+            </a:lnRef>
+            <a:fillRef idx="1">
+              <a:schemeClr val="accent1"/>
+            </a:fillRef>
+            <a:effectRef idx="0">
+              <a:schemeClr val="accent1"/>
+            </a:effectRef>
+            <a:fontRef idx="minor">
+              <a:schemeClr val="lt1"/>
+            </a:fontRef>
+          </p:style>
+          <p:txBody>
+            <a:bodyPr rtlCol="0" anchor="ctr"/>
+            <a:lstStyle/>
+            <a:p>
+              <a:pPr algn="ctr"/>
+              <a:endParaRPr lang="en-US"/>
+            </a:p>
+          </p:txBody>
+        </p:sp>
+      </p:grpSp>
+      <p:pic>
+        <p:nvPicPr>
+          <p:cNvPr id="14" name="Picture 13">
+            <a:extLst>
+              <a:ext uri="{FF2B5EF4-FFF2-40B4-BE49-F238E27FC236}">
+                <a16:creationId xmlns:a16="http://schemas.microsoft.com/office/drawing/2014/main" id="{B3A8FA4A-C80B-23AE-0E2F-F7767C4831AC}"/>
+              </a:ext>
+            </a:extLst>
+          </p:cNvPr>
+          <p:cNvPicPr>
+            <a:picLocks noChangeAspect="1"/>
+          </p:cNvPicPr>
+          <p:nvPr/>
+        </p:nvPicPr>
+        <p:blipFill>
+          <a:blip r:embed="rId5">
+            <a:extLst>
+              <a:ext uri="{28A0092B-C50C-407E-A947-70E740481C1C}">
+                <a14:useLocalDpi xmlns:a14="http://schemas.microsoft.com/office/drawing/2010/main" val="0"/>
+              </a:ext>
+            </a:extLst>
+          </a:blip>
+          <a:srcRect/>
+          <a:stretch/>
+        </p:blipFill>
+        <p:spPr>
+          <a:xfrm>
+            <a:off x="4463997" y="2455522"/>
+            <a:ext cx="3914620" cy="2833547"/>
+          </a:xfrm>
+          <a:prstGeom prst="rect">
+            <a:avLst/>
+          </a:prstGeom>
+        </p:spPr>
+      </p:pic>
+    </p:spTree>
+    <p:extLst>
+      <p:ext uri="{BB962C8B-B14F-4D97-AF65-F5344CB8AC3E}">
+        <p14:creationId xmlns:p14="http://schemas.microsoft.com/office/powerpoint/2010/main" val="4016668503"/>
+      </p:ext>
+    </p:extLst>
+  </p:cSld>
+  <p:clrMapOvr>
+    <a:masterClrMapping/>
+  </p:clrMapOvr>
+</p:sld>
+</file>
+
+<file path=ppt/slides/slide11.xml><?xml version="1.0" encoding="utf-8"?>
+<p:sld xmlns:a="http://schemas.openxmlformats.org/drawingml/2006/main" xmlns:r="http://schemas.openxmlformats.org/officeDocument/2006/relationships" xmlns:p="http://schemas.openxmlformats.org/presentationml/2006/main">
+  <p:cSld>
+    <p:spTree>
+      <p:nvGrpSpPr>
+        <p:cNvPr id="1" name="">
+          <a:extLst>
+            <a:ext uri="{FF2B5EF4-FFF2-40B4-BE49-F238E27FC236}">
+              <a16:creationId xmlns:a16="http://schemas.microsoft.com/office/drawing/2014/main" id="{3112AA24-BDA2-79B6-4683-6DF63DC1DBAA}"/>
+            </a:ext>
+          </a:extLst>
+        </p:cNvPr>
+        <p:cNvGrpSpPr/>
+        <p:nvPr/>
+      </p:nvGrpSpPr>
+      <p:grpSpPr>
+        <a:xfrm>
+          <a:off x="0" y="0"/>
+          <a:ext cx="0" cy="0"/>
+          <a:chOff x="0" y="0"/>
+          <a:chExt cx="0" cy="0"/>
+        </a:xfrm>
+      </p:grpSpPr>
+      <p:pic>
+        <p:nvPicPr>
+          <p:cNvPr id="11" name="Picture 10">
+            <a:extLst>
+              <a:ext uri="{FF2B5EF4-FFF2-40B4-BE49-F238E27FC236}">
+                <a16:creationId xmlns:a16="http://schemas.microsoft.com/office/drawing/2014/main" id="{3B60A0AB-3D04-1AE0-49FC-48FD416A0371}"/>
+              </a:ext>
+            </a:extLst>
+          </p:cNvPr>
+          <p:cNvPicPr>
+            <a:picLocks noChangeAspect="1"/>
+          </p:cNvPicPr>
+          <p:nvPr/>
+        </p:nvPicPr>
+        <p:blipFill>
+          <a:blip r:embed="rId3">
+            <a:extLst>
+              <a:ext uri="{28A0092B-C50C-407E-A947-70E740481C1C}">
+                <a14:useLocalDpi xmlns:a14="http://schemas.microsoft.com/office/drawing/2010/main" val="0"/>
+              </a:ext>
+            </a:extLst>
+          </a:blip>
+          <a:srcRect/>
+          <a:stretch/>
+        </p:blipFill>
+        <p:spPr>
+          <a:xfrm>
+            <a:off x="7494549" y="0"/>
+            <a:ext cx="4114800" cy="3593939"/>
+          </a:xfrm>
+          <a:prstGeom prst="rect">
+            <a:avLst/>
+          </a:prstGeom>
+        </p:spPr>
+      </p:pic>
+      <p:pic>
+        <p:nvPicPr>
+          <p:cNvPr id="4" name="Picture 3">
+            <a:extLst>
+              <a:ext uri="{FF2B5EF4-FFF2-40B4-BE49-F238E27FC236}">
+                <a16:creationId xmlns:a16="http://schemas.microsoft.com/office/drawing/2014/main" id="{03E24DCD-D397-183C-C7A5-3AC58BFDAAEE}"/>
+              </a:ext>
+            </a:extLst>
+          </p:cNvPr>
+          <p:cNvPicPr>
+            <a:picLocks noChangeAspect="1"/>
+          </p:cNvPicPr>
+          <p:nvPr/>
+        </p:nvPicPr>
+        <p:blipFill>
+          <a:blip r:embed="rId4">
+            <a:extLst>
+              <a:ext uri="{28A0092B-C50C-407E-A947-70E740481C1C}">
+                <a14:useLocalDpi xmlns:a14="http://schemas.microsoft.com/office/drawing/2010/main" val="0"/>
+              </a:ext>
+            </a:extLst>
+          </a:blip>
+          <a:srcRect/>
+          <a:stretch/>
+        </p:blipFill>
+        <p:spPr>
+          <a:xfrm>
+            <a:off x="3088368" y="361130"/>
+            <a:ext cx="4114800" cy="3067870"/>
+          </a:xfrm>
+          <a:prstGeom prst="rect">
+            <a:avLst/>
+          </a:prstGeom>
+        </p:spPr>
+      </p:pic>
+      <p:pic>
+        <p:nvPicPr>
+          <p:cNvPr id="6" name="Picture 5">
+            <a:extLst>
+              <a:ext uri="{FF2B5EF4-FFF2-40B4-BE49-F238E27FC236}">
+                <a16:creationId xmlns:a16="http://schemas.microsoft.com/office/drawing/2014/main" id="{55668DA3-F20A-DC0F-3F34-EEFA322FF58F}"/>
+              </a:ext>
+            </a:extLst>
+          </p:cNvPr>
+          <p:cNvPicPr>
+            <a:picLocks noChangeAspect="1"/>
+          </p:cNvPicPr>
+          <p:nvPr/>
+        </p:nvPicPr>
+        <p:blipFill>
+          <a:blip r:embed="rId5">
+            <a:extLst>
+              <a:ext uri="{28A0092B-C50C-407E-A947-70E740481C1C}">
+                <a14:useLocalDpi xmlns:a14="http://schemas.microsoft.com/office/drawing/2010/main" val="0"/>
+              </a:ext>
+            </a:extLst>
+          </a:blip>
+          <a:srcRect/>
+          <a:stretch/>
+        </p:blipFill>
+        <p:spPr>
+          <a:xfrm>
+            <a:off x="842346" y="3664404"/>
+            <a:ext cx="3806397" cy="3053315"/>
+          </a:xfrm>
+          <a:prstGeom prst="rect">
+            <a:avLst/>
+          </a:prstGeom>
+        </p:spPr>
+      </p:pic>
+      <p:pic>
+        <p:nvPicPr>
+          <p:cNvPr id="3" name="Picture 2">
+            <a:extLst>
+              <a:ext uri="{FF2B5EF4-FFF2-40B4-BE49-F238E27FC236}">
+                <a16:creationId xmlns:a16="http://schemas.microsoft.com/office/drawing/2014/main" id="{A84EB53D-5A5F-73C3-5F80-A871BFA59618}"/>
+              </a:ext>
+            </a:extLst>
+          </p:cNvPr>
+          <p:cNvPicPr>
+            <a:picLocks noChangeAspect="1"/>
+          </p:cNvPicPr>
+          <p:nvPr/>
+        </p:nvPicPr>
+        <p:blipFill>
+          <a:blip r:embed="rId6">
+            <a:extLst>
+              <a:ext uri="{28A0092B-C50C-407E-A947-70E740481C1C}">
+                <a14:useLocalDpi xmlns:a14="http://schemas.microsoft.com/office/drawing/2010/main" val="0"/>
+              </a:ext>
+            </a:extLst>
+          </a:blip>
+          <a:srcRect/>
+          <a:stretch/>
+        </p:blipFill>
+        <p:spPr>
+          <a:xfrm>
+            <a:off x="5022980" y="3737827"/>
+            <a:ext cx="6430522" cy="2979892"/>
+          </a:xfrm>
+          <a:prstGeom prst="rect">
+            <a:avLst/>
+          </a:prstGeom>
+        </p:spPr>
+      </p:pic>
+      <p:sp>
+        <p:nvSpPr>
+          <p:cNvPr id="12" name="Title 1">
+            <a:extLst>
+              <a:ext uri="{FF2B5EF4-FFF2-40B4-BE49-F238E27FC236}">
+                <a16:creationId xmlns:a16="http://schemas.microsoft.com/office/drawing/2014/main" id="{4FF93408-74AE-B4CF-ED9A-53020C00A53F}"/>
+              </a:ext>
+            </a:extLst>
+          </p:cNvPr>
+          <p:cNvSpPr>
+            <a:spLocks noGrp="1"/>
+          </p:cNvSpPr>
+          <p:nvPr>
+            <p:ph type="title"/>
+          </p:nvPr>
+        </p:nvSpPr>
+        <p:spPr>
+          <a:xfrm>
+            <a:off x="257287" y="140281"/>
+            <a:ext cx="2539701" cy="1325563"/>
+          </a:xfrm>
+        </p:spPr>
+        <p:txBody>
+          <a:bodyPr>
+            <a:noAutofit/>
+          </a:bodyPr>
+          <a:lstStyle/>
+          <a:p>
+            <a:r>
+              <a:rPr lang="en-US" sz="3200" dirty="0"/>
+              <a:t>Supp Fig. 2 GLM-HMM</a:t>
+            </a:r>
+            <a:br>
+              <a:rPr lang="en-US" sz="3200" dirty="0"/>
+            </a:br>
+            <a:r>
+              <a:rPr lang="en-US" sz="3200" dirty="0"/>
+              <a:t>whole session</a:t>
+            </a:r>
+          </a:p>
+        </p:txBody>
+      </p:sp>
+    </p:spTree>
+    <p:extLst>
+      <p:ext uri="{BB962C8B-B14F-4D97-AF65-F5344CB8AC3E}">
+        <p14:creationId xmlns:p14="http://schemas.microsoft.com/office/powerpoint/2010/main" val="2768749306"/>
+      </p:ext>
+    </p:extLst>
+  </p:cSld>
+  <p:clrMapOvr>
+    <a:masterClrMapping/>
+  </p:clrMapOvr>
+</p:sld>
+</file>
+
+<file path=ppt/slides/slide12.xml><?xml version="1.0" encoding="utf-8"?>
+<p:sld xmlns:a="http://schemas.openxmlformats.org/drawingml/2006/main" xmlns:r="http://schemas.openxmlformats.org/officeDocument/2006/relationships" xmlns:p="http://schemas.openxmlformats.org/presentationml/2006/main">
+  <p:cSld>
+    <p:spTree>
+      <p:nvGrpSpPr>
+        <p:cNvPr id="1" name="">
+          <a:extLst>
+            <a:ext uri="{FF2B5EF4-FFF2-40B4-BE49-F238E27FC236}">
+              <a16:creationId xmlns:a16="http://schemas.microsoft.com/office/drawing/2014/main" id="{F7765E3D-81DC-9F10-E44F-9CBD06DE7C0A}"/>
+            </a:ext>
+          </a:extLst>
+        </p:cNvPr>
+        <p:cNvGrpSpPr/>
+        <p:nvPr/>
+      </p:nvGrpSpPr>
+      <p:grpSpPr>
+        <a:xfrm>
+          <a:off x="0" y="0"/>
+          <a:ext cx="0" cy="0"/>
+          <a:chOff x="0" y="0"/>
+          <a:chExt cx="0" cy="0"/>
+        </a:xfrm>
+      </p:grpSpPr>
+      <p:sp>
+        <p:nvSpPr>
+          <p:cNvPr id="12" name="Title 1">
+            <a:extLst>
+              <a:ext uri="{FF2B5EF4-FFF2-40B4-BE49-F238E27FC236}">
+                <a16:creationId xmlns:a16="http://schemas.microsoft.com/office/drawing/2014/main" id="{1869E87C-389F-F8F6-A656-0CD9377D3E30}"/>
+              </a:ext>
+            </a:extLst>
+          </p:cNvPr>
+          <p:cNvSpPr>
+            <a:spLocks noGrp="1"/>
+          </p:cNvSpPr>
+          <p:nvPr>
+            <p:ph type="title"/>
+          </p:nvPr>
+        </p:nvSpPr>
+        <p:spPr>
+          <a:xfrm>
+            <a:off x="344341" y="-558966"/>
+            <a:ext cx="5838713" cy="2140340"/>
+          </a:xfrm>
+        </p:spPr>
+        <p:txBody>
+          <a:bodyPr>
+            <a:noAutofit/>
+          </a:bodyPr>
+          <a:lstStyle/>
+          <a:p>
+            <a:r>
+              <a:rPr lang="en-US" sz="3600" dirty="0"/>
+              <a:t>Supp Fig. 2 </a:t>
+            </a:r>
+          </a:p>
+        </p:txBody>
+      </p:sp>
+      <p:sp>
+        <p:nvSpPr>
+          <p:cNvPr id="2" name="Title 1">
+            <a:extLst>
+              <a:ext uri="{FF2B5EF4-FFF2-40B4-BE49-F238E27FC236}">
+                <a16:creationId xmlns:a16="http://schemas.microsoft.com/office/drawing/2014/main" id="{B85E3E4D-21B1-7928-D422-C37362A1C37B}"/>
+              </a:ext>
+            </a:extLst>
+          </p:cNvPr>
+          <p:cNvSpPr txBox="1">
+            <a:spLocks/>
+          </p:cNvSpPr>
+          <p:nvPr/>
+        </p:nvSpPr>
+        <p:spPr>
+          <a:xfrm>
+            <a:off x="570251" y="867080"/>
+            <a:ext cx="2905461" cy="2140340"/>
+          </a:xfrm>
+          <a:prstGeom prst="rect">
+            <a:avLst/>
+          </a:prstGeom>
+        </p:spPr>
+        <p:txBody>
+          <a:bodyPr vert="horz" lIns="91440" tIns="45720" rIns="91440" bIns="45720" rtlCol="0" anchor="ctr">
+            <a:noAutofit/>
+          </a:bodyPr>
+          <a:lstStyle>
+            <a:lvl1pPr algn="l" defTabSz="914400" rtl="0" eaLnBrk="1" latinLnBrk="0" hangingPunct="1">
+              <a:lnSpc>
+                <a:spcPct val="90000"/>
+              </a:lnSpc>
+              <a:spcBef>
+                <a:spcPct val="0"/>
+              </a:spcBef>
+              <a:buNone/>
+              <a:defRPr sz="4400" kern="1200">
+                <a:solidFill>
+                  <a:schemeClr val="tx1"/>
+                </a:solidFill>
+                <a:latin typeface="+mj-lt"/>
+                <a:ea typeface="+mj-ea"/>
+                <a:cs typeface="+mj-cs"/>
+              </a:defRPr>
+            </a:lvl1pPr>
+          </a:lstStyle>
+          <a:p>
+            <a:r>
+              <a:rPr lang="en-US" sz="3200" dirty="0"/>
+              <a:t>GLM-HMM</a:t>
+            </a:r>
+            <a:br>
+              <a:rPr lang="en-US" sz="3200" dirty="0"/>
+            </a:br>
+            <a:r>
+              <a:rPr lang="en-US" sz="3200" dirty="0"/>
+              <a:t>equal prior only</a:t>
+            </a:r>
+          </a:p>
+        </p:txBody>
+      </p:sp>
+      <p:pic>
+        <p:nvPicPr>
+          <p:cNvPr id="5" name="Picture 4">
+            <a:extLst>
+              <a:ext uri="{FF2B5EF4-FFF2-40B4-BE49-F238E27FC236}">
+                <a16:creationId xmlns:a16="http://schemas.microsoft.com/office/drawing/2014/main" id="{3ADF7C25-AC53-6E66-0AB8-122D3F0C9678}"/>
+              </a:ext>
+            </a:extLst>
+          </p:cNvPr>
+          <p:cNvPicPr>
+            <a:picLocks noChangeAspect="1"/>
+          </p:cNvPicPr>
+          <p:nvPr/>
+        </p:nvPicPr>
+        <p:blipFill>
+          <a:blip r:embed="rId3">
+            <a:extLst>
+              <a:ext uri="{28A0092B-C50C-407E-A947-70E740481C1C}">
+                <a14:useLocalDpi xmlns:a14="http://schemas.microsoft.com/office/drawing/2010/main" val="0"/>
+              </a:ext>
+            </a:extLst>
+          </a:blip>
+          <a:srcRect/>
+          <a:stretch/>
+        </p:blipFill>
+        <p:spPr>
+          <a:xfrm>
+            <a:off x="7816428" y="3381962"/>
+            <a:ext cx="3474824" cy="3034972"/>
+          </a:xfrm>
+          <a:prstGeom prst="rect">
+            <a:avLst/>
+          </a:prstGeom>
+        </p:spPr>
+      </p:pic>
+      <p:pic>
+        <p:nvPicPr>
+          <p:cNvPr id="7" name="Picture 6">
+            <a:extLst>
+              <a:ext uri="{FF2B5EF4-FFF2-40B4-BE49-F238E27FC236}">
+                <a16:creationId xmlns:a16="http://schemas.microsoft.com/office/drawing/2014/main" id="{CC52E691-BEDF-819A-E9E0-CF1664103B5D}"/>
+              </a:ext>
+            </a:extLst>
+          </p:cNvPr>
+          <p:cNvPicPr>
+            <a:picLocks noChangeAspect="1"/>
+          </p:cNvPicPr>
+          <p:nvPr/>
+        </p:nvPicPr>
+        <p:blipFill>
+          <a:blip r:embed="rId4">
+            <a:extLst>
+              <a:ext uri="{28A0092B-C50C-407E-A947-70E740481C1C}">
+                <a14:useLocalDpi xmlns:a14="http://schemas.microsoft.com/office/drawing/2010/main" val="0"/>
+              </a:ext>
+            </a:extLst>
+          </a:blip>
+          <a:srcRect/>
+          <a:stretch/>
+        </p:blipFill>
+        <p:spPr>
+          <a:xfrm>
+            <a:off x="3713375" y="3604086"/>
+            <a:ext cx="3468935" cy="2590723"/>
+          </a:xfrm>
+          <a:prstGeom prst="rect">
+            <a:avLst/>
+          </a:prstGeom>
+        </p:spPr>
+      </p:pic>
+      <p:pic>
+        <p:nvPicPr>
+          <p:cNvPr id="8" name="Picture 7">
+            <a:extLst>
+              <a:ext uri="{FF2B5EF4-FFF2-40B4-BE49-F238E27FC236}">
+                <a16:creationId xmlns:a16="http://schemas.microsoft.com/office/drawing/2014/main" id="{FF9874D7-B540-5705-C79C-580FD896580A}"/>
+              </a:ext>
+            </a:extLst>
+          </p:cNvPr>
+          <p:cNvPicPr>
+            <a:picLocks noChangeAspect="1"/>
+          </p:cNvPicPr>
+          <p:nvPr/>
+        </p:nvPicPr>
+        <p:blipFill>
+          <a:blip r:embed="rId5">
+            <a:extLst>
+              <a:ext uri="{28A0092B-C50C-407E-A947-70E740481C1C}">
+                <a14:useLocalDpi xmlns:a14="http://schemas.microsoft.com/office/drawing/2010/main" val="0"/>
+              </a:ext>
+            </a:extLst>
+          </a:blip>
+          <a:srcRect/>
+          <a:stretch/>
+        </p:blipFill>
+        <p:spPr>
+          <a:xfrm>
+            <a:off x="7816428" y="204396"/>
+            <a:ext cx="3474824" cy="3034973"/>
+          </a:xfrm>
+          <a:prstGeom prst="rect">
+            <a:avLst/>
+          </a:prstGeom>
+        </p:spPr>
+      </p:pic>
+      <p:pic>
+        <p:nvPicPr>
+          <p:cNvPr id="9" name="Picture 8">
+            <a:extLst>
+              <a:ext uri="{FF2B5EF4-FFF2-40B4-BE49-F238E27FC236}">
+                <a16:creationId xmlns:a16="http://schemas.microsoft.com/office/drawing/2014/main" id="{102A8F92-3957-CAD7-4485-3A965F95E5E3}"/>
+              </a:ext>
+            </a:extLst>
+          </p:cNvPr>
+          <p:cNvPicPr>
+            <a:picLocks noChangeAspect="1"/>
+          </p:cNvPicPr>
+          <p:nvPr/>
+        </p:nvPicPr>
+        <p:blipFill>
+          <a:blip r:embed="rId6">
+            <a:extLst>
+              <a:ext uri="{28A0092B-C50C-407E-A947-70E740481C1C}">
+                <a14:useLocalDpi xmlns:a14="http://schemas.microsoft.com/office/drawing/2010/main" val="0"/>
+              </a:ext>
+            </a:extLst>
+          </a:blip>
+          <a:srcRect/>
+          <a:stretch/>
+        </p:blipFill>
+        <p:spPr>
+          <a:xfrm>
+            <a:off x="3713375" y="416696"/>
+            <a:ext cx="3468935" cy="2590724"/>
+          </a:xfrm>
+          <a:prstGeom prst="rect">
+            <a:avLst/>
+          </a:prstGeom>
+        </p:spPr>
+      </p:pic>
+      <p:sp>
+        <p:nvSpPr>
+          <p:cNvPr id="10" name="Title 1">
+            <a:extLst>
+              <a:ext uri="{FF2B5EF4-FFF2-40B4-BE49-F238E27FC236}">
+                <a16:creationId xmlns:a16="http://schemas.microsoft.com/office/drawing/2014/main" id="{11C3F377-CDC9-345C-05B6-10E55B202F9D}"/>
+              </a:ext>
+            </a:extLst>
+          </p:cNvPr>
+          <p:cNvSpPr txBox="1">
+            <a:spLocks/>
+          </p:cNvSpPr>
+          <p:nvPr/>
+        </p:nvSpPr>
+        <p:spPr>
+          <a:xfrm>
+            <a:off x="193734" y="3418717"/>
+            <a:ext cx="3131371" cy="2140340"/>
+          </a:xfrm>
+          <a:prstGeom prst="rect">
+            <a:avLst/>
+          </a:prstGeom>
+        </p:spPr>
+        <p:txBody>
+          <a:bodyPr vert="horz" lIns="91440" tIns="45720" rIns="91440" bIns="45720" rtlCol="0" anchor="ctr">
+            <a:noAutofit/>
+          </a:bodyPr>
+          <a:lstStyle>
+            <a:lvl1pPr algn="l" defTabSz="914400" rtl="0" eaLnBrk="1" latinLnBrk="0" hangingPunct="1">
+              <a:lnSpc>
+                <a:spcPct val="90000"/>
+              </a:lnSpc>
+              <a:spcBef>
+                <a:spcPct val="0"/>
+              </a:spcBef>
+              <a:buNone/>
+              <a:defRPr sz="4400" kern="1200">
+                <a:solidFill>
+                  <a:schemeClr val="tx1"/>
+                </a:solidFill>
+                <a:latin typeface="+mj-lt"/>
+                <a:ea typeface="+mj-ea"/>
+                <a:cs typeface="+mj-cs"/>
+              </a:defRPr>
+            </a:lvl1pPr>
+          </a:lstStyle>
+          <a:p>
+            <a:r>
+              <a:rPr lang="en-US" sz="3200" dirty="0"/>
+              <a:t>GLM-HMM</a:t>
+            </a:r>
+            <a:br>
+              <a:rPr lang="en-US" sz="3200" dirty="0"/>
+            </a:br>
+            <a:r>
+              <a:rPr lang="en-US" sz="3200" dirty="0"/>
+              <a:t>unequal prior only</a:t>
+            </a:r>
+          </a:p>
+        </p:txBody>
+      </p:sp>
+    </p:spTree>
+    <p:extLst>
+      <p:ext uri="{BB962C8B-B14F-4D97-AF65-F5344CB8AC3E}">
+        <p14:creationId xmlns:p14="http://schemas.microsoft.com/office/powerpoint/2010/main" val="2251712148"/>
+      </p:ext>
+    </p:extLst>
+  </p:cSld>
+  <p:clrMapOvr>
+    <a:masterClrMapping/>
+  </p:clrMapOvr>
+</p:sld>
+</file>
+
+<file path=ppt/slides/slide13.xml><?xml version="1.0" encoding="utf-8"?>
+<p:sld xmlns:a="http://schemas.openxmlformats.org/drawingml/2006/main" xmlns:r="http://schemas.openxmlformats.org/officeDocument/2006/relationships" xmlns:p="http://schemas.openxmlformats.org/presentationml/2006/main">
+  <p:cSld>
+    <p:spTree>
+      <p:nvGrpSpPr>
+        <p:cNvPr id="1" name="">
+          <a:extLst>
+            <a:ext uri="{FF2B5EF4-FFF2-40B4-BE49-F238E27FC236}">
+              <a16:creationId xmlns:a16="http://schemas.microsoft.com/office/drawing/2014/main" id="{F4C53FD2-27AD-A3BE-C751-9A2816FCE964}"/>
+            </a:ext>
+          </a:extLst>
+        </p:cNvPr>
+        <p:cNvGrpSpPr/>
+        <p:nvPr/>
+      </p:nvGrpSpPr>
+      <p:grpSpPr>
+        <a:xfrm>
+          <a:off x="0" y="0"/>
+          <a:ext cx="0" cy="0"/>
+          <a:chOff x="0" y="0"/>
+          <a:chExt cx="0" cy="0"/>
+        </a:xfrm>
+      </p:grpSpPr>
+      <p:sp>
+        <p:nvSpPr>
+          <p:cNvPr id="2" name="Title 1">
+            <a:extLst>
+              <a:ext uri="{FF2B5EF4-FFF2-40B4-BE49-F238E27FC236}">
+                <a16:creationId xmlns:a16="http://schemas.microsoft.com/office/drawing/2014/main" id="{3F0C3732-2260-2FDB-ED81-D21A6694C20F}"/>
+              </a:ext>
+            </a:extLst>
+          </p:cNvPr>
+          <p:cNvSpPr>
+            <a:spLocks noGrp="1"/>
+          </p:cNvSpPr>
+          <p:nvPr>
+            <p:ph type="title"/>
+          </p:nvPr>
+        </p:nvSpPr>
+        <p:spPr/>
+        <p:txBody>
+          <a:bodyPr/>
+          <a:lstStyle/>
+          <a:p>
+            <a:r>
+              <a:rPr lang="en-US" dirty="0"/>
+              <a:t>Fig. 2 GLM-HMM</a:t>
+            </a:r>
+          </a:p>
+        </p:txBody>
+      </p:sp>
+      <p:pic>
+        <p:nvPicPr>
+          <p:cNvPr id="4" name="Picture 3">
+            <a:extLst>
+              <a:ext uri="{FF2B5EF4-FFF2-40B4-BE49-F238E27FC236}">
+                <a16:creationId xmlns:a16="http://schemas.microsoft.com/office/drawing/2014/main" id="{4E00EB9A-D238-A7ED-4120-25D05347ED23}"/>
+              </a:ext>
+            </a:extLst>
+          </p:cNvPr>
+          <p:cNvPicPr>
+            <a:picLocks noChangeAspect="1"/>
+          </p:cNvPicPr>
+          <p:nvPr/>
+        </p:nvPicPr>
+        <p:blipFill>
+          <a:blip r:embed="rId3">
+            <a:extLst>
+              <a:ext uri="{28A0092B-C50C-407E-A947-70E740481C1C}">
+                <a14:useLocalDpi xmlns:a14="http://schemas.microsoft.com/office/drawing/2010/main" val="0"/>
+              </a:ext>
+            </a:extLst>
+          </a:blip>
+          <a:srcRect/>
+          <a:stretch/>
+        </p:blipFill>
+        <p:spPr>
+          <a:xfrm>
+            <a:off x="360222" y="2224610"/>
+            <a:ext cx="3440253" cy="2646100"/>
+          </a:xfrm>
+          <a:prstGeom prst="rect">
+            <a:avLst/>
+          </a:prstGeom>
+        </p:spPr>
+      </p:pic>
+      <p:pic>
+        <p:nvPicPr>
+          <p:cNvPr id="6" name="Picture 5">
+            <a:extLst>
+              <a:ext uri="{FF2B5EF4-FFF2-40B4-BE49-F238E27FC236}">
+                <a16:creationId xmlns:a16="http://schemas.microsoft.com/office/drawing/2014/main" id="{F9CD0EC9-4815-1EF8-CD2C-F11D39C61A86}"/>
+              </a:ext>
+            </a:extLst>
+          </p:cNvPr>
+          <p:cNvPicPr>
+            <a:picLocks noChangeAspect="1"/>
+          </p:cNvPicPr>
+          <p:nvPr/>
+        </p:nvPicPr>
+        <p:blipFill>
+          <a:blip r:embed="rId4">
+            <a:extLst>
+              <a:ext uri="{28A0092B-C50C-407E-A947-70E740481C1C}">
+                <a14:useLocalDpi xmlns:a14="http://schemas.microsoft.com/office/drawing/2010/main" val="0"/>
+              </a:ext>
+            </a:extLst>
+          </a:blip>
+          <a:srcRect/>
+          <a:stretch/>
+        </p:blipFill>
+        <p:spPr>
+          <a:xfrm>
+            <a:off x="3853871" y="2422684"/>
+            <a:ext cx="4708029" cy="2568938"/>
+          </a:xfrm>
+          <a:prstGeom prst="rect">
+            <a:avLst/>
+          </a:prstGeom>
+        </p:spPr>
+      </p:pic>
+      <p:pic>
+        <p:nvPicPr>
+          <p:cNvPr id="13" name="Picture 12">
+            <a:extLst>
+              <a:ext uri="{FF2B5EF4-FFF2-40B4-BE49-F238E27FC236}">
+                <a16:creationId xmlns:a16="http://schemas.microsoft.com/office/drawing/2014/main" id="{81FE5B99-AA29-CF74-F974-43740AB0D1C9}"/>
+              </a:ext>
+            </a:extLst>
+          </p:cNvPr>
+          <p:cNvPicPr>
+            <a:picLocks noChangeAspect="1"/>
+          </p:cNvPicPr>
+          <p:nvPr/>
+        </p:nvPicPr>
+        <p:blipFill>
+          <a:blip r:embed="rId5">
+            <a:extLst>
+              <a:ext uri="{28A0092B-C50C-407E-A947-70E740481C1C}">
+                <a14:useLocalDpi xmlns:a14="http://schemas.microsoft.com/office/drawing/2010/main" val="0"/>
+              </a:ext>
+            </a:extLst>
+          </a:blip>
+          <a:srcRect/>
+          <a:stretch/>
+        </p:blipFill>
+        <p:spPr>
+          <a:xfrm>
+            <a:off x="8260556" y="2422684"/>
+            <a:ext cx="3836206" cy="2525043"/>
+          </a:xfrm>
+          <a:prstGeom prst="rect">
+            <a:avLst/>
+          </a:prstGeom>
+        </p:spPr>
+      </p:pic>
+    </p:spTree>
+    <p:extLst>
+      <p:ext uri="{BB962C8B-B14F-4D97-AF65-F5344CB8AC3E}">
+        <p14:creationId xmlns:p14="http://schemas.microsoft.com/office/powerpoint/2010/main" val="107297620"/>
+      </p:ext>
+    </p:extLst>
+  </p:cSld>
+  <p:clrMapOvr>
+    <a:masterClrMapping/>
+  </p:clrMapOvr>
+</p:sld>
+</file>
+
 <file path=ppt/slides/slide2.xml><?xml version="1.0" encoding="utf-8"?>
 <p:sld xmlns:a="http://schemas.openxmlformats.org/drawingml/2006/main" xmlns:r="http://schemas.openxmlformats.org/officeDocument/2006/relationships" xmlns:p="http://schemas.openxmlformats.org/presentationml/2006/main">
   <p:cSld>
@@ -5019,6 +6293,485 @@
           <p:cNvPr id="2" name="Title 1">
             <a:extLst>
               <a:ext uri="{FF2B5EF4-FFF2-40B4-BE49-F238E27FC236}">
+                <a16:creationId xmlns:a16="http://schemas.microsoft.com/office/drawing/2014/main" id="{B598D712-10F1-0F8D-C7B2-5C9FEAD65D35}"/>
+              </a:ext>
+            </a:extLst>
+          </p:cNvPr>
+          <p:cNvSpPr>
+            <a:spLocks noGrp="1"/>
+          </p:cNvSpPr>
+          <p:nvPr>
+            <p:ph type="title"/>
+          </p:nvPr>
+        </p:nvSpPr>
+        <p:spPr/>
+        <p:txBody>
+          <a:bodyPr/>
+          <a:lstStyle/>
+          <a:p>
+            <a:r>
+              <a:rPr lang="en-US" dirty="0"/>
+              <a:t>Supp fig 1</a:t>
+            </a:r>
+          </a:p>
+        </p:txBody>
+      </p:sp>
+      <p:pic>
+        <p:nvPicPr>
+          <p:cNvPr id="11" name="Picture 10">
+            <a:extLst>
+              <a:ext uri="{FF2B5EF4-FFF2-40B4-BE49-F238E27FC236}">
+                <a16:creationId xmlns:a16="http://schemas.microsoft.com/office/drawing/2014/main" id="{BDDBAF8F-3C19-4AB3-AB49-6E687EE928D5}"/>
+              </a:ext>
+            </a:extLst>
+          </p:cNvPr>
+          <p:cNvPicPr>
+            <a:picLocks noChangeAspect="1"/>
+          </p:cNvPicPr>
+          <p:nvPr/>
+        </p:nvPicPr>
+        <p:blipFill>
+          <a:blip r:embed="rId3"/>
+          <a:stretch>
+            <a:fillRect/>
+          </a:stretch>
+        </p:blipFill>
+        <p:spPr>
+          <a:xfrm>
+            <a:off x="4105274" y="882526"/>
+            <a:ext cx="6180595" cy="5092948"/>
+          </a:xfrm>
+          <a:prstGeom prst="rect">
+            <a:avLst/>
+          </a:prstGeom>
+        </p:spPr>
+      </p:pic>
+    </p:spTree>
+    <p:extLst>
+      <p:ext uri="{BB962C8B-B14F-4D97-AF65-F5344CB8AC3E}">
+        <p14:creationId xmlns:p14="http://schemas.microsoft.com/office/powerpoint/2010/main" val="1482307705"/>
+      </p:ext>
+    </p:extLst>
+  </p:cSld>
+  <p:clrMapOvr>
+    <a:masterClrMapping/>
+  </p:clrMapOvr>
+</p:sld>
+</file>
+
+<file path=ppt/slides/slide5.xml><?xml version="1.0" encoding="utf-8"?>
+<p:sld xmlns:a="http://schemas.openxmlformats.org/drawingml/2006/main" xmlns:r="http://schemas.openxmlformats.org/officeDocument/2006/relationships" xmlns:p="http://schemas.openxmlformats.org/presentationml/2006/main">
+  <p:cSld>
+    <p:spTree>
+      <p:nvGrpSpPr>
+        <p:cNvPr id="1" name="">
+          <a:extLst>
+            <a:ext uri="{FF2B5EF4-FFF2-40B4-BE49-F238E27FC236}">
+              <a16:creationId xmlns:a16="http://schemas.microsoft.com/office/drawing/2014/main" id="{DF94B3AB-9673-7EA3-BB02-6278296070FA}"/>
+            </a:ext>
+          </a:extLst>
+        </p:cNvPr>
+        <p:cNvGrpSpPr/>
+        <p:nvPr/>
+      </p:nvGrpSpPr>
+      <p:grpSpPr>
+        <a:xfrm>
+          <a:off x="0" y="0"/>
+          <a:ext cx="0" cy="0"/>
+          <a:chOff x="0" y="0"/>
+          <a:chExt cx="0" cy="0"/>
+        </a:xfrm>
+      </p:grpSpPr>
+      <p:sp>
+        <p:nvSpPr>
+          <p:cNvPr id="2" name="Title 1">
+            <a:extLst>
+              <a:ext uri="{FF2B5EF4-FFF2-40B4-BE49-F238E27FC236}">
+                <a16:creationId xmlns:a16="http://schemas.microsoft.com/office/drawing/2014/main" id="{F841D72A-81BA-4824-0651-F8E6E0D09731}"/>
+              </a:ext>
+            </a:extLst>
+          </p:cNvPr>
+          <p:cNvSpPr>
+            <a:spLocks noGrp="1"/>
+          </p:cNvSpPr>
+          <p:nvPr>
+            <p:ph type="title"/>
+          </p:nvPr>
+        </p:nvSpPr>
+        <p:spPr/>
+        <p:txBody>
+          <a:bodyPr/>
+          <a:lstStyle/>
+          <a:p>
+            <a:r>
+              <a:rPr lang="en-US" dirty="0"/>
+              <a:t>Supp fig 1</a:t>
+            </a:r>
+          </a:p>
+        </p:txBody>
+      </p:sp>
+      <p:pic>
+        <p:nvPicPr>
+          <p:cNvPr id="5" name="Content Placeholder 4">
+            <a:extLst>
+              <a:ext uri="{FF2B5EF4-FFF2-40B4-BE49-F238E27FC236}">
+                <a16:creationId xmlns:a16="http://schemas.microsoft.com/office/drawing/2014/main" id="{5C138CFE-B62C-5BE5-68CB-9DB0ABBD51F1}"/>
+              </a:ext>
+            </a:extLst>
+          </p:cNvPr>
+          <p:cNvPicPr>
+            <a:picLocks noGrp="1" noChangeAspect="1"/>
+          </p:cNvPicPr>
+          <p:nvPr>
+            <p:ph idx="1"/>
+          </p:nvPr>
+        </p:nvPicPr>
+        <p:blipFill>
+          <a:blip r:embed="rId2"/>
+          <a:stretch>
+            <a:fillRect/>
+          </a:stretch>
+        </p:blipFill>
+        <p:spPr>
+          <a:xfrm>
+            <a:off x="4626161" y="685800"/>
+            <a:ext cx="6294140" cy="2743200"/>
+          </a:xfrm>
+        </p:spPr>
+      </p:pic>
+      <p:pic>
+        <p:nvPicPr>
+          <p:cNvPr id="7" name="Picture 6">
+            <a:extLst>
+              <a:ext uri="{FF2B5EF4-FFF2-40B4-BE49-F238E27FC236}">
+                <a16:creationId xmlns:a16="http://schemas.microsoft.com/office/drawing/2014/main" id="{AD0F72F3-F42A-513B-A8FB-D5E7F596A4BE}"/>
+              </a:ext>
+            </a:extLst>
+          </p:cNvPr>
+          <p:cNvPicPr>
+            <a:picLocks noChangeAspect="1"/>
+          </p:cNvPicPr>
+          <p:nvPr/>
+        </p:nvPicPr>
+        <p:blipFill>
+          <a:blip r:embed="rId3"/>
+          <a:stretch>
+            <a:fillRect/>
+          </a:stretch>
+        </p:blipFill>
+        <p:spPr>
+          <a:xfrm>
+            <a:off x="4626161" y="3749675"/>
+            <a:ext cx="6243413" cy="2743200"/>
+          </a:xfrm>
+          <a:prstGeom prst="rect">
+            <a:avLst/>
+          </a:prstGeom>
+        </p:spPr>
+      </p:pic>
+    </p:spTree>
+    <p:extLst>
+      <p:ext uri="{BB962C8B-B14F-4D97-AF65-F5344CB8AC3E}">
+        <p14:creationId xmlns:p14="http://schemas.microsoft.com/office/powerpoint/2010/main" val="4139515049"/>
+      </p:ext>
+    </p:extLst>
+  </p:cSld>
+  <p:clrMapOvr>
+    <a:masterClrMapping/>
+  </p:clrMapOvr>
+</p:sld>
+</file>
+
+<file path=ppt/slides/slide6.xml><?xml version="1.0" encoding="utf-8"?>
+<p:sld xmlns:a="http://schemas.openxmlformats.org/drawingml/2006/main" xmlns:r="http://schemas.openxmlformats.org/officeDocument/2006/relationships" xmlns:p="http://schemas.openxmlformats.org/presentationml/2006/main">
+  <p:cSld>
+    <p:spTree>
+      <p:nvGrpSpPr>
+        <p:cNvPr id="1" name="">
+          <a:extLst>
+            <a:ext uri="{FF2B5EF4-FFF2-40B4-BE49-F238E27FC236}">
+              <a16:creationId xmlns:a16="http://schemas.microsoft.com/office/drawing/2014/main" id="{325045ED-11B9-CD40-FD80-5FCAA6C33759}"/>
+            </a:ext>
+          </a:extLst>
+        </p:cNvPr>
+        <p:cNvGrpSpPr/>
+        <p:nvPr/>
+      </p:nvGrpSpPr>
+      <p:grpSpPr>
+        <a:xfrm>
+          <a:off x="0" y="0"/>
+          <a:ext cx="0" cy="0"/>
+          <a:chOff x="0" y="0"/>
+          <a:chExt cx="0" cy="0"/>
+        </a:xfrm>
+      </p:grpSpPr>
+      <p:sp>
+        <p:nvSpPr>
+          <p:cNvPr id="2" name="Title 1">
+            <a:extLst>
+              <a:ext uri="{FF2B5EF4-FFF2-40B4-BE49-F238E27FC236}">
+                <a16:creationId xmlns:a16="http://schemas.microsoft.com/office/drawing/2014/main" id="{2739AB51-375D-315B-92F8-B0A3C1380E45}"/>
+              </a:ext>
+            </a:extLst>
+          </p:cNvPr>
+          <p:cNvSpPr>
+            <a:spLocks noGrp="1"/>
+          </p:cNvSpPr>
+          <p:nvPr>
+            <p:ph type="title"/>
+          </p:nvPr>
+        </p:nvSpPr>
+        <p:spPr/>
+        <p:txBody>
+          <a:bodyPr/>
+          <a:lstStyle/>
+          <a:p>
+            <a:r>
+              <a:rPr lang="en-US" dirty="0"/>
+              <a:t>Supp fig 1</a:t>
+            </a:r>
+          </a:p>
+        </p:txBody>
+      </p:sp>
+      <p:pic>
+        <p:nvPicPr>
+          <p:cNvPr id="5" name="Content Placeholder 4">
+            <a:extLst>
+              <a:ext uri="{FF2B5EF4-FFF2-40B4-BE49-F238E27FC236}">
+                <a16:creationId xmlns:a16="http://schemas.microsoft.com/office/drawing/2014/main" id="{3520CA8C-764A-7165-05E2-57744599C700}"/>
+              </a:ext>
+            </a:extLst>
+          </p:cNvPr>
+          <p:cNvPicPr>
+            <a:picLocks noGrp="1" noChangeAspect="1"/>
+          </p:cNvPicPr>
+          <p:nvPr>
+            <p:ph idx="1"/>
+          </p:nvPr>
+        </p:nvPicPr>
+        <p:blipFill>
+          <a:blip r:embed="rId2">
+            <a:extLst>
+              <a:ext uri="{28A0092B-C50C-407E-A947-70E740481C1C}">
+                <a14:useLocalDpi xmlns:a14="http://schemas.microsoft.com/office/drawing/2010/main" val="0"/>
+              </a:ext>
+            </a:extLst>
+          </a:blip>
+          <a:srcRect/>
+          <a:stretch/>
+        </p:blipFill>
+        <p:spPr>
+          <a:xfrm>
+            <a:off x="4626161" y="685800"/>
+            <a:ext cx="6294140" cy="2743200"/>
+          </a:xfrm>
+        </p:spPr>
+      </p:pic>
+      <p:pic>
+        <p:nvPicPr>
+          <p:cNvPr id="7" name="Picture 6">
+            <a:extLst>
+              <a:ext uri="{FF2B5EF4-FFF2-40B4-BE49-F238E27FC236}">
+                <a16:creationId xmlns:a16="http://schemas.microsoft.com/office/drawing/2014/main" id="{0339BEFE-43F8-854A-159F-FF604B8B815F}"/>
+              </a:ext>
+            </a:extLst>
+          </p:cNvPr>
+          <p:cNvPicPr>
+            <a:picLocks noChangeAspect="1"/>
+          </p:cNvPicPr>
+          <p:nvPr/>
+        </p:nvPicPr>
+        <p:blipFill>
+          <a:blip r:embed="rId3">
+            <a:extLst>
+              <a:ext uri="{28A0092B-C50C-407E-A947-70E740481C1C}">
+                <a14:useLocalDpi xmlns:a14="http://schemas.microsoft.com/office/drawing/2010/main" val="0"/>
+              </a:ext>
+            </a:extLst>
+          </a:blip>
+          <a:srcRect/>
+          <a:stretch/>
+        </p:blipFill>
+        <p:spPr>
+          <a:xfrm>
+            <a:off x="4493624" y="3569560"/>
+            <a:ext cx="6243413" cy="2743199"/>
+          </a:xfrm>
+          <a:prstGeom prst="rect">
+            <a:avLst/>
+          </a:prstGeom>
+        </p:spPr>
+      </p:pic>
+    </p:spTree>
+    <p:extLst>
+      <p:ext uri="{BB962C8B-B14F-4D97-AF65-F5344CB8AC3E}">
+        <p14:creationId xmlns:p14="http://schemas.microsoft.com/office/powerpoint/2010/main" val="1795766484"/>
+      </p:ext>
+    </p:extLst>
+  </p:cSld>
+  <p:clrMapOvr>
+    <a:masterClrMapping/>
+  </p:clrMapOvr>
+</p:sld>
+</file>
+
+<file path=ppt/slides/slide7.xml><?xml version="1.0" encoding="utf-8"?>
+<p:sld xmlns:a="http://schemas.openxmlformats.org/drawingml/2006/main" xmlns:r="http://schemas.openxmlformats.org/officeDocument/2006/relationships" xmlns:p="http://schemas.openxmlformats.org/presentationml/2006/main">
+  <p:cSld>
+    <p:spTree>
+      <p:nvGrpSpPr>
+        <p:cNvPr id="1" name=""/>
+        <p:cNvGrpSpPr/>
+        <p:nvPr/>
+      </p:nvGrpSpPr>
+      <p:grpSpPr>
+        <a:xfrm>
+          <a:off x="0" y="0"/>
+          <a:ext cx="0" cy="0"/>
+          <a:chOff x="0" y="0"/>
+          <a:chExt cx="0" cy="0"/>
+        </a:xfrm>
+      </p:grpSpPr>
+      <p:sp>
+        <p:nvSpPr>
+          <p:cNvPr id="2" name="Title 1">
+            <a:extLst>
+              <a:ext uri="{FF2B5EF4-FFF2-40B4-BE49-F238E27FC236}">
+                <a16:creationId xmlns:a16="http://schemas.microsoft.com/office/drawing/2014/main" id="{B9EECD58-AA8D-2A0B-2744-4718B1623E7C}"/>
+              </a:ext>
+            </a:extLst>
+          </p:cNvPr>
+          <p:cNvSpPr>
+            <a:spLocks noGrp="1"/>
+          </p:cNvSpPr>
+          <p:nvPr>
+            <p:ph type="title"/>
+          </p:nvPr>
+        </p:nvSpPr>
+        <p:spPr/>
+        <p:txBody>
+          <a:bodyPr/>
+          <a:lstStyle/>
+          <a:p>
+            <a:r>
+              <a:rPr lang="en-US" dirty="0"/>
+              <a:t>Supp fig.2 Rolling PMF</a:t>
+            </a:r>
+          </a:p>
+        </p:txBody>
+      </p:sp>
+      <p:sp>
+        <p:nvSpPr>
+          <p:cNvPr id="3" name="Content Placeholder 2">
+            <a:extLst>
+              <a:ext uri="{FF2B5EF4-FFF2-40B4-BE49-F238E27FC236}">
+                <a16:creationId xmlns:a16="http://schemas.microsoft.com/office/drawing/2014/main" id="{5C0AF5D7-06FC-55E6-5307-33B44FA9B86D}"/>
+              </a:ext>
+            </a:extLst>
+          </p:cNvPr>
+          <p:cNvSpPr>
+            <a:spLocks noGrp="1"/>
+          </p:cNvSpPr>
+          <p:nvPr>
+            <p:ph idx="1"/>
+          </p:nvPr>
+        </p:nvSpPr>
+        <p:spPr>
+          <a:xfrm>
+            <a:off x="838200" y="1825625"/>
+            <a:ext cx="6169090" cy="4351338"/>
+          </a:xfrm>
+        </p:spPr>
+        <p:txBody>
+          <a:bodyPr/>
+          <a:lstStyle/>
+          <a:p>
+            <a:r>
+              <a:rPr lang="en-US" dirty="0"/>
+              <a:t>Psych function every 80 trials.</a:t>
+            </a:r>
+          </a:p>
+          <a:p>
+            <a:r>
+              <a:rPr lang="en-US" dirty="0"/>
+              <a:t>Convolve with rolling mean kernel of 30 window size </a:t>
+            </a:r>
+          </a:p>
+          <a:p>
+            <a:endParaRPr lang="en-US" dirty="0"/>
+          </a:p>
+        </p:txBody>
+      </p:sp>
+      <p:pic>
+        <p:nvPicPr>
+          <p:cNvPr id="5" name="Picture 4">
+            <a:extLst>
+              <a:ext uri="{FF2B5EF4-FFF2-40B4-BE49-F238E27FC236}">
+                <a16:creationId xmlns:a16="http://schemas.microsoft.com/office/drawing/2014/main" id="{773C514E-EE6E-666D-F239-86CC58EEDBE3}"/>
+              </a:ext>
+            </a:extLst>
+          </p:cNvPr>
+          <p:cNvPicPr>
+            <a:picLocks noChangeAspect="1"/>
+          </p:cNvPicPr>
+          <p:nvPr/>
+        </p:nvPicPr>
+        <p:blipFill>
+          <a:blip r:embed="rId2">
+            <a:extLst>
+              <a:ext uri="{28A0092B-C50C-407E-A947-70E740481C1C}">
+                <a14:useLocalDpi xmlns:a14="http://schemas.microsoft.com/office/drawing/2010/main" val="0"/>
+              </a:ext>
+            </a:extLst>
+          </a:blip>
+          <a:srcRect/>
+          <a:stretch/>
+        </p:blipFill>
+        <p:spPr>
+          <a:xfrm>
+            <a:off x="7499116" y="146048"/>
+            <a:ext cx="4360092" cy="6711952"/>
+          </a:xfrm>
+          <a:prstGeom prst="rect">
+            <a:avLst/>
+          </a:prstGeom>
+        </p:spPr>
+      </p:pic>
+    </p:spTree>
+    <p:extLst>
+      <p:ext uri="{BB962C8B-B14F-4D97-AF65-F5344CB8AC3E}">
+        <p14:creationId xmlns:p14="http://schemas.microsoft.com/office/powerpoint/2010/main" val="3325137064"/>
+      </p:ext>
+    </p:extLst>
+  </p:cSld>
+  <p:clrMapOvr>
+    <a:masterClrMapping/>
+  </p:clrMapOvr>
+</p:sld>
+</file>
+
+<file path=ppt/slides/slide8.xml><?xml version="1.0" encoding="utf-8"?>
+<p:sld xmlns:a="http://schemas.openxmlformats.org/drawingml/2006/main" xmlns:r="http://schemas.openxmlformats.org/officeDocument/2006/relationships" xmlns:p="http://schemas.openxmlformats.org/presentationml/2006/main">
+  <p:cSld>
+    <p:spTree>
+      <p:nvGrpSpPr>
+        <p:cNvPr id="1" name=""/>
+        <p:cNvGrpSpPr/>
+        <p:nvPr/>
+      </p:nvGrpSpPr>
+      <p:grpSpPr>
+        <a:xfrm>
+          <a:off x="0" y="0"/>
+          <a:ext cx="0" cy="0"/>
+          <a:chOff x="0" y="0"/>
+          <a:chExt cx="0" cy="0"/>
+        </a:xfrm>
+      </p:grpSpPr>
+      <p:sp>
+        <p:nvSpPr>
+          <p:cNvPr id="2" name="Title 1">
+            <a:extLst>
+              <a:ext uri="{FF2B5EF4-FFF2-40B4-BE49-F238E27FC236}">
                 <a16:creationId xmlns:a16="http://schemas.microsoft.com/office/drawing/2014/main" id="{FDC9F0A8-A801-B0AD-CA01-3875524E262B}"/>
               </a:ext>
             </a:extLst>
@@ -5115,7 +6868,7 @@
 </p:sld>
 </file>
 
-<file path=ppt/slides/slide5.xml><?xml version="1.0" encoding="utf-8"?>
+<file path=ppt/slides/slide9.xml><?xml version="1.0" encoding="utf-8"?>
 <p:sld xmlns:a="http://schemas.openxmlformats.org/drawingml/2006/main" xmlns:r="http://schemas.openxmlformats.org/officeDocument/2006/relationships" xmlns:p="http://schemas.openxmlformats.org/presentationml/2006/main">
   <p:cSld>
     <p:spTree>
@@ -5950,715 +7703,6 @@
       </p:par>
     </p:tnLst>
   </p:timing>
-</p:sld>
-</file>
-
-<file path=ppt/slides/slide6.xml><?xml version="1.0" encoding="utf-8"?>
-<p:sld xmlns:a="http://schemas.openxmlformats.org/drawingml/2006/main" xmlns:r="http://schemas.openxmlformats.org/officeDocument/2006/relationships" xmlns:p="http://schemas.openxmlformats.org/presentationml/2006/main">
-  <p:cSld>
-    <p:spTree>
-      <p:nvGrpSpPr>
-        <p:cNvPr id="1" name=""/>
-        <p:cNvGrpSpPr/>
-        <p:nvPr/>
-      </p:nvGrpSpPr>
-      <p:grpSpPr>
-        <a:xfrm>
-          <a:off x="0" y="0"/>
-          <a:ext cx="0" cy="0"/>
-          <a:chOff x="0" y="0"/>
-          <a:chExt cx="0" cy="0"/>
-        </a:xfrm>
-      </p:grpSpPr>
-      <p:sp>
-        <p:nvSpPr>
-          <p:cNvPr id="2" name="Title 1">
-            <a:extLst>
-              <a:ext uri="{FF2B5EF4-FFF2-40B4-BE49-F238E27FC236}">
-                <a16:creationId xmlns:a16="http://schemas.microsoft.com/office/drawing/2014/main" id="{6499F9B1-CD61-B64C-0D8C-9C2872835C0C}"/>
-              </a:ext>
-            </a:extLst>
-          </p:cNvPr>
-          <p:cNvSpPr>
-            <a:spLocks noGrp="1"/>
-          </p:cNvSpPr>
-          <p:nvPr>
-            <p:ph type="title"/>
-          </p:nvPr>
-        </p:nvSpPr>
-        <p:spPr/>
-        <p:txBody>
-          <a:bodyPr/>
-          <a:lstStyle/>
-          <a:p>
-            <a:r>
-              <a:rPr lang="en-US" dirty="0"/>
-              <a:t>Fig. 2 GLM-HMM</a:t>
-            </a:r>
-          </a:p>
-        </p:txBody>
-      </p:sp>
-      <p:pic>
-        <p:nvPicPr>
-          <p:cNvPr id="8" name="Picture 7">
-            <a:extLst>
-              <a:ext uri="{FF2B5EF4-FFF2-40B4-BE49-F238E27FC236}">
-                <a16:creationId xmlns:a16="http://schemas.microsoft.com/office/drawing/2014/main" id="{5CAADE6A-566F-7AD4-BA81-D5F747017178}"/>
-              </a:ext>
-            </a:extLst>
-          </p:cNvPr>
-          <p:cNvPicPr>
-            <a:picLocks noChangeAspect="1"/>
-          </p:cNvPicPr>
-          <p:nvPr/>
-        </p:nvPicPr>
-        <p:blipFill>
-          <a:blip r:embed="rId3">
-            <a:extLst>
-              <a:ext uri="{28A0092B-C50C-407E-A947-70E740481C1C}">
-                <a14:useLocalDpi xmlns:a14="http://schemas.microsoft.com/office/drawing/2010/main" val="0"/>
-              </a:ext>
-            </a:extLst>
-          </a:blip>
-          <a:srcRect/>
-          <a:stretch/>
-        </p:blipFill>
-        <p:spPr>
-          <a:xfrm>
-            <a:off x="8432128" y="2466518"/>
-            <a:ext cx="3628723" cy="2812758"/>
-          </a:xfrm>
-          <a:prstGeom prst="rect">
-            <a:avLst/>
-          </a:prstGeom>
-        </p:spPr>
-      </p:pic>
-      <p:grpSp>
-        <p:nvGrpSpPr>
-          <p:cNvPr id="3" name="Group 2">
-            <a:extLst>
-              <a:ext uri="{FF2B5EF4-FFF2-40B4-BE49-F238E27FC236}">
-                <a16:creationId xmlns:a16="http://schemas.microsoft.com/office/drawing/2014/main" id="{EDC456D4-29BD-B94E-9175-4361FD929B8B}"/>
-              </a:ext>
-            </a:extLst>
-          </p:cNvPr>
-          <p:cNvGrpSpPr/>
-          <p:nvPr/>
-        </p:nvGrpSpPr>
-        <p:grpSpPr>
-          <a:xfrm>
-            <a:off x="708837" y="2466518"/>
-            <a:ext cx="3610067" cy="2743200"/>
-            <a:chOff x="708837" y="2466518"/>
-            <a:chExt cx="3610067" cy="2743200"/>
-          </a:xfrm>
-        </p:grpSpPr>
-        <p:pic>
-          <p:nvPicPr>
-            <p:cNvPr id="10" name="Picture 9">
-              <a:extLst>
-                <a:ext uri="{FF2B5EF4-FFF2-40B4-BE49-F238E27FC236}">
-                  <a16:creationId xmlns:a16="http://schemas.microsoft.com/office/drawing/2014/main" id="{AE51462A-E301-AFE2-67CF-F12D27F77BF2}"/>
-                </a:ext>
-              </a:extLst>
-            </p:cNvPr>
-            <p:cNvPicPr>
-              <a:picLocks noChangeAspect="1"/>
-            </p:cNvPicPr>
-            <p:nvPr/>
-          </p:nvPicPr>
-          <p:blipFill>
-            <a:blip r:embed="rId4">
-              <a:extLst>
-                <a:ext uri="{28A0092B-C50C-407E-A947-70E740481C1C}">
-                  <a14:useLocalDpi xmlns:a14="http://schemas.microsoft.com/office/drawing/2010/main" val="0"/>
-                </a:ext>
-              </a:extLst>
-            </a:blip>
-            <a:srcRect/>
-            <a:stretch/>
-          </p:blipFill>
-          <p:spPr>
-            <a:xfrm>
-              <a:off x="708837" y="2534873"/>
-              <a:ext cx="3610067" cy="2674845"/>
-            </a:xfrm>
-            <a:prstGeom prst="rect">
-              <a:avLst/>
-            </a:prstGeom>
-          </p:spPr>
-        </p:pic>
-        <p:sp>
-          <p:nvSpPr>
-            <p:cNvPr id="11" name="Rectangle: Rounded Corners 10">
-              <a:extLst>
-                <a:ext uri="{FF2B5EF4-FFF2-40B4-BE49-F238E27FC236}">
-                  <a16:creationId xmlns:a16="http://schemas.microsoft.com/office/drawing/2014/main" id="{E4117C3B-20F6-17B8-21C5-1E5DA8189EBE}"/>
-                </a:ext>
-              </a:extLst>
-            </p:cNvPr>
-            <p:cNvSpPr/>
-            <p:nvPr/>
-          </p:nvSpPr>
-          <p:spPr>
-            <a:xfrm>
-              <a:off x="1871656" y="2466518"/>
-              <a:ext cx="500063" cy="460254"/>
-            </a:xfrm>
-            <a:prstGeom prst="roundRect">
-              <a:avLst/>
-            </a:prstGeom>
-            <a:noFill/>
-            <a:ln w="38100">
-              <a:solidFill>
-                <a:schemeClr val="bg2">
-                  <a:lumMod val="25000"/>
-                </a:schemeClr>
-              </a:solidFill>
-            </a:ln>
-          </p:spPr>
-          <p:style>
-            <a:lnRef idx="2">
-              <a:schemeClr val="accent1">
-                <a:shade val="15000"/>
-              </a:schemeClr>
-            </a:lnRef>
-            <a:fillRef idx="1">
-              <a:schemeClr val="accent1"/>
-            </a:fillRef>
-            <a:effectRef idx="0">
-              <a:schemeClr val="accent1"/>
-            </a:effectRef>
-            <a:fontRef idx="minor">
-              <a:schemeClr val="lt1"/>
-            </a:fontRef>
-          </p:style>
-          <p:txBody>
-            <a:bodyPr rtlCol="0" anchor="ctr"/>
-            <a:lstStyle/>
-            <a:p>
-              <a:pPr algn="ctr"/>
-              <a:endParaRPr lang="en-US"/>
-            </a:p>
-          </p:txBody>
-        </p:sp>
-      </p:grpSp>
-      <p:pic>
-        <p:nvPicPr>
-          <p:cNvPr id="14" name="Picture 13">
-            <a:extLst>
-              <a:ext uri="{FF2B5EF4-FFF2-40B4-BE49-F238E27FC236}">
-                <a16:creationId xmlns:a16="http://schemas.microsoft.com/office/drawing/2014/main" id="{B3A8FA4A-C80B-23AE-0E2F-F7767C4831AC}"/>
-              </a:ext>
-            </a:extLst>
-          </p:cNvPr>
-          <p:cNvPicPr>
-            <a:picLocks noChangeAspect="1"/>
-          </p:cNvPicPr>
-          <p:nvPr/>
-        </p:nvPicPr>
-        <p:blipFill>
-          <a:blip r:embed="rId5">
-            <a:extLst>
-              <a:ext uri="{28A0092B-C50C-407E-A947-70E740481C1C}">
-                <a14:useLocalDpi xmlns:a14="http://schemas.microsoft.com/office/drawing/2010/main" val="0"/>
-              </a:ext>
-            </a:extLst>
-          </a:blip>
-          <a:srcRect/>
-          <a:stretch/>
-        </p:blipFill>
-        <p:spPr>
-          <a:xfrm>
-            <a:off x="4463997" y="2455522"/>
-            <a:ext cx="3914620" cy="2833547"/>
-          </a:xfrm>
-          <a:prstGeom prst="rect">
-            <a:avLst/>
-          </a:prstGeom>
-        </p:spPr>
-      </p:pic>
-    </p:spTree>
-    <p:extLst>
-      <p:ext uri="{BB962C8B-B14F-4D97-AF65-F5344CB8AC3E}">
-        <p14:creationId xmlns:p14="http://schemas.microsoft.com/office/powerpoint/2010/main" val="4016668503"/>
-      </p:ext>
-    </p:extLst>
-  </p:cSld>
-  <p:clrMapOvr>
-    <a:masterClrMapping/>
-  </p:clrMapOvr>
-</p:sld>
-</file>
-
-<file path=ppt/slides/slide7.xml><?xml version="1.0" encoding="utf-8"?>
-<p:sld xmlns:a="http://schemas.openxmlformats.org/drawingml/2006/main" xmlns:r="http://schemas.openxmlformats.org/officeDocument/2006/relationships" xmlns:p="http://schemas.openxmlformats.org/presentationml/2006/main">
-  <p:cSld>
-    <p:spTree>
-      <p:nvGrpSpPr>
-        <p:cNvPr id="1" name="">
-          <a:extLst>
-            <a:ext uri="{FF2B5EF4-FFF2-40B4-BE49-F238E27FC236}">
-              <a16:creationId xmlns:a16="http://schemas.microsoft.com/office/drawing/2014/main" id="{3112AA24-BDA2-79B6-4683-6DF63DC1DBAA}"/>
-            </a:ext>
-          </a:extLst>
-        </p:cNvPr>
-        <p:cNvGrpSpPr/>
-        <p:nvPr/>
-      </p:nvGrpSpPr>
-      <p:grpSpPr>
-        <a:xfrm>
-          <a:off x="0" y="0"/>
-          <a:ext cx="0" cy="0"/>
-          <a:chOff x="0" y="0"/>
-          <a:chExt cx="0" cy="0"/>
-        </a:xfrm>
-      </p:grpSpPr>
-      <p:pic>
-        <p:nvPicPr>
-          <p:cNvPr id="11" name="Picture 10">
-            <a:extLst>
-              <a:ext uri="{FF2B5EF4-FFF2-40B4-BE49-F238E27FC236}">
-                <a16:creationId xmlns:a16="http://schemas.microsoft.com/office/drawing/2014/main" id="{3B60A0AB-3D04-1AE0-49FC-48FD416A0371}"/>
-              </a:ext>
-            </a:extLst>
-          </p:cNvPr>
-          <p:cNvPicPr>
-            <a:picLocks noChangeAspect="1"/>
-          </p:cNvPicPr>
-          <p:nvPr/>
-        </p:nvPicPr>
-        <p:blipFill>
-          <a:blip r:embed="rId2">
-            <a:extLst>
-              <a:ext uri="{28A0092B-C50C-407E-A947-70E740481C1C}">
-                <a14:useLocalDpi xmlns:a14="http://schemas.microsoft.com/office/drawing/2010/main" val="0"/>
-              </a:ext>
-            </a:extLst>
-          </a:blip>
-          <a:srcRect/>
-          <a:stretch/>
-        </p:blipFill>
-        <p:spPr>
-          <a:xfrm>
-            <a:off x="1057498" y="73937"/>
-            <a:ext cx="4414726" cy="3297073"/>
-          </a:xfrm>
-          <a:prstGeom prst="rect">
-            <a:avLst/>
-          </a:prstGeom>
-        </p:spPr>
-      </p:pic>
-      <p:pic>
-        <p:nvPicPr>
-          <p:cNvPr id="4" name="Picture 3">
-            <a:extLst>
-              <a:ext uri="{FF2B5EF4-FFF2-40B4-BE49-F238E27FC236}">
-                <a16:creationId xmlns:a16="http://schemas.microsoft.com/office/drawing/2014/main" id="{03E24DCD-D397-183C-C7A5-3AC58BFDAAEE}"/>
-              </a:ext>
-            </a:extLst>
-          </p:cNvPr>
-          <p:cNvPicPr>
-            <a:picLocks noChangeAspect="1"/>
-          </p:cNvPicPr>
-          <p:nvPr/>
-        </p:nvPicPr>
-        <p:blipFill>
-          <a:blip r:embed="rId3"/>
-          <a:stretch>
-            <a:fillRect/>
-          </a:stretch>
-        </p:blipFill>
-        <p:spPr>
-          <a:xfrm>
-            <a:off x="5977935" y="73937"/>
-            <a:ext cx="4967052" cy="3721396"/>
-          </a:xfrm>
-          <a:prstGeom prst="rect">
-            <a:avLst/>
-          </a:prstGeom>
-        </p:spPr>
-      </p:pic>
-      <p:pic>
-        <p:nvPicPr>
-          <p:cNvPr id="6" name="Picture 5">
-            <a:extLst>
-              <a:ext uri="{FF2B5EF4-FFF2-40B4-BE49-F238E27FC236}">
-                <a16:creationId xmlns:a16="http://schemas.microsoft.com/office/drawing/2014/main" id="{55668DA3-F20A-DC0F-3F34-EEFA322FF58F}"/>
-              </a:ext>
-            </a:extLst>
-          </p:cNvPr>
-          <p:cNvPicPr>
-            <a:picLocks noChangeAspect="1"/>
-          </p:cNvPicPr>
-          <p:nvPr/>
-        </p:nvPicPr>
-        <p:blipFill>
-          <a:blip r:embed="rId4"/>
-          <a:stretch>
-            <a:fillRect/>
-          </a:stretch>
-        </p:blipFill>
-        <p:spPr>
-          <a:xfrm>
-            <a:off x="1837429" y="3486991"/>
-            <a:ext cx="4258571" cy="3053315"/>
-          </a:xfrm>
-          <a:prstGeom prst="rect">
-            <a:avLst/>
-          </a:prstGeom>
-        </p:spPr>
-      </p:pic>
-      <p:sp>
-        <p:nvSpPr>
-          <p:cNvPr id="7" name="TextBox 6">
-            <a:extLst>
-              <a:ext uri="{FF2B5EF4-FFF2-40B4-BE49-F238E27FC236}">
-                <a16:creationId xmlns:a16="http://schemas.microsoft.com/office/drawing/2014/main" id="{D829B96F-2139-C8EE-D71D-8EEF4933D86A}"/>
-              </a:ext>
-            </a:extLst>
-          </p:cNvPr>
-          <p:cNvSpPr txBox="1"/>
-          <p:nvPr/>
-        </p:nvSpPr>
-        <p:spPr>
-          <a:xfrm>
-            <a:off x="6677247" y="4281377"/>
-            <a:ext cx="4423144" cy="1477328"/>
-          </a:xfrm>
-          <a:prstGeom prst="rect">
-            <a:avLst/>
-          </a:prstGeom>
-          <a:noFill/>
-        </p:spPr>
-        <p:txBody>
-          <a:bodyPr wrap="square" rtlCol="0">
-            <a:spAutoFit/>
-          </a:bodyPr>
-          <a:lstStyle/>
-          <a:p>
-            <a:r>
-              <a:rPr lang="en-US" dirty="0"/>
-              <a:t>Log-likelihood: 2 states is the best</a:t>
-            </a:r>
-          </a:p>
-          <a:p>
-            <a:r>
-              <a:rPr lang="en-US" dirty="0"/>
-              <a:t>Predictive accuracy: 5 states is the highest</a:t>
-            </a:r>
-          </a:p>
-          <a:p>
-            <a:endParaRPr lang="en-US" dirty="0"/>
-          </a:p>
-          <a:p>
-            <a:r>
-              <a:rPr lang="en-US" dirty="0"/>
-              <a:t>5 states models are overall over-confident, i.e. higher penalty on incorrect predictions</a:t>
-            </a:r>
-          </a:p>
-        </p:txBody>
-      </p:sp>
-    </p:spTree>
-    <p:extLst>
-      <p:ext uri="{BB962C8B-B14F-4D97-AF65-F5344CB8AC3E}">
-        <p14:creationId xmlns:p14="http://schemas.microsoft.com/office/powerpoint/2010/main" val="2768749306"/>
-      </p:ext>
-    </p:extLst>
-  </p:cSld>
-  <p:clrMapOvr>
-    <a:masterClrMapping/>
-  </p:clrMapOvr>
-</p:sld>
-</file>
-
-<file path=ppt/slides/slide8.xml><?xml version="1.0" encoding="utf-8"?>
-<p:sld xmlns:a="http://schemas.openxmlformats.org/drawingml/2006/main" xmlns:r="http://schemas.openxmlformats.org/officeDocument/2006/relationships" xmlns:p="http://schemas.openxmlformats.org/presentationml/2006/main">
-  <p:cSld>
-    <p:spTree>
-      <p:nvGrpSpPr>
-        <p:cNvPr id="1" name=""/>
-        <p:cNvGrpSpPr/>
-        <p:nvPr/>
-      </p:nvGrpSpPr>
-      <p:grpSpPr>
-        <a:xfrm>
-          <a:off x="0" y="0"/>
-          <a:ext cx="0" cy="0"/>
-          <a:chOff x="0" y="0"/>
-          <a:chExt cx="0" cy="0"/>
-        </a:xfrm>
-      </p:grpSpPr>
-      <p:sp>
-        <p:nvSpPr>
-          <p:cNvPr id="2" name="Title 1">
-            <a:extLst>
-              <a:ext uri="{FF2B5EF4-FFF2-40B4-BE49-F238E27FC236}">
-                <a16:creationId xmlns:a16="http://schemas.microsoft.com/office/drawing/2014/main" id="{10B478D0-24D6-AA0A-8EB7-CAA5D77BB3B7}"/>
-              </a:ext>
-            </a:extLst>
-          </p:cNvPr>
-          <p:cNvSpPr>
-            <a:spLocks noGrp="1"/>
-          </p:cNvSpPr>
-          <p:nvPr>
-            <p:ph type="title"/>
-          </p:nvPr>
-        </p:nvSpPr>
-        <p:spPr/>
-        <p:txBody>
-          <a:bodyPr/>
-          <a:lstStyle/>
-          <a:p>
-            <a:r>
-              <a:rPr lang="en-US" dirty="0"/>
-              <a:t>Unequal block only GLM-HMM</a:t>
-            </a:r>
-          </a:p>
-        </p:txBody>
-      </p:sp>
-      <p:sp>
-        <p:nvSpPr>
-          <p:cNvPr id="3" name="Content Placeholder 2">
-            <a:extLst>
-              <a:ext uri="{FF2B5EF4-FFF2-40B4-BE49-F238E27FC236}">
-                <a16:creationId xmlns:a16="http://schemas.microsoft.com/office/drawing/2014/main" id="{ED1DDD19-839D-6192-96FC-210DCC2AC81A}"/>
-              </a:ext>
-            </a:extLst>
-          </p:cNvPr>
-          <p:cNvSpPr>
-            <a:spLocks noGrp="1"/>
-          </p:cNvSpPr>
-          <p:nvPr>
-            <p:ph idx="1"/>
-          </p:nvPr>
-        </p:nvSpPr>
-        <p:spPr>
-          <a:xfrm>
-            <a:off x="6741885" y="2066292"/>
-            <a:ext cx="3422756" cy="4351338"/>
-          </a:xfrm>
-        </p:spPr>
-        <p:txBody>
-          <a:bodyPr/>
-          <a:lstStyle/>
-          <a:p>
-            <a:r>
-              <a:rPr lang="en-US" dirty="0"/>
-              <a:t>2 states is still the best</a:t>
-            </a:r>
-          </a:p>
-        </p:txBody>
-      </p:sp>
-      <p:pic>
-        <p:nvPicPr>
-          <p:cNvPr id="5" name="Picture 4">
-            <a:extLst>
-              <a:ext uri="{FF2B5EF4-FFF2-40B4-BE49-F238E27FC236}">
-                <a16:creationId xmlns:a16="http://schemas.microsoft.com/office/drawing/2014/main" id="{A0A6D343-A6F4-4538-B91E-01FF17B780F3}"/>
-              </a:ext>
-            </a:extLst>
-          </p:cNvPr>
-          <p:cNvPicPr>
-            <a:picLocks noChangeAspect="1"/>
-          </p:cNvPicPr>
-          <p:nvPr/>
-        </p:nvPicPr>
-        <p:blipFill>
-          <a:blip r:embed="rId2"/>
-          <a:stretch>
-            <a:fillRect/>
-          </a:stretch>
-        </p:blipFill>
-        <p:spPr>
-          <a:xfrm>
-            <a:off x="-407028" y="1499855"/>
-            <a:ext cx="6257925" cy="4552950"/>
-          </a:xfrm>
-          <a:prstGeom prst="rect">
-            <a:avLst/>
-          </a:prstGeom>
-        </p:spPr>
-      </p:pic>
-    </p:spTree>
-    <p:extLst>
-      <p:ext uri="{BB962C8B-B14F-4D97-AF65-F5344CB8AC3E}">
-        <p14:creationId xmlns:p14="http://schemas.microsoft.com/office/powerpoint/2010/main" val="3385422129"/>
-      </p:ext>
-    </p:extLst>
-  </p:cSld>
-  <p:clrMapOvr>
-    <a:masterClrMapping/>
-  </p:clrMapOvr>
-</p:sld>
-</file>
-
-<file path=ppt/slides/slide9.xml><?xml version="1.0" encoding="utf-8"?>
-<p:sld xmlns:a="http://schemas.openxmlformats.org/drawingml/2006/main" xmlns:r="http://schemas.openxmlformats.org/officeDocument/2006/relationships" xmlns:p="http://schemas.openxmlformats.org/presentationml/2006/main">
-  <p:cSld>
-    <p:spTree>
-      <p:nvGrpSpPr>
-        <p:cNvPr id="1" name="">
-          <a:extLst>
-            <a:ext uri="{FF2B5EF4-FFF2-40B4-BE49-F238E27FC236}">
-              <a16:creationId xmlns:a16="http://schemas.microsoft.com/office/drawing/2014/main" id="{F4C53FD2-27AD-A3BE-C751-9A2816FCE964}"/>
-            </a:ext>
-          </a:extLst>
-        </p:cNvPr>
-        <p:cNvGrpSpPr/>
-        <p:nvPr/>
-      </p:nvGrpSpPr>
-      <p:grpSpPr>
-        <a:xfrm>
-          <a:off x="0" y="0"/>
-          <a:ext cx="0" cy="0"/>
-          <a:chOff x="0" y="0"/>
-          <a:chExt cx="0" cy="0"/>
-        </a:xfrm>
-      </p:grpSpPr>
-      <p:sp>
-        <p:nvSpPr>
-          <p:cNvPr id="2" name="Title 1">
-            <a:extLst>
-              <a:ext uri="{FF2B5EF4-FFF2-40B4-BE49-F238E27FC236}">
-                <a16:creationId xmlns:a16="http://schemas.microsoft.com/office/drawing/2014/main" id="{3F0C3732-2260-2FDB-ED81-D21A6694C20F}"/>
-              </a:ext>
-            </a:extLst>
-          </p:cNvPr>
-          <p:cNvSpPr>
-            <a:spLocks noGrp="1"/>
-          </p:cNvSpPr>
-          <p:nvPr>
-            <p:ph type="title"/>
-          </p:nvPr>
-        </p:nvSpPr>
-        <p:spPr/>
-        <p:txBody>
-          <a:bodyPr/>
-          <a:lstStyle/>
-          <a:p>
-            <a:r>
-              <a:rPr lang="en-US" dirty="0"/>
-              <a:t>Fig. 2 GLM-HMM</a:t>
-            </a:r>
-          </a:p>
-        </p:txBody>
-      </p:sp>
-      <p:pic>
-        <p:nvPicPr>
-          <p:cNvPr id="4" name="Picture 3">
-            <a:extLst>
-              <a:ext uri="{FF2B5EF4-FFF2-40B4-BE49-F238E27FC236}">
-                <a16:creationId xmlns:a16="http://schemas.microsoft.com/office/drawing/2014/main" id="{4E00EB9A-D238-A7ED-4120-25D05347ED23}"/>
-              </a:ext>
-            </a:extLst>
-          </p:cNvPr>
-          <p:cNvPicPr>
-            <a:picLocks noChangeAspect="1"/>
-          </p:cNvPicPr>
-          <p:nvPr/>
-        </p:nvPicPr>
-        <p:blipFill>
-          <a:blip r:embed="rId3">
-            <a:extLst>
-              <a:ext uri="{28A0092B-C50C-407E-A947-70E740481C1C}">
-                <a14:useLocalDpi xmlns:a14="http://schemas.microsoft.com/office/drawing/2010/main" val="0"/>
-              </a:ext>
-            </a:extLst>
-          </a:blip>
-          <a:srcRect/>
-          <a:stretch/>
-        </p:blipFill>
-        <p:spPr>
-          <a:xfrm>
-            <a:off x="360222" y="2224610"/>
-            <a:ext cx="3440253" cy="2646100"/>
-          </a:xfrm>
-          <a:prstGeom prst="rect">
-            <a:avLst/>
-          </a:prstGeom>
-        </p:spPr>
-      </p:pic>
-      <p:pic>
-        <p:nvPicPr>
-          <p:cNvPr id="6" name="Picture 5">
-            <a:extLst>
-              <a:ext uri="{FF2B5EF4-FFF2-40B4-BE49-F238E27FC236}">
-                <a16:creationId xmlns:a16="http://schemas.microsoft.com/office/drawing/2014/main" id="{F9CD0EC9-4815-1EF8-CD2C-F11D39C61A86}"/>
-              </a:ext>
-            </a:extLst>
-          </p:cNvPr>
-          <p:cNvPicPr>
-            <a:picLocks noChangeAspect="1"/>
-          </p:cNvPicPr>
-          <p:nvPr/>
-        </p:nvPicPr>
-        <p:blipFill>
-          <a:blip r:embed="rId4">
-            <a:extLst>
-              <a:ext uri="{28A0092B-C50C-407E-A947-70E740481C1C}">
-                <a14:useLocalDpi xmlns:a14="http://schemas.microsoft.com/office/drawing/2010/main" val="0"/>
-              </a:ext>
-            </a:extLst>
-          </a:blip>
-          <a:srcRect/>
-          <a:stretch/>
-        </p:blipFill>
-        <p:spPr>
-          <a:xfrm>
-            <a:off x="3853871" y="2422684"/>
-            <a:ext cx="4708029" cy="2568938"/>
-          </a:xfrm>
-          <a:prstGeom prst="rect">
-            <a:avLst/>
-          </a:prstGeom>
-        </p:spPr>
-      </p:pic>
-      <p:pic>
-        <p:nvPicPr>
-          <p:cNvPr id="13" name="Picture 12">
-            <a:extLst>
-              <a:ext uri="{FF2B5EF4-FFF2-40B4-BE49-F238E27FC236}">
-                <a16:creationId xmlns:a16="http://schemas.microsoft.com/office/drawing/2014/main" id="{81FE5B99-AA29-CF74-F974-43740AB0D1C9}"/>
-              </a:ext>
-            </a:extLst>
-          </p:cNvPr>
-          <p:cNvPicPr>
-            <a:picLocks noChangeAspect="1"/>
-          </p:cNvPicPr>
-          <p:nvPr/>
-        </p:nvPicPr>
-        <p:blipFill>
-          <a:blip r:embed="rId5">
-            <a:extLst>
-              <a:ext uri="{28A0092B-C50C-407E-A947-70E740481C1C}">
-                <a14:useLocalDpi xmlns:a14="http://schemas.microsoft.com/office/drawing/2010/main" val="0"/>
-              </a:ext>
-            </a:extLst>
-          </a:blip>
-          <a:srcRect/>
-          <a:stretch/>
-        </p:blipFill>
-        <p:spPr>
-          <a:xfrm>
-            <a:off x="8260556" y="2422684"/>
-            <a:ext cx="3836206" cy="2525043"/>
-          </a:xfrm>
-          <a:prstGeom prst="rect">
-            <a:avLst/>
-          </a:prstGeom>
-        </p:spPr>
-      </p:pic>
-    </p:spTree>
-    <p:extLst>
-      <p:ext uri="{BB962C8B-B14F-4D97-AF65-F5344CB8AC3E}">
-        <p14:creationId xmlns:p14="http://schemas.microsoft.com/office/powerpoint/2010/main" val="107297620"/>
-      </p:ext>
-    </p:extLst>
-  </p:cSld>
-  <p:clrMapOvr>
-    <a:masterClrMapping/>
-  </p:clrMapOvr>
 </p:sld>
 </file>
 

</xml_diff>

<commit_message>
feat: glm-hmm ready for PI review
</commit_message>
<xml_diff>
--- a/dissemination/Prior encoding of Superior Colliculus in perceptual decision-making.pptx
+++ b/dissemination/Prior encoding of Superior Colliculus in perceptual decision-making.pptx
@@ -5,7 +5,7 @@
     <p:sldMasterId id="2147483648" r:id="rId1"/>
   </p:sldMasterIdLst>
   <p:notesMasterIdLst>
-    <p:notesMasterId r:id="rId15"/>
+    <p:notesMasterId r:id="rId16"/>
   </p:notesMasterIdLst>
   <p:sldIdLst>
     <p:sldId id="256" r:id="rId2"/>
@@ -20,7 +20,8 @@
     <p:sldId id="262" r:id="rId11"/>
     <p:sldId id="266" r:id="rId12"/>
     <p:sldId id="275" r:id="rId13"/>
-    <p:sldId id="264" r:id="rId14"/>
+    <p:sldId id="276" r:id="rId14"/>
+    <p:sldId id="264" r:id="rId15"/>
   </p:sldIdLst>
   <p:sldSz cx="12192000" cy="6858000"/>
   <p:notesSz cx="6858000" cy="9144000"/>
@@ -209,7 +210,7 @@
           <a:p>
             <a:fld id="{BA3E252F-87BF-4487-AB21-8F0FF193234C}" type="datetimeFigureOut">
               <a:rPr lang="en-US" smtClean="0"/>
-              <a:t>7/28/2025</a:t>
+              <a:t>8/5/25</a:t>
             </a:fld>
             <a:endParaRPr lang="en-US"/>
           </a:p>
@@ -584,6 +585,114 @@
 </p:notes>
 </file>
 
+<file path=ppt/notesSlides/notesSlide10.xml><?xml version="1.0" encoding="utf-8"?>
+<p:notes xmlns:a="http://schemas.openxmlformats.org/drawingml/2006/main" xmlns:r="http://schemas.openxmlformats.org/officeDocument/2006/relationships" xmlns:p="http://schemas.openxmlformats.org/presentationml/2006/main">
+  <p:cSld>
+    <p:spTree>
+      <p:nvGrpSpPr>
+        <p:cNvPr id="1" name="">
+          <a:extLst>
+            <a:ext uri="{FF2B5EF4-FFF2-40B4-BE49-F238E27FC236}">
+              <a16:creationId xmlns:a16="http://schemas.microsoft.com/office/drawing/2014/main" id="{8E26174D-4889-6B1A-5F22-0512173A245B}"/>
+            </a:ext>
+          </a:extLst>
+        </p:cNvPr>
+        <p:cNvGrpSpPr/>
+        <p:nvPr/>
+      </p:nvGrpSpPr>
+      <p:grpSpPr>
+        <a:xfrm>
+          <a:off x="0" y="0"/>
+          <a:ext cx="0" cy="0"/>
+          <a:chOff x="0" y="0"/>
+          <a:chExt cx="0" cy="0"/>
+        </a:xfrm>
+      </p:grpSpPr>
+      <p:sp>
+        <p:nvSpPr>
+          <p:cNvPr id="2" name="Slide Image Placeholder 1">
+            <a:extLst>
+              <a:ext uri="{FF2B5EF4-FFF2-40B4-BE49-F238E27FC236}">
+                <a16:creationId xmlns:a16="http://schemas.microsoft.com/office/drawing/2014/main" id="{24890C6B-394D-98F5-5989-3B6287E78099}"/>
+              </a:ext>
+            </a:extLst>
+          </p:cNvPr>
+          <p:cNvSpPr>
+            <a:spLocks noGrp="1" noRot="1" noChangeAspect="1"/>
+          </p:cNvSpPr>
+          <p:nvPr>
+            <p:ph type="sldImg"/>
+          </p:nvPr>
+        </p:nvSpPr>
+        <p:spPr/>
+      </p:sp>
+      <p:sp>
+        <p:nvSpPr>
+          <p:cNvPr id="3" name="Notes Placeholder 2">
+            <a:extLst>
+              <a:ext uri="{FF2B5EF4-FFF2-40B4-BE49-F238E27FC236}">
+                <a16:creationId xmlns:a16="http://schemas.microsoft.com/office/drawing/2014/main" id="{7A69655C-F4C7-B025-6088-E77E1DF08674}"/>
+              </a:ext>
+            </a:extLst>
+          </p:cNvPr>
+          <p:cNvSpPr>
+            <a:spLocks noGrp="1"/>
+          </p:cNvSpPr>
+          <p:nvPr>
+            <p:ph type="body" idx="1"/>
+          </p:nvPr>
+        </p:nvSpPr>
+        <p:spPr/>
+        <p:txBody>
+          <a:bodyPr/>
+          <a:lstStyle/>
+          <a:p>
+            <a:endParaRPr lang="en-US" dirty="0"/>
+          </a:p>
+        </p:txBody>
+      </p:sp>
+      <p:sp>
+        <p:nvSpPr>
+          <p:cNvPr id="4" name="Slide Number Placeholder 3">
+            <a:extLst>
+              <a:ext uri="{FF2B5EF4-FFF2-40B4-BE49-F238E27FC236}">
+                <a16:creationId xmlns:a16="http://schemas.microsoft.com/office/drawing/2014/main" id="{EDB41845-DBF9-D5D3-0AD0-EB44364BA97B}"/>
+              </a:ext>
+            </a:extLst>
+          </p:cNvPr>
+          <p:cNvSpPr>
+            <a:spLocks noGrp="1"/>
+          </p:cNvSpPr>
+          <p:nvPr>
+            <p:ph type="sldNum" sz="quarter" idx="5"/>
+          </p:nvPr>
+        </p:nvSpPr>
+        <p:spPr/>
+        <p:txBody>
+          <a:bodyPr/>
+          <a:lstStyle/>
+          <a:p>
+            <a:fld id="{F4472248-5027-4A3C-9488-9C593E53F37B}" type="slidenum">
+              <a:rPr lang="en-US" smtClean="0"/>
+              <a:t>14</a:t>
+            </a:fld>
+            <a:endParaRPr lang="en-US"/>
+          </a:p>
+        </p:txBody>
+      </p:sp>
+    </p:spTree>
+    <p:extLst>
+      <p:ext uri="{BB962C8B-B14F-4D97-AF65-F5344CB8AC3E}">
+        <p14:creationId xmlns:p14="http://schemas.microsoft.com/office/powerpoint/2010/main" val="603407146"/>
+      </p:ext>
+    </p:extLst>
+  </p:cSld>
+  <p:clrMapOvr>
+    <a:masterClrMapping/>
+  </p:clrMapOvr>
+</p:notes>
+</file>
+
 <file path=ppt/notesSlides/notesSlide2.xml><?xml version="1.0" encoding="utf-8"?>
 <p:notes xmlns:a="http://schemas.openxmlformats.org/drawingml/2006/main" xmlns:r="http://schemas.openxmlformats.org/officeDocument/2006/relationships" xmlns:p="http://schemas.openxmlformats.org/presentationml/2006/main">
   <p:cSld>
@@ -1066,6 +1175,76 @@
         <p:txBody>
           <a:bodyPr/>
           <a:lstStyle/>
+          <a:p>
+            <a:r>
+              <a:rPr lang="en-US" sz="1200" b="0" i="0" kern="1200" dirty="0">
+                <a:solidFill>
+                  <a:schemeClr val="tx1"/>
+                </a:solidFill>
+                <a:effectLst/>
+                <a:latin typeface="+mn-lt"/>
+                <a:ea typeface="+mn-ea"/>
+                <a:cs typeface="+mn-cs"/>
+              </a:rPr>
+              <a:t>Biased to Biased: [0.990, 1.000] </a:t>
+            </a:r>
+          </a:p>
+          <a:p>
+            <a:r>
+              <a:rPr lang="en-US" sz="1200" b="0" i="0" kern="1200" dirty="0">
+                <a:solidFill>
+                  <a:schemeClr val="tx1"/>
+                </a:solidFill>
+                <a:effectLst/>
+                <a:latin typeface="+mn-lt"/>
+                <a:ea typeface="+mn-ea"/>
+                <a:cs typeface="+mn-cs"/>
+              </a:rPr>
+              <a:t>Biased to Unbiased: [0.000, 0.010] </a:t>
+            </a:r>
+          </a:p>
+          <a:p>
+            <a:r>
+              <a:rPr lang="en-US" sz="1200" b="0" i="0" kern="1200" dirty="0">
+                <a:solidFill>
+                  <a:schemeClr val="tx1"/>
+                </a:solidFill>
+                <a:effectLst/>
+                <a:latin typeface="+mn-lt"/>
+                <a:ea typeface="+mn-ea"/>
+                <a:cs typeface="+mn-cs"/>
+              </a:rPr>
+              <a:t>Unbiased to Biased: [0.000, 0.009] </a:t>
+            </a:r>
+          </a:p>
+          <a:p>
+            <a:r>
+              <a:rPr lang="en-US" sz="1200" b="0" i="0" kern="1200" dirty="0">
+                <a:solidFill>
+                  <a:schemeClr val="tx1"/>
+                </a:solidFill>
+                <a:effectLst/>
+                <a:latin typeface="+mn-lt"/>
+                <a:ea typeface="+mn-ea"/>
+                <a:cs typeface="+mn-cs"/>
+              </a:rPr>
+              <a:t>Unbiased to Unbiased: [0.991, 1.000]</a:t>
+            </a:r>
+          </a:p>
+          <a:p>
+            <a:r>
+              <a:rPr lang="en-US" sz="1200" b="0" i="0" kern="1200" dirty="0">
+                <a:solidFill>
+                  <a:schemeClr val="tx1"/>
+                </a:solidFill>
+                <a:effectLst/>
+                <a:latin typeface="+mn-lt"/>
+                <a:ea typeface="+mn-ea"/>
+                <a:cs typeface="+mn-cs"/>
+              </a:rPr>
+              <a:t>The ranges above are clipped between 0 and 1</a:t>
+            </a:r>
+          </a:p>
           <a:p>
             <a:endParaRPr lang="en-US" dirty="0"/>
           </a:p>
@@ -1340,7 +1519,7 @@
         <p:cNvPr id="1" name="">
           <a:extLst>
             <a:ext uri="{FF2B5EF4-FFF2-40B4-BE49-F238E27FC236}">
-              <a16:creationId xmlns:a16="http://schemas.microsoft.com/office/drawing/2014/main" id="{8E26174D-4889-6B1A-5F22-0512173A245B}"/>
+              <a16:creationId xmlns:a16="http://schemas.microsoft.com/office/drawing/2014/main" id="{CB723CF2-D52B-A8B8-14DE-FD8C084C0162}"/>
             </a:ext>
           </a:extLst>
         </p:cNvPr>
@@ -1360,7 +1539,7 @@
           <p:cNvPr id="2" name="Slide Image Placeholder 1">
             <a:extLst>
               <a:ext uri="{FF2B5EF4-FFF2-40B4-BE49-F238E27FC236}">
-                <a16:creationId xmlns:a16="http://schemas.microsoft.com/office/drawing/2014/main" id="{24890C6B-394D-98F5-5989-3B6287E78099}"/>
+                <a16:creationId xmlns:a16="http://schemas.microsoft.com/office/drawing/2014/main" id="{824A609A-9E14-106D-4715-0A7312164F2D}"/>
               </a:ext>
             </a:extLst>
           </p:cNvPr>
@@ -1378,7 +1557,7 @@
           <p:cNvPr id="3" name="Notes Placeholder 2">
             <a:extLst>
               <a:ext uri="{FF2B5EF4-FFF2-40B4-BE49-F238E27FC236}">
-                <a16:creationId xmlns:a16="http://schemas.microsoft.com/office/drawing/2014/main" id="{7A69655C-F4C7-B025-6088-E77E1DF08674}"/>
+                <a16:creationId xmlns:a16="http://schemas.microsoft.com/office/drawing/2014/main" id="{27E777AE-7C52-2E46-2CCF-45DD9CD0A76A}"/>
               </a:ext>
             </a:extLst>
           </p:cNvPr>
@@ -1394,6 +1573,18 @@
           <a:bodyPr/>
           <a:lstStyle/>
           <a:p>
+            <a:r>
+              <a:rPr lang="en-US" dirty="0"/>
+              <a:t>Equal prior only: 1 state</a:t>
+            </a:r>
+          </a:p>
+          <a:p>
+            <a:r>
+              <a:rPr lang="en-US" dirty="0"/>
+              <a:t>Unequal prior only: 2 states</a:t>
+            </a:r>
+          </a:p>
+          <a:p>
             <a:endParaRPr lang="en-US" dirty="0"/>
           </a:p>
         </p:txBody>
@@ -1403,7 +1594,7 @@
           <p:cNvPr id="4" name="Slide Number Placeholder 3">
             <a:extLst>
               <a:ext uri="{FF2B5EF4-FFF2-40B4-BE49-F238E27FC236}">
-                <a16:creationId xmlns:a16="http://schemas.microsoft.com/office/drawing/2014/main" id="{EDB41845-DBF9-D5D3-0AD0-EB44364BA97B}"/>
+                <a16:creationId xmlns:a16="http://schemas.microsoft.com/office/drawing/2014/main" id="{91CDCACA-4E4D-87DC-EB02-39E6B14A95C8}"/>
               </a:ext>
             </a:extLst>
           </p:cNvPr>
@@ -1430,7 +1621,7 @@
     </p:spTree>
     <p:extLst>
       <p:ext uri="{BB962C8B-B14F-4D97-AF65-F5344CB8AC3E}">
-        <p14:creationId xmlns:p14="http://schemas.microsoft.com/office/powerpoint/2010/main" val="603407146"/>
+        <p14:creationId xmlns:p14="http://schemas.microsoft.com/office/powerpoint/2010/main" val="436891340"/>
       </p:ext>
     </p:extLst>
   </p:cSld>
@@ -1587,7 +1778,7 @@
           <a:p>
             <a:fld id="{EBF6AAF7-2BB1-4A84-8C15-D326179851E7}" type="datetimeFigureOut">
               <a:rPr lang="en-US" smtClean="0"/>
-              <a:t>7/28/2025</a:t>
+              <a:t>8/5/25</a:t>
             </a:fld>
             <a:endParaRPr lang="en-US"/>
           </a:p>
@@ -1785,7 +1976,7 @@
           <a:p>
             <a:fld id="{EBF6AAF7-2BB1-4A84-8C15-D326179851E7}" type="datetimeFigureOut">
               <a:rPr lang="en-US" smtClean="0"/>
-              <a:t>7/28/2025</a:t>
+              <a:t>8/5/25</a:t>
             </a:fld>
             <a:endParaRPr lang="en-US"/>
           </a:p>
@@ -1993,7 +2184,7 @@
           <a:p>
             <a:fld id="{EBF6AAF7-2BB1-4A84-8C15-D326179851E7}" type="datetimeFigureOut">
               <a:rPr lang="en-US" smtClean="0"/>
-              <a:t>7/28/2025</a:t>
+              <a:t>8/5/25</a:t>
             </a:fld>
             <a:endParaRPr lang="en-US"/>
           </a:p>
@@ -2191,7 +2382,7 @@
           <a:p>
             <a:fld id="{EBF6AAF7-2BB1-4A84-8C15-D326179851E7}" type="datetimeFigureOut">
               <a:rPr lang="en-US" smtClean="0"/>
-              <a:t>7/28/2025</a:t>
+              <a:t>8/5/25</a:t>
             </a:fld>
             <a:endParaRPr lang="en-US"/>
           </a:p>
@@ -2466,7 +2657,7 @@
           <a:p>
             <a:fld id="{EBF6AAF7-2BB1-4A84-8C15-D326179851E7}" type="datetimeFigureOut">
               <a:rPr lang="en-US" smtClean="0"/>
-              <a:t>7/28/2025</a:t>
+              <a:t>8/5/25</a:t>
             </a:fld>
             <a:endParaRPr lang="en-US"/>
           </a:p>
@@ -2731,7 +2922,7 @@
           <a:p>
             <a:fld id="{EBF6AAF7-2BB1-4A84-8C15-D326179851E7}" type="datetimeFigureOut">
               <a:rPr lang="en-US" smtClean="0"/>
-              <a:t>7/28/2025</a:t>
+              <a:t>8/5/25</a:t>
             </a:fld>
             <a:endParaRPr lang="en-US"/>
           </a:p>
@@ -3143,7 +3334,7 @@
           <a:p>
             <a:fld id="{EBF6AAF7-2BB1-4A84-8C15-D326179851E7}" type="datetimeFigureOut">
               <a:rPr lang="en-US" smtClean="0"/>
-              <a:t>7/28/2025</a:t>
+              <a:t>8/5/25</a:t>
             </a:fld>
             <a:endParaRPr lang="en-US"/>
           </a:p>
@@ -3284,7 +3475,7 @@
           <a:p>
             <a:fld id="{EBF6AAF7-2BB1-4A84-8C15-D326179851E7}" type="datetimeFigureOut">
               <a:rPr lang="en-US" smtClean="0"/>
-              <a:t>7/28/2025</a:t>
+              <a:t>8/5/25</a:t>
             </a:fld>
             <a:endParaRPr lang="en-US"/>
           </a:p>
@@ -3397,7 +3588,7 @@
           <a:p>
             <a:fld id="{EBF6AAF7-2BB1-4A84-8C15-D326179851E7}" type="datetimeFigureOut">
               <a:rPr lang="en-US" smtClean="0"/>
-              <a:t>7/28/2025</a:t>
+              <a:t>8/5/25</a:t>
             </a:fld>
             <a:endParaRPr lang="en-US"/>
           </a:p>
@@ -3708,7 +3899,7 @@
           <a:p>
             <a:fld id="{EBF6AAF7-2BB1-4A84-8C15-D326179851E7}" type="datetimeFigureOut">
               <a:rPr lang="en-US" smtClean="0"/>
-              <a:t>7/28/2025</a:t>
+              <a:t>8/5/25</a:t>
             </a:fld>
             <a:endParaRPr lang="en-US"/>
           </a:p>
@@ -3996,7 +4187,7 @@
           <a:p>
             <a:fld id="{EBF6AAF7-2BB1-4A84-8C15-D326179851E7}" type="datetimeFigureOut">
               <a:rPr lang="en-US" smtClean="0"/>
-              <a:t>7/28/2025</a:t>
+              <a:t>8/5/25</a:t>
             </a:fld>
             <a:endParaRPr lang="en-US"/>
           </a:p>
@@ -4237,7 +4428,7 @@
           <a:p>
             <a:fld id="{EBF6AAF7-2BB1-4A84-8C15-D326179851E7}" type="datetimeFigureOut">
               <a:rPr lang="en-US" smtClean="0"/>
-              <a:t>7/28/2025</a:t>
+              <a:t>8/5/25</a:t>
             </a:fld>
             <a:endParaRPr lang="en-US"/>
           </a:p>
@@ -4747,41 +4938,6 @@
           </a:p>
         </p:txBody>
       </p:sp>
-      <p:pic>
-        <p:nvPicPr>
-          <p:cNvPr id="8" name="Picture 7">
-            <a:extLst>
-              <a:ext uri="{FF2B5EF4-FFF2-40B4-BE49-F238E27FC236}">
-                <a16:creationId xmlns:a16="http://schemas.microsoft.com/office/drawing/2014/main" id="{5CAADE6A-566F-7AD4-BA81-D5F747017178}"/>
-              </a:ext>
-            </a:extLst>
-          </p:cNvPr>
-          <p:cNvPicPr>
-            <a:picLocks noChangeAspect="1"/>
-          </p:cNvPicPr>
-          <p:nvPr/>
-        </p:nvPicPr>
-        <p:blipFill>
-          <a:blip r:embed="rId3">
-            <a:extLst>
-              <a:ext uri="{28A0092B-C50C-407E-A947-70E740481C1C}">
-                <a14:useLocalDpi xmlns:a14="http://schemas.microsoft.com/office/drawing/2010/main" val="0"/>
-              </a:ext>
-            </a:extLst>
-          </a:blip>
-          <a:srcRect/>
-          <a:stretch/>
-        </p:blipFill>
-        <p:spPr>
-          <a:xfrm>
-            <a:off x="8432128" y="2466518"/>
-            <a:ext cx="3628723" cy="2812758"/>
-          </a:xfrm>
-          <a:prstGeom prst="rect">
-            <a:avLst/>
-          </a:prstGeom>
-        </p:spPr>
-      </p:pic>
       <p:grpSp>
         <p:nvGrpSpPr>
           <p:cNvPr id="3" name="Group 2">
@@ -4796,8 +4952,8 @@
         </p:nvGrpSpPr>
         <p:grpSpPr>
           <a:xfrm>
-            <a:off x="708361" y="2348183"/>
-            <a:ext cx="3702125" cy="2833547"/>
+            <a:off x="279007" y="2195407"/>
+            <a:ext cx="4009943" cy="3126025"/>
             <a:chOff x="719119" y="2466518"/>
             <a:chExt cx="3589503" cy="2743200"/>
           </a:xfrm>
@@ -4817,7 +4973,7 @@
             <p:nvPr/>
           </p:nvPicPr>
           <p:blipFill>
-            <a:blip r:embed="rId4">
+            <a:blip r:embed="rId3">
               <a:extLst>
                 <a:ext uri="{28A0092B-C50C-407E-A947-70E740481C1C}">
                   <a14:useLocalDpi xmlns:a14="http://schemas.microsoft.com/office/drawing/2010/main" val="0"/>
@@ -4907,7 +5063,7 @@
           <p:nvPr/>
         </p:nvPicPr>
         <p:blipFill>
-          <a:blip r:embed="rId5">
+          <a:blip r:embed="rId4">
             <a:extLst>
               <a:ext uri="{28A0092B-C50C-407E-A947-70E740481C1C}">
                 <a14:useLocalDpi xmlns:a14="http://schemas.microsoft.com/office/drawing/2010/main" val="0"/>
@@ -4919,8 +5075,43 @@
         </p:blipFill>
         <p:spPr>
           <a:xfrm>
-            <a:off x="4463997" y="2455522"/>
-            <a:ext cx="3914620" cy="2833547"/>
+            <a:off x="4384175" y="2239521"/>
+            <a:ext cx="3845099" cy="3117649"/>
+          </a:xfrm>
+          <a:prstGeom prst="rect">
+            <a:avLst/>
+          </a:prstGeom>
+        </p:spPr>
+      </p:pic>
+      <p:pic>
+        <p:nvPicPr>
+          <p:cNvPr id="4" name="Picture 3">
+            <a:extLst>
+              <a:ext uri="{FF2B5EF4-FFF2-40B4-BE49-F238E27FC236}">
+                <a16:creationId xmlns:a16="http://schemas.microsoft.com/office/drawing/2014/main" id="{1E363F21-FA22-2429-0D4C-C5C95876648C}"/>
+              </a:ext>
+            </a:extLst>
+          </p:cNvPr>
+          <p:cNvPicPr>
+            <a:picLocks noChangeAspect="1"/>
+          </p:cNvPicPr>
+          <p:nvPr/>
+        </p:nvPicPr>
+        <p:blipFill>
+          <a:blip r:embed="rId5">
+            <a:extLst>
+              <a:ext uri="{28A0092B-C50C-407E-A947-70E740481C1C}">
+                <a14:useLocalDpi xmlns:a14="http://schemas.microsoft.com/office/drawing/2010/main" val="0"/>
+              </a:ext>
+            </a:extLst>
+          </a:blip>
+          <a:srcRect/>
+          <a:stretch/>
+        </p:blipFill>
+        <p:spPr>
+          <a:xfrm>
+            <a:off x="8203667" y="2195407"/>
+            <a:ext cx="3939566" cy="3030435"/>
           </a:xfrm>
           <a:prstGeom prst="rect">
             <a:avLst/>
@@ -5499,6 +5690,299 @@
         <p:cNvPr id="1" name="">
           <a:extLst>
             <a:ext uri="{FF2B5EF4-FFF2-40B4-BE49-F238E27FC236}">
+              <a16:creationId xmlns:a16="http://schemas.microsoft.com/office/drawing/2014/main" id="{3D2435D9-43D2-428D-93A7-3737846DBDBC}"/>
+            </a:ext>
+          </a:extLst>
+        </p:cNvPr>
+        <p:cNvGrpSpPr/>
+        <p:nvPr/>
+      </p:nvGrpSpPr>
+      <p:grpSpPr>
+        <a:xfrm>
+          <a:off x="0" y="0"/>
+          <a:ext cx="0" cy="0"/>
+          <a:chOff x="0" y="0"/>
+          <a:chExt cx="0" cy="0"/>
+        </a:xfrm>
+      </p:grpSpPr>
+      <p:sp>
+        <p:nvSpPr>
+          <p:cNvPr id="12" name="Title 1">
+            <a:extLst>
+              <a:ext uri="{FF2B5EF4-FFF2-40B4-BE49-F238E27FC236}">
+                <a16:creationId xmlns:a16="http://schemas.microsoft.com/office/drawing/2014/main" id="{D2275769-F153-F72D-0283-84570E65F283}"/>
+              </a:ext>
+            </a:extLst>
+          </p:cNvPr>
+          <p:cNvSpPr>
+            <a:spLocks noGrp="1"/>
+          </p:cNvSpPr>
+          <p:nvPr>
+            <p:ph type="title"/>
+          </p:nvPr>
+        </p:nvSpPr>
+        <p:spPr>
+          <a:xfrm>
+            <a:off x="344341" y="-558966"/>
+            <a:ext cx="5838713" cy="2140340"/>
+          </a:xfrm>
+        </p:spPr>
+        <p:txBody>
+          <a:bodyPr>
+            <a:noAutofit/>
+          </a:bodyPr>
+          <a:lstStyle/>
+          <a:p>
+            <a:r>
+              <a:rPr lang="en-US" sz="3600" dirty="0"/>
+              <a:t>Supp Fig. 2 </a:t>
+            </a:r>
+          </a:p>
+        </p:txBody>
+      </p:sp>
+      <p:sp>
+        <p:nvSpPr>
+          <p:cNvPr id="2" name="Title 1">
+            <a:extLst>
+              <a:ext uri="{FF2B5EF4-FFF2-40B4-BE49-F238E27FC236}">
+                <a16:creationId xmlns:a16="http://schemas.microsoft.com/office/drawing/2014/main" id="{A491D90D-3E1B-F914-EAE6-22DA5E1D1825}"/>
+              </a:ext>
+            </a:extLst>
+          </p:cNvPr>
+          <p:cNvSpPr txBox="1">
+            <a:spLocks/>
+          </p:cNvSpPr>
+          <p:nvPr/>
+        </p:nvSpPr>
+        <p:spPr>
+          <a:xfrm>
+            <a:off x="570251" y="867080"/>
+            <a:ext cx="2905461" cy="2140340"/>
+          </a:xfrm>
+          <a:prstGeom prst="rect">
+            <a:avLst/>
+          </a:prstGeom>
+        </p:spPr>
+        <p:txBody>
+          <a:bodyPr vert="horz" lIns="91440" tIns="45720" rIns="91440" bIns="45720" rtlCol="0" anchor="ctr">
+            <a:noAutofit/>
+          </a:bodyPr>
+          <a:lstStyle>
+            <a:lvl1pPr algn="l" defTabSz="914400" rtl="0" eaLnBrk="1" latinLnBrk="0" hangingPunct="1">
+              <a:lnSpc>
+                <a:spcPct val="90000"/>
+              </a:lnSpc>
+              <a:spcBef>
+                <a:spcPct val="0"/>
+              </a:spcBef>
+              <a:buNone/>
+              <a:defRPr sz="4400" kern="1200">
+                <a:solidFill>
+                  <a:schemeClr val="tx1"/>
+                </a:solidFill>
+                <a:latin typeface="+mj-lt"/>
+                <a:ea typeface="+mj-ea"/>
+                <a:cs typeface="+mj-cs"/>
+              </a:defRPr>
+            </a:lvl1pPr>
+          </a:lstStyle>
+          <a:p>
+            <a:r>
+              <a:rPr lang="en-US" sz="3200" dirty="0"/>
+              <a:t>GLM-HMM</a:t>
+            </a:r>
+            <a:br>
+              <a:rPr lang="en-US" sz="3200" dirty="0"/>
+            </a:br>
+            <a:r>
+              <a:rPr lang="en-US" sz="3200" dirty="0"/>
+              <a:t>equal prior only</a:t>
+            </a:r>
+          </a:p>
+        </p:txBody>
+      </p:sp>
+      <p:pic>
+        <p:nvPicPr>
+          <p:cNvPr id="7" name="Picture 6">
+            <a:extLst>
+              <a:ext uri="{FF2B5EF4-FFF2-40B4-BE49-F238E27FC236}">
+                <a16:creationId xmlns:a16="http://schemas.microsoft.com/office/drawing/2014/main" id="{0B37C21B-4229-6BDD-EA09-46F3B3CCA23D}"/>
+              </a:ext>
+            </a:extLst>
+          </p:cNvPr>
+          <p:cNvPicPr>
+            <a:picLocks noChangeAspect="1"/>
+          </p:cNvPicPr>
+          <p:nvPr/>
+        </p:nvPicPr>
+        <p:blipFill>
+          <a:blip r:embed="rId3">
+            <a:extLst>
+              <a:ext uri="{28A0092B-C50C-407E-A947-70E740481C1C}">
+                <a14:useLocalDpi xmlns:a14="http://schemas.microsoft.com/office/drawing/2010/main" val="0"/>
+              </a:ext>
+            </a:extLst>
+          </a:blip>
+          <a:srcRect/>
+          <a:stretch/>
+        </p:blipFill>
+        <p:spPr>
+          <a:xfrm>
+            <a:off x="3880092" y="3206496"/>
+            <a:ext cx="3616696" cy="2988313"/>
+          </a:xfrm>
+          <a:prstGeom prst="rect">
+            <a:avLst/>
+          </a:prstGeom>
+        </p:spPr>
+      </p:pic>
+      <p:pic>
+        <p:nvPicPr>
+          <p:cNvPr id="9" name="Picture 8">
+            <a:extLst>
+              <a:ext uri="{FF2B5EF4-FFF2-40B4-BE49-F238E27FC236}">
+                <a16:creationId xmlns:a16="http://schemas.microsoft.com/office/drawing/2014/main" id="{476C6BBC-0137-7608-11B3-578BCCCD9CEE}"/>
+              </a:ext>
+            </a:extLst>
+          </p:cNvPr>
+          <p:cNvPicPr>
+            <a:picLocks noChangeAspect="1"/>
+          </p:cNvPicPr>
+          <p:nvPr/>
+        </p:nvPicPr>
+        <p:blipFill>
+          <a:blip r:embed="rId4">
+            <a:extLst>
+              <a:ext uri="{28A0092B-C50C-407E-A947-70E740481C1C}">
+                <a14:useLocalDpi xmlns:a14="http://schemas.microsoft.com/office/drawing/2010/main" val="0"/>
+              </a:ext>
+            </a:extLst>
+          </a:blip>
+          <a:srcRect/>
+          <a:stretch/>
+        </p:blipFill>
+        <p:spPr>
+          <a:xfrm>
+            <a:off x="3890166" y="103039"/>
+            <a:ext cx="3646559" cy="2956670"/>
+          </a:xfrm>
+          <a:prstGeom prst="rect">
+            <a:avLst/>
+          </a:prstGeom>
+        </p:spPr>
+      </p:pic>
+      <p:sp>
+        <p:nvSpPr>
+          <p:cNvPr id="10" name="Title 1">
+            <a:extLst>
+              <a:ext uri="{FF2B5EF4-FFF2-40B4-BE49-F238E27FC236}">
+                <a16:creationId xmlns:a16="http://schemas.microsoft.com/office/drawing/2014/main" id="{C5A64974-4AFB-F662-4437-CE7D53BFC1E9}"/>
+              </a:ext>
+            </a:extLst>
+          </p:cNvPr>
+          <p:cNvSpPr txBox="1">
+            <a:spLocks/>
+          </p:cNvSpPr>
+          <p:nvPr/>
+        </p:nvSpPr>
+        <p:spPr>
+          <a:xfrm>
+            <a:off x="193734" y="3418717"/>
+            <a:ext cx="3131371" cy="2140340"/>
+          </a:xfrm>
+          <a:prstGeom prst="rect">
+            <a:avLst/>
+          </a:prstGeom>
+        </p:spPr>
+        <p:txBody>
+          <a:bodyPr vert="horz" lIns="91440" tIns="45720" rIns="91440" bIns="45720" rtlCol="0" anchor="ctr">
+            <a:noAutofit/>
+          </a:bodyPr>
+          <a:lstStyle>
+            <a:lvl1pPr algn="l" defTabSz="914400" rtl="0" eaLnBrk="1" latinLnBrk="0" hangingPunct="1">
+              <a:lnSpc>
+                <a:spcPct val="90000"/>
+              </a:lnSpc>
+              <a:spcBef>
+                <a:spcPct val="0"/>
+              </a:spcBef>
+              <a:buNone/>
+              <a:defRPr sz="4400" kern="1200">
+                <a:solidFill>
+                  <a:schemeClr val="tx1"/>
+                </a:solidFill>
+                <a:latin typeface="+mj-lt"/>
+                <a:ea typeface="+mj-ea"/>
+                <a:cs typeface="+mj-cs"/>
+              </a:defRPr>
+            </a:lvl1pPr>
+          </a:lstStyle>
+          <a:p>
+            <a:r>
+              <a:rPr lang="en-US" sz="3200" dirty="0"/>
+              <a:t>GLM-HMM</a:t>
+            </a:r>
+            <a:br>
+              <a:rPr lang="en-US" sz="3200" dirty="0"/>
+            </a:br>
+            <a:r>
+              <a:rPr lang="en-US" sz="3200" dirty="0"/>
+              <a:t>unequal prior only</a:t>
+            </a:r>
+          </a:p>
+        </p:txBody>
+      </p:sp>
+      <p:pic>
+        <p:nvPicPr>
+          <p:cNvPr id="3" name="Picture 2">
+            <a:extLst>
+              <a:ext uri="{FF2B5EF4-FFF2-40B4-BE49-F238E27FC236}">
+                <a16:creationId xmlns:a16="http://schemas.microsoft.com/office/drawing/2014/main" id="{6608F178-DA65-D3FD-F721-D42292443376}"/>
+              </a:ext>
+            </a:extLst>
+          </p:cNvPr>
+          <p:cNvPicPr>
+            <a:picLocks noChangeAspect="1"/>
+          </p:cNvPicPr>
+          <p:nvPr/>
+        </p:nvPicPr>
+        <p:blipFill>
+          <a:blip r:embed="rId5"/>
+          <a:stretch>
+            <a:fillRect/>
+          </a:stretch>
+        </p:blipFill>
+        <p:spPr>
+          <a:xfrm>
+            <a:off x="7791957" y="2990719"/>
+            <a:ext cx="3951711" cy="3204090"/>
+          </a:xfrm>
+          <a:prstGeom prst="rect">
+            <a:avLst/>
+          </a:prstGeom>
+        </p:spPr>
+      </p:pic>
+    </p:spTree>
+    <p:extLst>
+      <p:ext uri="{BB962C8B-B14F-4D97-AF65-F5344CB8AC3E}">
+        <p14:creationId xmlns:p14="http://schemas.microsoft.com/office/powerpoint/2010/main" val="4143694802"/>
+      </p:ext>
+    </p:extLst>
+  </p:cSld>
+  <p:clrMapOvr>
+    <a:masterClrMapping/>
+  </p:clrMapOvr>
+</p:sld>
+</file>
+
+<file path=ppt/slides/slide14.xml><?xml version="1.0" encoding="utf-8"?>
+<p:sld xmlns:a="http://schemas.openxmlformats.org/drawingml/2006/main" xmlns:r="http://schemas.openxmlformats.org/officeDocument/2006/relationships" xmlns:p="http://schemas.openxmlformats.org/presentationml/2006/main">
+  <p:cSld>
+    <p:spTree>
+      <p:nvGrpSpPr>
+        <p:cNvPr id="1" name="">
+          <a:extLst>
+            <a:ext uri="{FF2B5EF4-FFF2-40B4-BE49-F238E27FC236}">
               <a16:creationId xmlns:a16="http://schemas.microsoft.com/office/drawing/2014/main" id="{F4C53FD2-27AD-A3BE-C751-9A2816FCE964}"/>
             </a:ext>
           </a:extLst>
@@ -5569,8 +6053,8 @@
         </p:blipFill>
         <p:spPr>
           <a:xfrm>
-            <a:off x="360222" y="2224610"/>
-            <a:ext cx="3440253" cy="2646100"/>
+            <a:off x="364568" y="2224610"/>
+            <a:ext cx="3431560" cy="2646100"/>
           </a:xfrm>
           <a:prstGeom prst="rect">
             <a:avLst/>
@@ -5604,8 +6088,8 @@
         </p:blipFill>
         <p:spPr>
           <a:xfrm>
-            <a:off x="3853871" y="2422684"/>
-            <a:ext cx="4708029" cy="2568938"/>
+            <a:off x="4002791" y="2301772"/>
+            <a:ext cx="4186417" cy="2568938"/>
           </a:xfrm>
           <a:prstGeom prst="rect">
             <a:avLst/>
@@ -5639,8 +6123,8 @@
         </p:blipFill>
         <p:spPr>
           <a:xfrm>
-            <a:off x="8260556" y="2422684"/>
-            <a:ext cx="3836206" cy="2525043"/>
+            <a:off x="8189208" y="2377596"/>
+            <a:ext cx="3836206" cy="2493114"/>
           </a:xfrm>
           <a:prstGeom prst="rect">
             <a:avLst/>

</xml_diff>